<commit_message>
Finish the unfinished "Ethics: honest data" slide
The slide broke off mid-sentence at "A researcher is surveying households in a
community:" - the three things that researcher actually did never followed it,
so the setup had no payoff. It was also the only content slide in the deck with
no animations.

It is now a copy of the Facebook slide's layout (a context paragraph over three
numbered question/reveal pairs, click-to-reveal included), carrying the three
behaviours from Example 1.22 that the notes already spell out, each with the
name of what is wrong: convenience sampling, nonresponse, and fabricated data.

The Facebook slide and this one now share a Set-ContextPairs helper in the build
script, since they have the same shape layout.

Co-Authored-By: Claude Opus 5 (1M context) <noreply@anthropic.com>
</commit_message>
<xml_diff>
--- a/docs/lecture_slides/Week 5/Week5_Lecture11_Slides_9_25_2026.pptx
+++ b/docs/lecture_slides/Week 5/Week5_Lecture11_Slides_9_25_2026.pptx
@@ -16,7 +16,7 @@
     <p:sldId id="304" r:id="rId10"/>
     <p:sldId id="305" r:id="rId11"/>
     <p:sldId id="306" r:id="rId12"/>
-    <p:sldId id="307" r:id="rId13"/>
+    <p:sldId id="324" r:id="rId13"/>
     <p:sldId id="308" r:id="rId14"/>
     <p:sldId id="320" r:id="rId15"/>
     <p:sldId id="321" r:id="rId16"/>
@@ -3405,7 +3405,7 @@
     </p:spTree>
     <p:extLst>
       <p:ext uri="{BB962C8B-B14F-4D97-AF65-F5344CB8AC3E}">
-        <p14:creationId xmlns:p14="http://schemas.microsoft.com/office/powerpoint/2010/main" val="1356768287"/>
+        <p14:creationId xmlns:p14="http://schemas.microsoft.com/office/powerpoint/2010/main" val="3424977105"/>
       </p:ext>
     </p:extLst>
   </p:cSld>
@@ -5316,7 +5316,7 @@
           <p:cNvPr id="2" name="Title 1">
             <a:extLst>
               <a:ext uri="{FF2B5EF4-FFF2-40B4-BE49-F238E27FC236}">
-                <a16:creationId xmlns:a16="http://schemas.microsoft.com/office/drawing/2014/main" id="{9DEE9C50-2180-9A09-7608-C08B3B78FF29}"/>
+                <a16:creationId xmlns:a16="http://schemas.microsoft.com/office/drawing/2014/main" id="{928FBCDC-48E3-34D7-E16A-ED185680B6C5}"/>
               </a:ext>
             </a:extLst>
           </p:cNvPr>
@@ -5350,7 +5350,7 @@
           <p:cNvPr id="4" name="Slide Number Placeholder 3">
             <a:extLst>
               <a:ext uri="{FF2B5EF4-FFF2-40B4-BE49-F238E27FC236}">
-                <a16:creationId xmlns:a16="http://schemas.microsoft.com/office/drawing/2014/main" id="{6203678C-7C08-89CA-E3B2-CB2008D7B3C1}"/>
+                <a16:creationId xmlns:a16="http://schemas.microsoft.com/office/drawing/2014/main" id="{867D343A-B691-3B93-BC2E-2BC7ADBAE788}"/>
               </a:ext>
             </a:extLst>
           </p:cNvPr>
@@ -5379,7 +5379,7 @@
           <p:cNvPr id="5" name="TextBox 4">
             <a:extLst>
               <a:ext uri="{FF2B5EF4-FFF2-40B4-BE49-F238E27FC236}">
-                <a16:creationId xmlns:a16="http://schemas.microsoft.com/office/drawing/2014/main" id="{0B8108D8-C022-6582-B6B8-EB2AE42F8E82}"/>
+                <a16:creationId xmlns:a16="http://schemas.microsoft.com/office/drawing/2014/main" id="{803EF544-7BC1-830E-74B1-64EDAAE169AE}"/>
               </a:ext>
             </a:extLst>
           </p:cNvPr>
@@ -5389,7 +5389,7 @@
         <p:spPr>
           <a:xfrm>
             <a:off x="762000" y="1841499"/>
-            <a:ext cx="10668000" cy="589280"/>
+            <a:ext cx="10668000" cy="830997"/>
           </a:xfrm>
           <a:prstGeom prst="rect">
             <a:avLst/>
@@ -5398,7 +5398,7 @@
         </p:spPr>
         <p:txBody>
           <a:bodyPr vert="horz" wrap="square" rtlCol="0">
-            <a:noAutofit/>
+            <a:spAutoFit/>
           </a:bodyPr>
           <a:lstStyle/>
           <a:p>
@@ -5408,12 +5408,273 @@
               </a:spcAft>
             </a:pPr>
             <a:r>
-              <a:rPr lang="en-US" sz="1600" dirty="0">
+              <a:rPr lang="en-US" sz="1600">
                 <a:solidFill>
                   <a:srgbClr val="000000"/>
                 </a:solidFill>
               </a:rPr>
-              <a:t>Ethics also means honest data. An investigation of psychologist Diederik Stapel, infamous social psychologist, found he had invented data: it tainted more than 55 of his papers and 10 PhD dissertations he supervised. A researcher is surveying households in a community:</a:t>
+              <a:t>Ethics also means honest data. An investigation of the social psychologist Diederik Stapel found he had invented data outright, tainting more than 55 of his papers and 10 PhD dissertations he supervised. But a problem does not have to be that big to matter. A researcher is surveying households in a community. What is wrong with each of these?</a:t>
+            </a:r>
+          </a:p>
+        </p:txBody>
+      </p:sp>
+      <p:sp>
+        <p:nvSpPr>
+          <p:cNvPr id="6" name="TextBox 5">
+            <a:extLst>
+              <a:ext uri="{FF2B5EF4-FFF2-40B4-BE49-F238E27FC236}">
+                <a16:creationId xmlns:a16="http://schemas.microsoft.com/office/drawing/2014/main" id="{173928F0-6402-96DA-08AE-79702CFCC1E5}"/>
+              </a:ext>
+            </a:extLst>
+          </p:cNvPr>
+          <p:cNvSpPr txBox="1"/>
+          <p:nvPr/>
+        </p:nvSpPr>
+        <p:spPr>
+          <a:xfrm>
+            <a:off x="762000" y="2824896"/>
+            <a:ext cx="10668000" cy="345440"/>
+          </a:xfrm>
+          <a:prstGeom prst="rect">
+            <a:avLst/>
+          </a:prstGeom>
+          <a:noFill/>
+        </p:spPr>
+        <p:txBody>
+          <a:bodyPr vert="horz" wrap="square" rtlCol="0">
+            <a:spAutoFit/>
+          </a:bodyPr>
+          <a:lstStyle/>
+          <a:p>
+            <a:pPr marL="304800" indent="-304800"/>
+            <a:r>
+              <a:rPr lang="en-US" sz="1600" b="1">
+                <a:solidFill>
+                  <a:srgbClr val="C00000"/>
+                </a:solidFill>
+              </a:rPr>
+              <a:t>1.</a:t>
+            </a:r>
+            <a:r>
+              <a:rPr lang="en-US" sz="1600">
+                <a:solidFill>
+                  <a:srgbClr val="000000"/>
+                </a:solidFill>
+              </a:rPr>
+              <a:t>  She picks a block where she already knows a lot of the neighbours.</a:t>
+            </a:r>
+          </a:p>
+        </p:txBody>
+      </p:sp>
+      <p:sp>
+        <p:nvSpPr>
+          <p:cNvPr id="7" name="TextBox 6">
+            <a:extLst>
+              <a:ext uri="{FF2B5EF4-FFF2-40B4-BE49-F238E27FC236}">
+                <a16:creationId xmlns:a16="http://schemas.microsoft.com/office/drawing/2014/main" id="{096B0234-5946-443E-D3EF-6B904164792E}"/>
+              </a:ext>
+            </a:extLst>
+          </p:cNvPr>
+          <p:cNvSpPr txBox="1"/>
+          <p:nvPr/>
+        </p:nvSpPr>
+        <p:spPr>
+          <a:xfrm>
+            <a:off x="1117600" y="3195736"/>
+            <a:ext cx="10312400" cy="338554"/>
+          </a:xfrm>
+          <a:prstGeom prst="rect">
+            <a:avLst/>
+          </a:prstGeom>
+          <a:noFill/>
+        </p:spPr>
+        <p:txBody>
+          <a:bodyPr vert="horz" wrap="square" rtlCol="0">
+            <a:spAutoFit/>
+          </a:bodyPr>
+          <a:lstStyle/>
+          <a:p>
+            <a:r>
+              <a:rPr lang="en-US" sz="1600" b="1">
+                <a:solidFill>
+                  <a:srgbClr val="C00000"/>
+                </a:solidFill>
+              </a:rPr>
+              <a:t>A convenience sample. It is biased, and presenting it as representative of the community is misleading.</a:t>
+            </a:r>
+          </a:p>
+        </p:txBody>
+      </p:sp>
+      <p:sp>
+        <p:nvSpPr>
+          <p:cNvPr id="8" name="TextBox 7">
+            <a:extLst>
+              <a:ext uri="{FF2B5EF4-FFF2-40B4-BE49-F238E27FC236}">
+                <a16:creationId xmlns:a16="http://schemas.microsoft.com/office/drawing/2014/main" id="{DDBAFEBF-2B58-DFE7-62AD-B002E3656906}"/>
+              </a:ext>
+            </a:extLst>
+          </p:cNvPr>
+          <p:cNvSpPr txBox="1"/>
+          <p:nvPr/>
+        </p:nvSpPr>
+        <p:spPr>
+          <a:xfrm>
+            <a:off x="762000" y="3712090"/>
+            <a:ext cx="10668000" cy="345440"/>
+          </a:xfrm>
+          <a:prstGeom prst="rect">
+            <a:avLst/>
+          </a:prstGeom>
+          <a:noFill/>
+        </p:spPr>
+        <p:txBody>
+          <a:bodyPr vert="horz" wrap="square" rtlCol="0">
+            <a:spAutoFit/>
+          </a:bodyPr>
+          <a:lstStyle/>
+          <a:p>
+            <a:pPr marL="304800" indent="-304800"/>
+            <a:r>
+              <a:rPr lang="en-US" sz="1600" b="1">
+                <a:solidFill>
+                  <a:srgbClr val="C00000"/>
+                </a:solidFill>
+              </a:rPr>
+              <a:t>2.</a:t>
+            </a:r>
+            <a:r>
+              <a:rPr lang="en-US" sz="1600">
+                <a:solidFill>
+                  <a:srgbClr val="000000"/>
+                </a:solidFill>
+              </a:rPr>
+              <a:t>  Four houses have nobody home. She skips them and never goes back.</a:t>
+            </a:r>
+          </a:p>
+        </p:txBody>
+      </p:sp>
+      <p:sp>
+        <p:nvSpPr>
+          <p:cNvPr id="9" name="TextBox 8">
+            <a:extLst>
+              <a:ext uri="{FF2B5EF4-FFF2-40B4-BE49-F238E27FC236}">
+                <a16:creationId xmlns:a16="http://schemas.microsoft.com/office/drawing/2014/main" id="{37C5EB09-8181-01D4-0AE9-A06C5E9A6703}"/>
+              </a:ext>
+            </a:extLst>
+          </p:cNvPr>
+          <p:cNvSpPr txBox="1"/>
+          <p:nvPr/>
+        </p:nvSpPr>
+        <p:spPr>
+          <a:xfrm>
+            <a:off x="1117600" y="4082930"/>
+            <a:ext cx="10312400" cy="589280"/>
+          </a:xfrm>
+          <a:prstGeom prst="rect">
+            <a:avLst/>
+          </a:prstGeom>
+          <a:noFill/>
+        </p:spPr>
+        <p:txBody>
+          <a:bodyPr vert="horz" wrap="square" rtlCol="0">
+            <a:spAutoFit/>
+          </a:bodyPr>
+          <a:lstStyle/>
+          <a:p>
+            <a:r>
+              <a:rPr lang="en-US" sz="1600" b="1">
+                <a:solidFill>
+                  <a:srgbClr val="C00000"/>
+                </a:solidFill>
+              </a:rPr>
+              <a:t>Nonresponse. The households she misses are not a random subset - working families are exactly the ones least likely to be home in the daytime.</a:t>
+            </a:r>
+          </a:p>
+        </p:txBody>
+      </p:sp>
+      <p:sp>
+        <p:nvSpPr>
+          <p:cNvPr id="10" name="TextBox 9">
+            <a:extLst>
+              <a:ext uri="{FF2B5EF4-FFF2-40B4-BE49-F238E27FC236}">
+                <a16:creationId xmlns:a16="http://schemas.microsoft.com/office/drawing/2014/main" id="{2235831A-51A3-E82F-82A5-67061AA1A22E}"/>
+              </a:ext>
+            </a:extLst>
+          </p:cNvPr>
+          <p:cNvSpPr txBox="1"/>
+          <p:nvPr/>
+        </p:nvSpPr>
+        <p:spPr>
+          <a:xfrm>
+            <a:off x="762000" y="4850010"/>
+            <a:ext cx="10668000" cy="345440"/>
+          </a:xfrm>
+          <a:prstGeom prst="rect">
+            <a:avLst/>
+          </a:prstGeom>
+          <a:noFill/>
+        </p:spPr>
+        <p:txBody>
+          <a:bodyPr vert="horz" wrap="square" rtlCol="0">
+            <a:spAutoFit/>
+          </a:bodyPr>
+          <a:lstStyle/>
+          <a:p>
+            <a:pPr marL="304800" indent="-304800"/>
+            <a:r>
+              <a:rPr lang="en-US" sz="1600" b="1">
+                <a:solidFill>
+                  <a:srgbClr val="C00000"/>
+                </a:solidFill>
+              </a:rPr>
+              <a:t>3.</a:t>
+            </a:r>
+            <a:r>
+              <a:rPr lang="en-US" sz="1600">
+                <a:solidFill>
+                  <a:srgbClr val="000000"/>
+                </a:solidFill>
+              </a:rPr>
+              <a:t>  She fills in those four forms with answers copied from the neighbours.</a:t>
+            </a:r>
+          </a:p>
+        </p:txBody>
+      </p:sp>
+      <p:sp>
+        <p:nvSpPr>
+          <p:cNvPr id="11" name="TextBox 10">
+            <a:extLst>
+              <a:ext uri="{FF2B5EF4-FFF2-40B4-BE49-F238E27FC236}">
+                <a16:creationId xmlns:a16="http://schemas.microsoft.com/office/drawing/2014/main" id="{7EEE7946-5EA0-8B72-F855-AEB4B6636110}"/>
+              </a:ext>
+            </a:extLst>
+          </p:cNvPr>
+          <p:cNvSpPr txBox="1"/>
+          <p:nvPr/>
+        </p:nvSpPr>
+        <p:spPr>
+          <a:xfrm>
+            <a:off x="1117600" y="5220850"/>
+            <a:ext cx="10312400" cy="345440"/>
+          </a:xfrm>
+          <a:prstGeom prst="rect">
+            <a:avLst/>
+          </a:prstGeom>
+          <a:noFill/>
+        </p:spPr>
+        <p:txBody>
+          <a:bodyPr vert="horz" wrap="square" rtlCol="0">
+            <a:spAutoFit/>
+          </a:bodyPr>
+          <a:lstStyle/>
+          <a:p>
+            <a:r>
+              <a:rPr lang="en-US" sz="1600" b="1">
+                <a:solidFill>
+                  <a:srgbClr val="C00000"/>
+                </a:solidFill>
+              </a:rPr>
+              <a:t>Fabricated data. However small the study, this is never acceptable.</a:t>
             </a:r>
           </a:p>
         </p:txBody>
@@ -5423,7 +5684,7 @@
           <p:cNvPr id="12" name="TextBox 11">
             <a:extLst>
               <a:ext uri="{FF2B5EF4-FFF2-40B4-BE49-F238E27FC236}">
-                <a16:creationId xmlns:a16="http://schemas.microsoft.com/office/drawing/2014/main" id="{4CDC1D6A-F2F5-13CF-ACE8-FA96E392EA08}"/>
+                <a16:creationId xmlns:a16="http://schemas.microsoft.com/office/drawing/2014/main" id="{3D8E5BD3-1CF7-2352-2707-2D7DBFFA6EBD}"/>
               </a:ext>
             </a:extLst>
           </p:cNvPr>
@@ -5463,7 +5724,7 @@
           <p:cNvPr id="3" name="Title rule">
             <a:extLst>
               <a:ext uri="{FF2B5EF4-FFF2-40B4-BE49-F238E27FC236}">
-                <a16:creationId xmlns:a16="http://schemas.microsoft.com/office/drawing/2014/main" id="{CD14A3EC-A9EF-F0CA-9E7C-BE87A5742DBA}"/>
+                <a16:creationId xmlns:a16="http://schemas.microsoft.com/office/drawing/2014/main" id="{2A19CE9B-6143-6D05-1FF1-AF917901111D}"/>
               </a:ext>
             </a:extLst>
           </p:cNvPr>
@@ -5529,13 +5790,360 @@
     </p:spTree>
     <p:extLst>
       <p:ext uri="{BB962C8B-B14F-4D97-AF65-F5344CB8AC3E}">
-        <p14:creationId xmlns:p14="http://schemas.microsoft.com/office/powerpoint/2010/main" val="36314437"/>
+        <p14:creationId xmlns:p14="http://schemas.microsoft.com/office/powerpoint/2010/main" val="4119278081"/>
       </p:ext>
     </p:extLst>
   </p:cSld>
   <p:clrMapOvr>
     <a:masterClrMapping/>
   </p:clrMapOvr>
+  <p:timing>
+    <p:tnLst>
+      <p:par>
+        <p:cTn id="1" dur="indefinite" restart="never" nodeType="tmRoot">
+          <p:childTnLst>
+            <p:seq concurrent="1" nextAc="seek">
+              <p:cTn id="2" dur="indefinite" nodeType="mainSeq">
+                <p:childTnLst>
+                  <p:par>
+                    <p:cTn id="3" fill="hold">
+                      <p:stCondLst>
+                        <p:cond delay="indefinite"/>
+                      </p:stCondLst>
+                      <p:childTnLst>
+                        <p:par>
+                          <p:cTn id="4" fill="hold">
+                            <p:stCondLst>
+                              <p:cond delay="0"/>
+                            </p:stCondLst>
+                            <p:childTnLst>
+                              <p:par>
+                                <p:cTn id="5" presetID="34" presetClass="entr" presetSubtype="0" fill="hold" grpId="0" nodeType="clickEffect">
+                                  <p:stCondLst>
+                                    <p:cond delay="0"/>
+                                  </p:stCondLst>
+                                  <p:childTnLst>
+                                    <p:set>
+                                      <p:cBhvr>
+                                        <p:cTn id="6" dur="1" fill="hold">
+                                          <p:stCondLst>
+                                            <p:cond delay="0"/>
+                                          </p:stCondLst>
+                                        </p:cTn>
+                                        <p:tgtEl>
+                                          <p:spTgt spid="7"/>
+                                        </p:tgtEl>
+                                        <p:attrNameLst>
+                                          <p:attrName>style.visibility</p:attrName>
+                                        </p:attrNameLst>
+                                      </p:cBhvr>
+                                      <p:to>
+                                        <p:strVal val="visible"/>
+                                      </p:to>
+                                    </p:set>
+                                    <p:anim from="(-#ppt_w/2)" to="(#ppt_x)" calcmode="lin" valueType="num">
+                                      <p:cBhvr>
+                                        <p:cTn id="7" dur="600" fill="hold">
+                                          <p:stCondLst>
+                                            <p:cond delay="0"/>
+                                          </p:stCondLst>
+                                        </p:cTn>
+                                        <p:tgtEl>
+                                          <p:spTgt spid="7"/>
+                                        </p:tgtEl>
+                                        <p:attrNameLst>
+                                          <p:attrName>ppt_x</p:attrName>
+                                        </p:attrNameLst>
+                                      </p:cBhvr>
+                                    </p:anim>
+                                    <p:anim from="0" to="-1.0" calcmode="lin" valueType="num">
+                                      <p:cBhvr>
+                                        <p:cTn id="8" dur="200" decel="50000" autoRev="1" fill="hold">
+                                          <p:stCondLst>
+                                            <p:cond delay="600"/>
+                                          </p:stCondLst>
+                                        </p:cTn>
+                                        <p:tgtEl>
+                                          <p:spTgt spid="7"/>
+                                        </p:tgtEl>
+                                        <p:attrNameLst>
+                                          <p:attrName>xshear</p:attrName>
+                                        </p:attrNameLst>
+                                      </p:cBhvr>
+                                    </p:anim>
+                                    <p:animScale>
+                                      <p:cBhvr>
+                                        <p:cTn id="9" dur="200" decel="100000" autoRev="1" fill="hold">
+                                          <p:stCondLst>
+                                            <p:cond delay="600"/>
+                                          </p:stCondLst>
+                                        </p:cTn>
+                                        <p:tgtEl>
+                                          <p:spTgt spid="7"/>
+                                        </p:tgtEl>
+                                      </p:cBhvr>
+                                      <p:from x="100000" y="100000"/>
+                                      <p:to x="80000" y="100000"/>
+                                    </p:animScale>
+                                    <p:anim by="(#ppt_h/3+#ppt_w*0.1)" calcmode="lin" valueType="num">
+                                      <p:cBhvr additive="sum">
+                                        <p:cTn id="10" dur="200" decel="100000" autoRev="1" fill="hold">
+                                          <p:stCondLst>
+                                            <p:cond delay="600"/>
+                                          </p:stCondLst>
+                                        </p:cTn>
+                                        <p:tgtEl>
+                                          <p:spTgt spid="7"/>
+                                        </p:tgtEl>
+                                        <p:attrNameLst>
+                                          <p:attrName>ppt_x</p:attrName>
+                                        </p:attrNameLst>
+                                      </p:cBhvr>
+                                    </p:anim>
+                                  </p:childTnLst>
+                                </p:cTn>
+                              </p:par>
+                            </p:childTnLst>
+                          </p:cTn>
+                        </p:par>
+                      </p:childTnLst>
+                    </p:cTn>
+                  </p:par>
+                  <p:par>
+                    <p:cTn id="11" fill="hold">
+                      <p:stCondLst>
+                        <p:cond delay="indefinite"/>
+                      </p:stCondLst>
+                      <p:childTnLst>
+                        <p:par>
+                          <p:cTn id="12" fill="hold">
+                            <p:stCondLst>
+                              <p:cond delay="0"/>
+                            </p:stCondLst>
+                            <p:childTnLst>
+                              <p:par>
+                                <p:cTn id="13" presetID="34" presetClass="entr" presetSubtype="0" fill="hold" grpId="0" nodeType="clickEffect">
+                                  <p:stCondLst>
+                                    <p:cond delay="0"/>
+                                  </p:stCondLst>
+                                  <p:childTnLst>
+                                    <p:set>
+                                      <p:cBhvr>
+                                        <p:cTn id="14" dur="1" fill="hold">
+                                          <p:stCondLst>
+                                            <p:cond delay="0"/>
+                                          </p:stCondLst>
+                                        </p:cTn>
+                                        <p:tgtEl>
+                                          <p:spTgt spid="9"/>
+                                        </p:tgtEl>
+                                        <p:attrNameLst>
+                                          <p:attrName>style.visibility</p:attrName>
+                                        </p:attrNameLst>
+                                      </p:cBhvr>
+                                      <p:to>
+                                        <p:strVal val="visible"/>
+                                      </p:to>
+                                    </p:set>
+                                    <p:anim from="(-#ppt_w/2)" to="(#ppt_x)" calcmode="lin" valueType="num">
+                                      <p:cBhvr>
+                                        <p:cTn id="15" dur="600" fill="hold">
+                                          <p:stCondLst>
+                                            <p:cond delay="0"/>
+                                          </p:stCondLst>
+                                        </p:cTn>
+                                        <p:tgtEl>
+                                          <p:spTgt spid="9"/>
+                                        </p:tgtEl>
+                                        <p:attrNameLst>
+                                          <p:attrName>ppt_x</p:attrName>
+                                        </p:attrNameLst>
+                                      </p:cBhvr>
+                                    </p:anim>
+                                    <p:anim from="0" to="-1.0" calcmode="lin" valueType="num">
+                                      <p:cBhvr>
+                                        <p:cTn id="16" dur="200" decel="50000" autoRev="1" fill="hold">
+                                          <p:stCondLst>
+                                            <p:cond delay="600"/>
+                                          </p:stCondLst>
+                                        </p:cTn>
+                                        <p:tgtEl>
+                                          <p:spTgt spid="9"/>
+                                        </p:tgtEl>
+                                        <p:attrNameLst>
+                                          <p:attrName>xshear</p:attrName>
+                                        </p:attrNameLst>
+                                      </p:cBhvr>
+                                    </p:anim>
+                                    <p:animScale>
+                                      <p:cBhvr>
+                                        <p:cTn id="17" dur="200" decel="100000" autoRev="1" fill="hold">
+                                          <p:stCondLst>
+                                            <p:cond delay="600"/>
+                                          </p:stCondLst>
+                                        </p:cTn>
+                                        <p:tgtEl>
+                                          <p:spTgt spid="9"/>
+                                        </p:tgtEl>
+                                      </p:cBhvr>
+                                      <p:from x="100000" y="100000"/>
+                                      <p:to x="80000" y="100000"/>
+                                    </p:animScale>
+                                    <p:anim by="(#ppt_h/3+#ppt_w*0.1)" calcmode="lin" valueType="num">
+                                      <p:cBhvr additive="sum">
+                                        <p:cTn id="18" dur="200" decel="100000" autoRev="1" fill="hold">
+                                          <p:stCondLst>
+                                            <p:cond delay="600"/>
+                                          </p:stCondLst>
+                                        </p:cTn>
+                                        <p:tgtEl>
+                                          <p:spTgt spid="9"/>
+                                        </p:tgtEl>
+                                        <p:attrNameLst>
+                                          <p:attrName>ppt_x</p:attrName>
+                                        </p:attrNameLst>
+                                      </p:cBhvr>
+                                    </p:anim>
+                                  </p:childTnLst>
+                                </p:cTn>
+                              </p:par>
+                            </p:childTnLst>
+                          </p:cTn>
+                        </p:par>
+                      </p:childTnLst>
+                    </p:cTn>
+                  </p:par>
+                  <p:par>
+                    <p:cTn id="19" fill="hold">
+                      <p:stCondLst>
+                        <p:cond delay="indefinite"/>
+                      </p:stCondLst>
+                      <p:childTnLst>
+                        <p:par>
+                          <p:cTn id="20" fill="hold">
+                            <p:stCondLst>
+                              <p:cond delay="0"/>
+                            </p:stCondLst>
+                            <p:childTnLst>
+                              <p:par>
+                                <p:cTn id="21" presetID="34" presetClass="entr" presetSubtype="0" fill="hold" grpId="0" nodeType="clickEffect">
+                                  <p:stCondLst>
+                                    <p:cond delay="0"/>
+                                  </p:stCondLst>
+                                  <p:childTnLst>
+                                    <p:set>
+                                      <p:cBhvr>
+                                        <p:cTn id="22" dur="1" fill="hold">
+                                          <p:stCondLst>
+                                            <p:cond delay="0"/>
+                                          </p:stCondLst>
+                                        </p:cTn>
+                                        <p:tgtEl>
+                                          <p:spTgt spid="11"/>
+                                        </p:tgtEl>
+                                        <p:attrNameLst>
+                                          <p:attrName>style.visibility</p:attrName>
+                                        </p:attrNameLst>
+                                      </p:cBhvr>
+                                      <p:to>
+                                        <p:strVal val="visible"/>
+                                      </p:to>
+                                    </p:set>
+                                    <p:anim from="(-#ppt_w/2)" to="(#ppt_x)" calcmode="lin" valueType="num">
+                                      <p:cBhvr>
+                                        <p:cTn id="23" dur="600" fill="hold">
+                                          <p:stCondLst>
+                                            <p:cond delay="0"/>
+                                          </p:stCondLst>
+                                        </p:cTn>
+                                        <p:tgtEl>
+                                          <p:spTgt spid="11"/>
+                                        </p:tgtEl>
+                                        <p:attrNameLst>
+                                          <p:attrName>ppt_x</p:attrName>
+                                        </p:attrNameLst>
+                                      </p:cBhvr>
+                                    </p:anim>
+                                    <p:anim from="0" to="-1.0" calcmode="lin" valueType="num">
+                                      <p:cBhvr>
+                                        <p:cTn id="24" dur="200" decel="50000" autoRev="1" fill="hold">
+                                          <p:stCondLst>
+                                            <p:cond delay="600"/>
+                                          </p:stCondLst>
+                                        </p:cTn>
+                                        <p:tgtEl>
+                                          <p:spTgt spid="11"/>
+                                        </p:tgtEl>
+                                        <p:attrNameLst>
+                                          <p:attrName>xshear</p:attrName>
+                                        </p:attrNameLst>
+                                      </p:cBhvr>
+                                    </p:anim>
+                                    <p:animScale>
+                                      <p:cBhvr>
+                                        <p:cTn id="25" dur="200" decel="100000" autoRev="1" fill="hold">
+                                          <p:stCondLst>
+                                            <p:cond delay="600"/>
+                                          </p:stCondLst>
+                                        </p:cTn>
+                                        <p:tgtEl>
+                                          <p:spTgt spid="11"/>
+                                        </p:tgtEl>
+                                      </p:cBhvr>
+                                      <p:from x="100000" y="100000"/>
+                                      <p:to x="80000" y="100000"/>
+                                    </p:animScale>
+                                    <p:anim by="(#ppt_h/3+#ppt_w*0.1)" calcmode="lin" valueType="num">
+                                      <p:cBhvr additive="sum">
+                                        <p:cTn id="26" dur="200" decel="100000" autoRev="1" fill="hold">
+                                          <p:stCondLst>
+                                            <p:cond delay="600"/>
+                                          </p:stCondLst>
+                                        </p:cTn>
+                                        <p:tgtEl>
+                                          <p:spTgt spid="11"/>
+                                        </p:tgtEl>
+                                        <p:attrNameLst>
+                                          <p:attrName>ppt_x</p:attrName>
+                                        </p:attrNameLst>
+                                      </p:cBhvr>
+                                    </p:anim>
+                                  </p:childTnLst>
+                                </p:cTn>
+                              </p:par>
+                            </p:childTnLst>
+                          </p:cTn>
+                        </p:par>
+                      </p:childTnLst>
+                    </p:cTn>
+                  </p:par>
+                </p:childTnLst>
+              </p:cTn>
+              <p:prevCondLst>
+                <p:cond evt="onPrev" delay="0">
+                  <p:tgtEl>
+                    <p:sldTgt/>
+                  </p:tgtEl>
+                </p:cond>
+              </p:prevCondLst>
+              <p:nextCondLst>
+                <p:cond evt="onNext" delay="0">
+                  <p:tgtEl>
+                    <p:sldTgt/>
+                  </p:tgtEl>
+                </p:cond>
+              </p:nextCondLst>
+            </p:seq>
+          </p:childTnLst>
+        </p:cTn>
+      </p:par>
+    </p:tnLst>
+    <p:bldLst>
+      <p:bldP spid="7" grpId="0"/>
+      <p:bldP spid="9" grpId="0"/>
+      <p:bldP spid="11" grpId="0"/>
+    </p:bldLst>
+  </p:timing>
 </p:sld>
 </file>
 
@@ -6696,7 +7304,7 @@
     </p:spTree>
     <p:extLst>
       <p:ext uri="{BB962C8B-B14F-4D97-AF65-F5344CB8AC3E}">
-        <p14:creationId xmlns:p14="http://schemas.microsoft.com/office/powerpoint/2010/main" val="1224854299"/>
+        <p14:creationId xmlns:p14="http://schemas.microsoft.com/office/powerpoint/2010/main" val="2480152057"/>
       </p:ext>
     </p:extLst>
   </p:cSld>
@@ -7441,7 +8049,7 @@
     </p:spTree>
     <p:extLst>
       <p:ext uri="{BB962C8B-B14F-4D97-AF65-F5344CB8AC3E}">
-        <p14:creationId xmlns:p14="http://schemas.microsoft.com/office/powerpoint/2010/main" val="1044485156"/>
+        <p14:creationId xmlns:p14="http://schemas.microsoft.com/office/powerpoint/2010/main" val="2508626730"/>
       </p:ext>
     </p:extLst>
   </p:cSld>
@@ -8186,7 +8794,7 @@
     </p:spTree>
     <p:extLst>
       <p:ext uri="{BB962C8B-B14F-4D97-AF65-F5344CB8AC3E}">
-        <p14:creationId xmlns:p14="http://schemas.microsoft.com/office/powerpoint/2010/main" val="1461543805"/>
+        <p14:creationId xmlns:p14="http://schemas.microsoft.com/office/powerpoint/2010/main" val="4219450826"/>
       </p:ext>
     </p:extLst>
   </p:cSld>
@@ -8931,7 +9539,7 @@
     </p:spTree>
     <p:extLst>
       <p:ext uri="{BB962C8B-B14F-4D97-AF65-F5344CB8AC3E}">
-        <p14:creationId xmlns:p14="http://schemas.microsoft.com/office/powerpoint/2010/main" val="3931615824"/>
+        <p14:creationId xmlns:p14="http://schemas.microsoft.com/office/powerpoint/2010/main" val="4067632691"/>
       </p:ext>
     </p:extLst>
   </p:cSld>
@@ -9648,7 +10256,7 @@
     </p:spTree>
     <p:extLst>
       <p:ext uri="{BB962C8B-B14F-4D97-AF65-F5344CB8AC3E}">
-        <p14:creationId xmlns:p14="http://schemas.microsoft.com/office/powerpoint/2010/main" val="457254124"/>
+        <p14:creationId xmlns:p14="http://schemas.microsoft.com/office/powerpoint/2010/main" val="1732832051"/>
       </p:ext>
     </p:extLst>
   </p:cSld>
@@ -13041,7 +13649,7 @@
     </p:spTree>
     <p:extLst>
       <p:ext uri="{BB962C8B-B14F-4D97-AF65-F5344CB8AC3E}">
-        <p14:creationId xmlns:p14="http://schemas.microsoft.com/office/powerpoint/2010/main" val="3774026440"/>
+        <p14:creationId xmlns:p14="http://schemas.microsoft.com/office/powerpoint/2010/main" val="476550455"/>
       </p:ext>
     </p:extLst>
   </p:cSld>

</xml_diff>

<commit_message>
Carry the VITAL trial slide into Lecture 11, after the review
It is the worked example of the language of an experiment - units, factors,
levels, treatments - and it was delivered on Wednesday only as far as slide 15,
so it belongs at the front of Friday's class rather than being left behind in
Lecture 10. It now sits between the review and the placebo surgery trial, so
the two clinical trials read as a pair: VITAL names the parts of an experiment,
the placebo trial shows why the placebo arm and the blinding matter.

The build script parks a copy of Lecture 10's slide 15 at the end alongside the
title and review copies before the leading slides are trimmed, then moves all
three to the front. It inherits yesterday's corrected question 4 (what design is
this, and is it blinded) rather than the old "what happened?".

Deck is 18 slides.

Co-Authored-By: Claude Opus 5 (1M context) <noreply@anthropic.com>
</commit_message>
<xml_diff>
--- a/docs/lecture_slides/Week 5/Week5_Lecture11_Slides_9_25_2026.pptx
+++ b/docs/lecture_slides/Week 5/Week5_Lecture11_Slides_9_25_2026.pptx
@@ -7,21 +7,22 @@
   <p:sldIdLst>
     <p:sldId id="317" r:id="rId2"/>
     <p:sldId id="318" r:id="rId3"/>
-    <p:sldId id="298" r:id="rId4"/>
-    <p:sldId id="299" r:id="rId5"/>
-    <p:sldId id="300" r:id="rId6"/>
-    <p:sldId id="301" r:id="rId7"/>
-    <p:sldId id="302" r:id="rId8"/>
-    <p:sldId id="319" r:id="rId9"/>
-    <p:sldId id="304" r:id="rId10"/>
-    <p:sldId id="305" r:id="rId11"/>
-    <p:sldId id="306" r:id="rId12"/>
-    <p:sldId id="324" r:id="rId13"/>
-    <p:sldId id="308" r:id="rId14"/>
-    <p:sldId id="320" r:id="rId15"/>
+    <p:sldId id="319" r:id="rId4"/>
+    <p:sldId id="298" r:id="rId5"/>
+    <p:sldId id="299" r:id="rId6"/>
+    <p:sldId id="300" r:id="rId7"/>
+    <p:sldId id="301" r:id="rId8"/>
+    <p:sldId id="302" r:id="rId9"/>
+    <p:sldId id="320" r:id="rId10"/>
+    <p:sldId id="304" r:id="rId11"/>
+    <p:sldId id="305" r:id="rId12"/>
+    <p:sldId id="306" r:id="rId13"/>
+    <p:sldId id="325" r:id="rId14"/>
+    <p:sldId id="308" r:id="rId15"/>
     <p:sldId id="321" r:id="rId16"/>
     <p:sldId id="322" r:id="rId17"/>
     <p:sldId id="323" r:id="rId18"/>
+    <p:sldId id="324" r:id="rId19"/>
   </p:sldIdLst>
   <p:sldSz cx="12192000" cy="6858000"/>
   <p:notesSz cx="6858000" cy="9144000"/>
@@ -3405,7 +3406,7 @@
     </p:spTree>
     <p:extLst>
       <p:ext uri="{BB962C8B-B14F-4D97-AF65-F5344CB8AC3E}">
-        <p14:creationId xmlns:p14="http://schemas.microsoft.com/office/powerpoint/2010/main" val="3424977105"/>
+        <p14:creationId xmlns:p14="http://schemas.microsoft.com/office/powerpoint/2010/main" val="1954165810"/>
       </p:ext>
     </p:extLst>
   </p:cSld>
@@ -3416,6 +3417,859 @@
 </file>
 
 <file path=ppt/slides/slide10.xml><?xml version="1.0" encoding="utf-8"?>
+<p:sld xmlns:a="http://schemas.openxmlformats.org/drawingml/2006/main" xmlns:r="http://schemas.openxmlformats.org/officeDocument/2006/relationships" xmlns:p="http://schemas.openxmlformats.org/presentationml/2006/main">
+  <p:cSld>
+    <p:spTree>
+      <p:nvGrpSpPr>
+        <p:cNvPr id="1" name=""/>
+        <p:cNvGrpSpPr/>
+        <p:nvPr/>
+      </p:nvGrpSpPr>
+      <p:grpSpPr>
+        <a:xfrm>
+          <a:off x="0" y="0"/>
+          <a:ext cx="0" cy="0"/>
+          <a:chOff x="0" y="0"/>
+          <a:chExt cx="0" cy="0"/>
+        </a:xfrm>
+      </p:grpSpPr>
+      <p:sp>
+        <p:nvSpPr>
+          <p:cNvPr id="2" name="Title 1">
+            <a:extLst>
+              <a:ext uri="{FF2B5EF4-FFF2-40B4-BE49-F238E27FC236}">
+                <a16:creationId xmlns:a16="http://schemas.microsoft.com/office/drawing/2014/main" id="{928FBCDC-48E3-34D7-E16A-ED185680B6C5}"/>
+              </a:ext>
+            </a:extLst>
+          </p:cNvPr>
+          <p:cNvSpPr>
+            <a:spLocks noGrp="1"/>
+          </p:cNvSpPr>
+          <p:nvPr>
+            <p:ph type="title"/>
+          </p:nvPr>
+        </p:nvSpPr>
+        <p:spPr/>
+        <p:txBody>
+          <a:bodyPr>
+            <a:noAutofit/>
+          </a:bodyPr>
+          <a:lstStyle/>
+          <a:p>
+            <a:r>
+              <a:rPr lang="en-US">
+                <a:solidFill>
+                  <a:srgbClr val="1F3864"/>
+                </a:solidFill>
+              </a:rPr>
+              <a:t>Ethics: the Facebook experiment</a:t>
+            </a:r>
+          </a:p>
+        </p:txBody>
+      </p:sp>
+      <p:sp>
+        <p:nvSpPr>
+          <p:cNvPr id="4" name="Slide Number Placeholder 3">
+            <a:extLst>
+              <a:ext uri="{FF2B5EF4-FFF2-40B4-BE49-F238E27FC236}">
+                <a16:creationId xmlns:a16="http://schemas.microsoft.com/office/drawing/2014/main" id="{867D343A-B691-3B93-BC2E-2BC7ADBAE788}"/>
+              </a:ext>
+            </a:extLst>
+          </p:cNvPr>
+          <p:cNvSpPr>
+            <a:spLocks noGrp="1"/>
+          </p:cNvSpPr>
+          <p:nvPr>
+            <p:ph type="sldNum" sz="quarter" idx="12"/>
+          </p:nvPr>
+        </p:nvSpPr>
+        <p:spPr/>
+        <p:txBody>
+          <a:bodyPr/>
+          <a:lstStyle/>
+          <a:p>
+            <a:fld id="{A80A81DD-F10A-4B1C-963A-0ABBB4865886}" type="slidenum">
+              <a:rPr lang="en-US" sz="1600" smtClean="0"/>
+              <a:t>10</a:t>
+            </a:fld>
+            <a:endParaRPr lang="en-US" sz="1600"/>
+          </a:p>
+        </p:txBody>
+      </p:sp>
+      <p:sp>
+        <p:nvSpPr>
+          <p:cNvPr id="5" name="TextBox 4">
+            <a:extLst>
+              <a:ext uri="{FF2B5EF4-FFF2-40B4-BE49-F238E27FC236}">
+                <a16:creationId xmlns:a16="http://schemas.microsoft.com/office/drawing/2014/main" id="{803EF544-7BC1-830E-74B1-64EDAAE169AE}"/>
+              </a:ext>
+            </a:extLst>
+          </p:cNvPr>
+          <p:cNvSpPr txBox="1"/>
+          <p:nvPr/>
+        </p:nvSpPr>
+        <p:spPr>
+          <a:xfrm>
+            <a:off x="762000" y="1841499"/>
+            <a:ext cx="10668000" cy="830997"/>
+          </a:xfrm>
+          <a:prstGeom prst="rect">
+            <a:avLst/>
+          </a:prstGeom>
+          <a:noFill/>
+        </p:spPr>
+        <p:txBody>
+          <a:bodyPr vert="horz" wrap="square" rtlCol="0">
+            <a:spAutoFit/>
+          </a:bodyPr>
+          <a:lstStyle/>
+          <a:p>
+            <a:pPr>
+              <a:spcAft>
+                <a:spcPts val="400"/>
+              </a:spcAft>
+            </a:pPr>
+            <a:r>
+              <a:rPr lang="en-US" sz="1600">
+                <a:solidFill>
+                  <a:srgbClr val="000000"/>
+                </a:solidFill>
+              </a:rPr>
+              <a:t>For one week in January 2012, Facebook ran a completely randomized experiment on 689,003 users: each was assigned at random to a News Feed with fewer positive posts, with fewer negative posts, or left unchanged as a control. The results were published in 2014. The users never knew.</a:t>
+            </a:r>
+          </a:p>
+        </p:txBody>
+      </p:sp>
+      <p:sp>
+        <p:nvSpPr>
+          <p:cNvPr id="6" name="TextBox 5">
+            <a:extLst>
+              <a:ext uri="{FF2B5EF4-FFF2-40B4-BE49-F238E27FC236}">
+                <a16:creationId xmlns:a16="http://schemas.microsoft.com/office/drawing/2014/main" id="{173928F0-6402-96DA-08AE-79702CFCC1E5}"/>
+              </a:ext>
+            </a:extLst>
+          </p:cNvPr>
+          <p:cNvSpPr txBox="1"/>
+          <p:nvPr/>
+        </p:nvSpPr>
+        <p:spPr>
+          <a:xfrm>
+            <a:off x="762000" y="2824896"/>
+            <a:ext cx="10668000" cy="345440"/>
+          </a:xfrm>
+          <a:prstGeom prst="rect">
+            <a:avLst/>
+          </a:prstGeom>
+          <a:noFill/>
+        </p:spPr>
+        <p:txBody>
+          <a:bodyPr vert="horz" wrap="square" rtlCol="0">
+            <a:spAutoFit/>
+          </a:bodyPr>
+          <a:lstStyle/>
+          <a:p>
+            <a:pPr marL="304800" indent="-304800"/>
+            <a:r>
+              <a:rPr lang="en-US" sz="1600" b="1">
+                <a:solidFill>
+                  <a:srgbClr val="C00000"/>
+                </a:solidFill>
+              </a:rPr>
+              <a:t>1.</a:t>
+            </a:r>
+            <a:r>
+              <a:rPr lang="en-US" sz="1600">
+                <a:solidFill>
+                  <a:srgbClr val="000000"/>
+                </a:solidFill>
+              </a:rPr>
+              <a:t>  Facebook said agreeing to its Data Use Policy counted as informed consent. Do you agree?</a:t>
+            </a:r>
+          </a:p>
+        </p:txBody>
+      </p:sp>
+      <p:sp>
+        <p:nvSpPr>
+          <p:cNvPr id="7" name="TextBox 6">
+            <a:extLst>
+              <a:ext uri="{FF2B5EF4-FFF2-40B4-BE49-F238E27FC236}">
+                <a16:creationId xmlns:a16="http://schemas.microsoft.com/office/drawing/2014/main" id="{096B0234-5946-443E-D3EF-6B904164792E}"/>
+              </a:ext>
+            </a:extLst>
+          </p:cNvPr>
+          <p:cNvSpPr txBox="1"/>
+          <p:nvPr/>
+        </p:nvSpPr>
+        <p:spPr>
+          <a:xfrm>
+            <a:off x="1117600" y="3195736"/>
+            <a:ext cx="10312400" cy="589280"/>
+          </a:xfrm>
+          <a:prstGeom prst="rect">
+            <a:avLst/>
+          </a:prstGeom>
+          <a:noFill/>
+        </p:spPr>
+        <p:txBody>
+          <a:bodyPr vert="horz" wrap="square" rtlCol="0">
+            <a:spAutoFit/>
+          </a:bodyPr>
+          <a:lstStyle/>
+          <a:p>
+            <a:r>
+              <a:rPr lang="en-US" sz="1600" b="1">
+                <a:solidFill>
+                  <a:srgbClr val="C00000"/>
+                </a:solidFill>
+              </a:rPr>
+              <a:t>The journal did not: its Expression of Concern said the study may not have met the principles of informed consent and the chance to opt out.</a:t>
+            </a:r>
+          </a:p>
+        </p:txBody>
+      </p:sp>
+      <p:sp>
+        <p:nvSpPr>
+          <p:cNvPr id="8" name="TextBox 7">
+            <a:extLst>
+              <a:ext uri="{FF2B5EF4-FFF2-40B4-BE49-F238E27FC236}">
+                <a16:creationId xmlns:a16="http://schemas.microsoft.com/office/drawing/2014/main" id="{DDBAFEBF-2B58-DFE7-62AD-B002E3656906}"/>
+              </a:ext>
+            </a:extLst>
+          </p:cNvPr>
+          <p:cNvSpPr txBox="1"/>
+          <p:nvPr/>
+        </p:nvSpPr>
+        <p:spPr>
+          <a:xfrm>
+            <a:off x="762000" y="3962816"/>
+            <a:ext cx="10668000" cy="345440"/>
+          </a:xfrm>
+          <a:prstGeom prst="rect">
+            <a:avLst/>
+          </a:prstGeom>
+          <a:noFill/>
+        </p:spPr>
+        <p:txBody>
+          <a:bodyPr vert="horz" wrap="square" rtlCol="0">
+            <a:spAutoFit/>
+          </a:bodyPr>
+          <a:lstStyle/>
+          <a:p>
+            <a:pPr marL="304800" indent="-304800"/>
+            <a:r>
+              <a:rPr lang="en-US" sz="1600" b="1">
+                <a:solidFill>
+                  <a:srgbClr val="C00000"/>
+                </a:solidFill>
+              </a:rPr>
+              <a:t>2.</a:t>
+            </a:r>
+            <a:r>
+              <a:rPr lang="en-US" sz="1600">
+                <a:solidFill>
+                  <a:srgbClr val="000000"/>
+                </a:solidFill>
+              </a:rPr>
+              <a:t>  Why did no ethics board stop it?</a:t>
+            </a:r>
+          </a:p>
+        </p:txBody>
+      </p:sp>
+      <p:sp>
+        <p:nvSpPr>
+          <p:cNvPr id="9" name="TextBox 8">
+            <a:extLst>
+              <a:ext uri="{FF2B5EF4-FFF2-40B4-BE49-F238E27FC236}">
+                <a16:creationId xmlns:a16="http://schemas.microsoft.com/office/drawing/2014/main" id="{37C5EB09-8181-01D4-0AE9-A06C5E9A6703}"/>
+              </a:ext>
+            </a:extLst>
+          </p:cNvPr>
+          <p:cNvSpPr txBox="1"/>
+          <p:nvPr/>
+        </p:nvSpPr>
+        <p:spPr>
+          <a:xfrm>
+            <a:off x="1117600" y="4333656"/>
+            <a:ext cx="10312400" cy="589280"/>
+          </a:xfrm>
+          <a:prstGeom prst="rect">
+            <a:avLst/>
+          </a:prstGeom>
+          <a:noFill/>
+        </p:spPr>
+        <p:txBody>
+          <a:bodyPr vert="horz" wrap="square" rtlCol="0">
+            <a:spAutoFit/>
+          </a:bodyPr>
+          <a:lstStyle/>
+          <a:p>
+            <a:r>
+              <a:rPr lang="en-US" sz="1600" b="1">
+                <a:solidFill>
+                  <a:srgbClr val="C00000"/>
+                </a:solidFill>
+              </a:rPr>
+              <a:t>Facebook, a private company, was not bound by the federal rules. Cornell's board decided its researcher was not directly involved, so it did no review.</a:t>
+            </a:r>
+          </a:p>
+        </p:txBody>
+      </p:sp>
+      <p:sp>
+        <p:nvSpPr>
+          <p:cNvPr id="10" name="TextBox 9">
+            <a:extLst>
+              <a:ext uri="{FF2B5EF4-FFF2-40B4-BE49-F238E27FC236}">
+                <a16:creationId xmlns:a16="http://schemas.microsoft.com/office/drawing/2014/main" id="{2235831A-51A3-E82F-82A5-67061AA1A22E}"/>
+              </a:ext>
+            </a:extLst>
+          </p:cNvPr>
+          <p:cNvSpPr txBox="1"/>
+          <p:nvPr/>
+        </p:nvSpPr>
+        <p:spPr>
+          <a:xfrm>
+            <a:off x="762000" y="5100736"/>
+            <a:ext cx="10668000" cy="345440"/>
+          </a:xfrm>
+          <a:prstGeom prst="rect">
+            <a:avLst/>
+          </a:prstGeom>
+          <a:noFill/>
+        </p:spPr>
+        <p:txBody>
+          <a:bodyPr vert="horz" wrap="square" rtlCol="0">
+            <a:spAutoFit/>
+          </a:bodyPr>
+          <a:lstStyle/>
+          <a:p>
+            <a:pPr marL="304800" indent="-304800"/>
+            <a:r>
+              <a:rPr lang="en-US" sz="1600" b="1">
+                <a:solidFill>
+                  <a:srgbClr val="C00000"/>
+                </a:solidFill>
+              </a:rPr>
+              <a:t>3.</a:t>
+            </a:r>
+            <a:r>
+              <a:rPr lang="en-US" sz="1600">
+                <a:solidFill>
+                  <a:srgbClr val="000000"/>
+                </a:solidFill>
+              </a:rPr>
+              <a:t>  What is the lesson?</a:t>
+            </a:r>
+          </a:p>
+        </p:txBody>
+      </p:sp>
+      <p:sp>
+        <p:nvSpPr>
+          <p:cNvPr id="11" name="TextBox 10">
+            <a:extLst>
+              <a:ext uri="{FF2B5EF4-FFF2-40B4-BE49-F238E27FC236}">
+                <a16:creationId xmlns:a16="http://schemas.microsoft.com/office/drawing/2014/main" id="{7EEE7946-5EA0-8B72-F855-AEB4B6636110}"/>
+              </a:ext>
+            </a:extLst>
+          </p:cNvPr>
+          <p:cNvSpPr txBox="1"/>
+          <p:nvPr/>
+        </p:nvSpPr>
+        <p:spPr>
+          <a:xfrm>
+            <a:off x="1117600" y="5471576"/>
+            <a:ext cx="10312400" cy="345440"/>
+          </a:xfrm>
+          <a:prstGeom prst="rect">
+            <a:avLst/>
+          </a:prstGeom>
+          <a:noFill/>
+        </p:spPr>
+        <p:txBody>
+          <a:bodyPr vert="horz" wrap="square" rtlCol="0">
+            <a:spAutoFit/>
+          </a:bodyPr>
+          <a:lstStyle/>
+          <a:p>
+            <a:r>
+              <a:rPr lang="en-US" sz="1600" b="1">
+                <a:solidFill>
+                  <a:srgbClr val="C00000"/>
+                </a:solidFill>
+              </a:rPr>
+              <a:t>Clicking I agree on a terms-of-service page is not informed consent - even for a well-designed experiment.</a:t>
+            </a:r>
+          </a:p>
+        </p:txBody>
+      </p:sp>
+      <p:sp>
+        <p:nvSpPr>
+          <p:cNvPr id="12" name="TextBox 11">
+            <a:extLst>
+              <a:ext uri="{FF2B5EF4-FFF2-40B4-BE49-F238E27FC236}">
+                <a16:creationId xmlns:a16="http://schemas.microsoft.com/office/drawing/2014/main" id="{3D8E5BD3-1CF7-2352-2707-2D7DBFFA6EBD}"/>
+              </a:ext>
+            </a:extLst>
+          </p:cNvPr>
+          <p:cNvSpPr txBox="1"/>
+          <p:nvPr/>
+        </p:nvSpPr>
+        <p:spPr>
+          <a:xfrm>
+            <a:off x="762000" y="6045200"/>
+            <a:ext cx="10668000" cy="345440"/>
+          </a:xfrm>
+          <a:prstGeom prst="rect">
+            <a:avLst/>
+          </a:prstGeom>
+          <a:noFill/>
+        </p:spPr>
+        <p:txBody>
+          <a:bodyPr vert="horz" wrap="square" rtlCol="0">
+            <a:noAutofit/>
+          </a:bodyPr>
+          <a:lstStyle/>
+          <a:p>
+            <a:pPr algn="r"/>
+            <a:r>
+              <a:rPr lang="en-US" sz="1600" i="1">
+                <a:solidFill>
+                  <a:srgbClr val="595959"/>
+                </a:solidFill>
+              </a:rPr>
+              <a:t>Sources: Kramer, Guillory and Hancock (2014), PNAS; PNAS Editorial Expression of Concern (2014)</a:t>
+            </a:r>
+          </a:p>
+        </p:txBody>
+      </p:sp>
+      <p:sp>
+        <p:nvSpPr>
+          <p:cNvPr id="3" name="Title rule">
+            <a:extLst>
+              <a:ext uri="{FF2B5EF4-FFF2-40B4-BE49-F238E27FC236}">
+                <a16:creationId xmlns:a16="http://schemas.microsoft.com/office/drawing/2014/main" id="{2A19CE9B-6143-6D05-1FF1-AF917901111D}"/>
+              </a:ext>
+            </a:extLst>
+          </p:cNvPr>
+          <p:cNvSpPr/>
+          <p:nvPr/>
+        </p:nvSpPr>
+        <p:spPr>
+          <a:xfrm>
+            <a:off x="838200" y="1600200"/>
+            <a:ext cx="10515600" cy="38100"/>
+          </a:xfrm>
+          <a:prstGeom prst="rect">
+            <a:avLst/>
+          </a:prstGeom>
+          <a:solidFill>
+            <a:srgbClr val="4472C4"/>
+          </a:solidFill>
+          <a:ln w="12700" cap="flat" cmpd="sng" algn="ctr">
+            <a:noFill/>
+            <a:prstDash val="solid"/>
+            <a:miter lim="800000"/>
+          </a:ln>
+          <a:effectLst/>
+          <a:extLst>
+            <a:ext uri="{91240B29-F687-4F45-9708-019B960494DF}">
+              <a14:hiddenLine xmlns:a14="http://schemas.microsoft.com/office/drawing/2010/main" w="12700" cap="flat" cmpd="sng" algn="ctr">
+                <a:solidFill>
+                  <a:schemeClr val="accent1">
+                    <a:shade val="15000"/>
+                  </a:schemeClr>
+                </a:solidFill>
+                <a:prstDash val="solid"/>
+                <a:miter lim="800000"/>
+              </a14:hiddenLine>
+            </a:ext>
+          </a:extLst>
+        </p:spPr>
+        <p:style>
+          <a:lnRef idx="2">
+            <a:schemeClr val="accent1">
+              <a:shade val="15000"/>
+            </a:schemeClr>
+          </a:lnRef>
+          <a:fillRef idx="1">
+            <a:schemeClr val="accent1"/>
+          </a:fillRef>
+          <a:effectRef idx="0">
+            <a:schemeClr val="accent1"/>
+          </a:effectRef>
+          <a:fontRef idx="minor">
+            <a:schemeClr val="lt1"/>
+          </a:fontRef>
+        </p:style>
+        <p:txBody>
+          <a:bodyPr rtlCol="0" anchor="ctr"/>
+          <a:lstStyle/>
+          <a:p>
+            <a:pPr algn="ctr"/>
+            <a:endParaRPr lang="en-US"/>
+          </a:p>
+        </p:txBody>
+      </p:sp>
+    </p:spTree>
+    <p:extLst>
+      <p:ext uri="{BB962C8B-B14F-4D97-AF65-F5344CB8AC3E}">
+        <p14:creationId xmlns:p14="http://schemas.microsoft.com/office/powerpoint/2010/main" val="2555584021"/>
+      </p:ext>
+    </p:extLst>
+  </p:cSld>
+  <p:clrMapOvr>
+    <a:masterClrMapping/>
+  </p:clrMapOvr>
+  <p:timing>
+    <p:tnLst>
+      <p:par>
+        <p:cTn id="1" dur="indefinite" restart="never" nodeType="tmRoot">
+          <p:childTnLst>
+            <p:seq concurrent="1" nextAc="seek">
+              <p:cTn id="2" dur="indefinite" nodeType="mainSeq">
+                <p:childTnLst>
+                  <p:par>
+                    <p:cTn id="3" fill="hold">
+                      <p:stCondLst>
+                        <p:cond delay="indefinite"/>
+                      </p:stCondLst>
+                      <p:childTnLst>
+                        <p:par>
+                          <p:cTn id="4" fill="hold">
+                            <p:stCondLst>
+                              <p:cond delay="0"/>
+                            </p:stCondLst>
+                            <p:childTnLst>
+                              <p:par>
+                                <p:cTn id="5" presetID="34" presetClass="entr" presetSubtype="0" fill="hold" grpId="0" nodeType="clickEffect">
+                                  <p:stCondLst>
+                                    <p:cond delay="0"/>
+                                  </p:stCondLst>
+                                  <p:childTnLst>
+                                    <p:set>
+                                      <p:cBhvr>
+                                        <p:cTn id="6" dur="1" fill="hold">
+                                          <p:stCondLst>
+                                            <p:cond delay="0"/>
+                                          </p:stCondLst>
+                                        </p:cTn>
+                                        <p:tgtEl>
+                                          <p:spTgt spid="7"/>
+                                        </p:tgtEl>
+                                        <p:attrNameLst>
+                                          <p:attrName>style.visibility</p:attrName>
+                                        </p:attrNameLst>
+                                      </p:cBhvr>
+                                      <p:to>
+                                        <p:strVal val="visible"/>
+                                      </p:to>
+                                    </p:set>
+                                    <p:anim from="(-#ppt_w/2)" to="(#ppt_x)" calcmode="lin" valueType="num">
+                                      <p:cBhvr>
+                                        <p:cTn id="7" dur="600" fill="hold">
+                                          <p:stCondLst>
+                                            <p:cond delay="0"/>
+                                          </p:stCondLst>
+                                        </p:cTn>
+                                        <p:tgtEl>
+                                          <p:spTgt spid="7"/>
+                                        </p:tgtEl>
+                                        <p:attrNameLst>
+                                          <p:attrName>ppt_x</p:attrName>
+                                        </p:attrNameLst>
+                                      </p:cBhvr>
+                                    </p:anim>
+                                    <p:anim from="0" to="-1.0" calcmode="lin" valueType="num">
+                                      <p:cBhvr>
+                                        <p:cTn id="8" dur="200" decel="50000" autoRev="1" fill="hold">
+                                          <p:stCondLst>
+                                            <p:cond delay="600"/>
+                                          </p:stCondLst>
+                                        </p:cTn>
+                                        <p:tgtEl>
+                                          <p:spTgt spid="7"/>
+                                        </p:tgtEl>
+                                        <p:attrNameLst>
+                                          <p:attrName>xshear</p:attrName>
+                                        </p:attrNameLst>
+                                      </p:cBhvr>
+                                    </p:anim>
+                                    <p:animScale>
+                                      <p:cBhvr>
+                                        <p:cTn id="9" dur="200" decel="100000" autoRev="1" fill="hold">
+                                          <p:stCondLst>
+                                            <p:cond delay="600"/>
+                                          </p:stCondLst>
+                                        </p:cTn>
+                                        <p:tgtEl>
+                                          <p:spTgt spid="7"/>
+                                        </p:tgtEl>
+                                      </p:cBhvr>
+                                      <p:from x="100000" y="100000"/>
+                                      <p:to x="80000" y="100000"/>
+                                    </p:animScale>
+                                    <p:anim by="(#ppt_h/3+#ppt_w*0.1)" calcmode="lin" valueType="num">
+                                      <p:cBhvr additive="sum">
+                                        <p:cTn id="10" dur="200" decel="100000" autoRev="1" fill="hold">
+                                          <p:stCondLst>
+                                            <p:cond delay="600"/>
+                                          </p:stCondLst>
+                                        </p:cTn>
+                                        <p:tgtEl>
+                                          <p:spTgt spid="7"/>
+                                        </p:tgtEl>
+                                        <p:attrNameLst>
+                                          <p:attrName>ppt_x</p:attrName>
+                                        </p:attrNameLst>
+                                      </p:cBhvr>
+                                    </p:anim>
+                                  </p:childTnLst>
+                                </p:cTn>
+                              </p:par>
+                            </p:childTnLst>
+                          </p:cTn>
+                        </p:par>
+                      </p:childTnLst>
+                    </p:cTn>
+                  </p:par>
+                  <p:par>
+                    <p:cTn id="11" fill="hold">
+                      <p:stCondLst>
+                        <p:cond delay="indefinite"/>
+                      </p:stCondLst>
+                      <p:childTnLst>
+                        <p:par>
+                          <p:cTn id="12" fill="hold">
+                            <p:stCondLst>
+                              <p:cond delay="0"/>
+                            </p:stCondLst>
+                            <p:childTnLst>
+                              <p:par>
+                                <p:cTn id="13" presetID="34" presetClass="entr" presetSubtype="0" fill="hold" grpId="0" nodeType="clickEffect">
+                                  <p:stCondLst>
+                                    <p:cond delay="0"/>
+                                  </p:stCondLst>
+                                  <p:childTnLst>
+                                    <p:set>
+                                      <p:cBhvr>
+                                        <p:cTn id="14" dur="1" fill="hold">
+                                          <p:stCondLst>
+                                            <p:cond delay="0"/>
+                                          </p:stCondLst>
+                                        </p:cTn>
+                                        <p:tgtEl>
+                                          <p:spTgt spid="9"/>
+                                        </p:tgtEl>
+                                        <p:attrNameLst>
+                                          <p:attrName>style.visibility</p:attrName>
+                                        </p:attrNameLst>
+                                      </p:cBhvr>
+                                      <p:to>
+                                        <p:strVal val="visible"/>
+                                      </p:to>
+                                    </p:set>
+                                    <p:anim from="(-#ppt_w/2)" to="(#ppt_x)" calcmode="lin" valueType="num">
+                                      <p:cBhvr>
+                                        <p:cTn id="15" dur="600" fill="hold">
+                                          <p:stCondLst>
+                                            <p:cond delay="0"/>
+                                          </p:stCondLst>
+                                        </p:cTn>
+                                        <p:tgtEl>
+                                          <p:spTgt spid="9"/>
+                                        </p:tgtEl>
+                                        <p:attrNameLst>
+                                          <p:attrName>ppt_x</p:attrName>
+                                        </p:attrNameLst>
+                                      </p:cBhvr>
+                                    </p:anim>
+                                    <p:anim from="0" to="-1.0" calcmode="lin" valueType="num">
+                                      <p:cBhvr>
+                                        <p:cTn id="16" dur="200" decel="50000" autoRev="1" fill="hold">
+                                          <p:stCondLst>
+                                            <p:cond delay="600"/>
+                                          </p:stCondLst>
+                                        </p:cTn>
+                                        <p:tgtEl>
+                                          <p:spTgt spid="9"/>
+                                        </p:tgtEl>
+                                        <p:attrNameLst>
+                                          <p:attrName>xshear</p:attrName>
+                                        </p:attrNameLst>
+                                      </p:cBhvr>
+                                    </p:anim>
+                                    <p:animScale>
+                                      <p:cBhvr>
+                                        <p:cTn id="17" dur="200" decel="100000" autoRev="1" fill="hold">
+                                          <p:stCondLst>
+                                            <p:cond delay="600"/>
+                                          </p:stCondLst>
+                                        </p:cTn>
+                                        <p:tgtEl>
+                                          <p:spTgt spid="9"/>
+                                        </p:tgtEl>
+                                      </p:cBhvr>
+                                      <p:from x="100000" y="100000"/>
+                                      <p:to x="80000" y="100000"/>
+                                    </p:animScale>
+                                    <p:anim by="(#ppt_h/3+#ppt_w*0.1)" calcmode="lin" valueType="num">
+                                      <p:cBhvr additive="sum">
+                                        <p:cTn id="18" dur="200" decel="100000" autoRev="1" fill="hold">
+                                          <p:stCondLst>
+                                            <p:cond delay="600"/>
+                                          </p:stCondLst>
+                                        </p:cTn>
+                                        <p:tgtEl>
+                                          <p:spTgt spid="9"/>
+                                        </p:tgtEl>
+                                        <p:attrNameLst>
+                                          <p:attrName>ppt_x</p:attrName>
+                                        </p:attrNameLst>
+                                      </p:cBhvr>
+                                    </p:anim>
+                                  </p:childTnLst>
+                                </p:cTn>
+                              </p:par>
+                            </p:childTnLst>
+                          </p:cTn>
+                        </p:par>
+                      </p:childTnLst>
+                    </p:cTn>
+                  </p:par>
+                  <p:par>
+                    <p:cTn id="19" fill="hold">
+                      <p:stCondLst>
+                        <p:cond delay="indefinite"/>
+                      </p:stCondLst>
+                      <p:childTnLst>
+                        <p:par>
+                          <p:cTn id="20" fill="hold">
+                            <p:stCondLst>
+                              <p:cond delay="0"/>
+                            </p:stCondLst>
+                            <p:childTnLst>
+                              <p:par>
+                                <p:cTn id="21" presetID="34" presetClass="entr" presetSubtype="0" fill="hold" grpId="0" nodeType="clickEffect">
+                                  <p:stCondLst>
+                                    <p:cond delay="0"/>
+                                  </p:stCondLst>
+                                  <p:childTnLst>
+                                    <p:set>
+                                      <p:cBhvr>
+                                        <p:cTn id="22" dur="1" fill="hold">
+                                          <p:stCondLst>
+                                            <p:cond delay="0"/>
+                                          </p:stCondLst>
+                                        </p:cTn>
+                                        <p:tgtEl>
+                                          <p:spTgt spid="11"/>
+                                        </p:tgtEl>
+                                        <p:attrNameLst>
+                                          <p:attrName>style.visibility</p:attrName>
+                                        </p:attrNameLst>
+                                      </p:cBhvr>
+                                      <p:to>
+                                        <p:strVal val="visible"/>
+                                      </p:to>
+                                    </p:set>
+                                    <p:anim from="(-#ppt_w/2)" to="(#ppt_x)" calcmode="lin" valueType="num">
+                                      <p:cBhvr>
+                                        <p:cTn id="23" dur="600" fill="hold">
+                                          <p:stCondLst>
+                                            <p:cond delay="0"/>
+                                          </p:stCondLst>
+                                        </p:cTn>
+                                        <p:tgtEl>
+                                          <p:spTgt spid="11"/>
+                                        </p:tgtEl>
+                                        <p:attrNameLst>
+                                          <p:attrName>ppt_x</p:attrName>
+                                        </p:attrNameLst>
+                                      </p:cBhvr>
+                                    </p:anim>
+                                    <p:anim from="0" to="-1.0" calcmode="lin" valueType="num">
+                                      <p:cBhvr>
+                                        <p:cTn id="24" dur="200" decel="50000" autoRev="1" fill="hold">
+                                          <p:stCondLst>
+                                            <p:cond delay="600"/>
+                                          </p:stCondLst>
+                                        </p:cTn>
+                                        <p:tgtEl>
+                                          <p:spTgt spid="11"/>
+                                        </p:tgtEl>
+                                        <p:attrNameLst>
+                                          <p:attrName>xshear</p:attrName>
+                                        </p:attrNameLst>
+                                      </p:cBhvr>
+                                    </p:anim>
+                                    <p:animScale>
+                                      <p:cBhvr>
+                                        <p:cTn id="25" dur="200" decel="100000" autoRev="1" fill="hold">
+                                          <p:stCondLst>
+                                            <p:cond delay="600"/>
+                                          </p:stCondLst>
+                                        </p:cTn>
+                                        <p:tgtEl>
+                                          <p:spTgt spid="11"/>
+                                        </p:tgtEl>
+                                      </p:cBhvr>
+                                      <p:from x="100000" y="100000"/>
+                                      <p:to x="80000" y="100000"/>
+                                    </p:animScale>
+                                    <p:anim by="(#ppt_h/3+#ppt_w*0.1)" calcmode="lin" valueType="num">
+                                      <p:cBhvr additive="sum">
+                                        <p:cTn id="26" dur="200" decel="100000" autoRev="1" fill="hold">
+                                          <p:stCondLst>
+                                            <p:cond delay="600"/>
+                                          </p:stCondLst>
+                                        </p:cTn>
+                                        <p:tgtEl>
+                                          <p:spTgt spid="11"/>
+                                        </p:tgtEl>
+                                        <p:attrNameLst>
+                                          <p:attrName>ppt_x</p:attrName>
+                                        </p:attrNameLst>
+                                      </p:cBhvr>
+                                    </p:anim>
+                                  </p:childTnLst>
+                                </p:cTn>
+                              </p:par>
+                            </p:childTnLst>
+                          </p:cTn>
+                        </p:par>
+                      </p:childTnLst>
+                    </p:cTn>
+                  </p:par>
+                </p:childTnLst>
+              </p:cTn>
+              <p:prevCondLst>
+                <p:cond evt="onPrev" delay="0">
+                  <p:tgtEl>
+                    <p:sldTgt/>
+                  </p:tgtEl>
+                </p:cond>
+              </p:prevCondLst>
+              <p:nextCondLst>
+                <p:cond evt="onNext" delay="0">
+                  <p:tgtEl>
+                    <p:sldTgt/>
+                  </p:tgtEl>
+                </p:cond>
+              </p:nextCondLst>
+            </p:seq>
+          </p:childTnLst>
+        </p:cTn>
+      </p:par>
+    </p:tnLst>
+    <p:bldLst>
+      <p:bldP spid="7" grpId="0"/>
+      <p:bldP spid="9" grpId="0"/>
+      <p:bldP spid="11" grpId="0"/>
+    </p:bldLst>
+  </p:timing>
+</p:sld>
+</file>
+
+<file path=ppt/slides/slide11.xml><?xml version="1.0" encoding="utf-8"?>
 <p:sld xmlns:a="http://schemas.openxmlformats.org/drawingml/2006/main" xmlns:r="http://schemas.openxmlformats.org/officeDocument/2006/relationships" xmlns:p="http://schemas.openxmlformats.org/presentationml/2006/main">
   <p:cSld>
     <p:spTree>
@@ -3657,7 +4511,7 @@
           <a:p>
             <a:fld id="{A80A81DD-F10A-4B1C-963A-0ABBB4865886}" type="slidenum">
               <a:rPr lang="en-US" sz="1600" smtClean="0"/>
-              <a:t>10</a:t>
+              <a:t>11</a:t>
             </a:fld>
             <a:endParaRPr lang="en-US" sz="1600"/>
           </a:p>
@@ -4374,7 +5228,7 @@
 </p:sld>
 </file>
 
-<file path=ppt/slides/slide11.xml><?xml version="1.0" encoding="utf-8"?>
+<file path=ppt/slides/slide12.xml><?xml version="1.0" encoding="utf-8"?>
 <p:sld xmlns:a="http://schemas.openxmlformats.org/drawingml/2006/main" xmlns:r="http://schemas.openxmlformats.org/officeDocument/2006/relationships" xmlns:p="http://schemas.openxmlformats.org/presentationml/2006/main">
   <p:cSld>
     <p:spTree>
@@ -4616,7 +5470,7 @@
           <a:p>
             <a:fld id="{A80A81DD-F10A-4B1C-963A-0ABBB4865886}" type="slidenum">
               <a:rPr lang="en-US" sz="1600" smtClean="0"/>
-              <a:t>11</a:t>
+              <a:t>12</a:t>
             </a:fld>
             <a:endParaRPr lang="en-US" sz="1600"/>
           </a:p>
@@ -5294,7 +6148,7 @@
 </p:sld>
 </file>
 
-<file path=ppt/slides/slide12.xml><?xml version="1.0" encoding="utf-8"?>
+<file path=ppt/slides/slide13.xml><?xml version="1.0" encoding="utf-8"?>
 <p:sld xmlns:a="http://schemas.openxmlformats.org/drawingml/2006/main" xmlns:r="http://schemas.openxmlformats.org/officeDocument/2006/relationships" xmlns:p="http://schemas.openxmlformats.org/presentationml/2006/main">
   <p:cSld>
     <p:spTree>
@@ -5368,7 +6222,7 @@
           <a:p>
             <a:fld id="{A80A81DD-F10A-4B1C-963A-0ABBB4865886}" type="slidenum">
               <a:rPr lang="en-US" sz="1600" smtClean="0"/>
-              <a:t>12</a:t>
+              <a:t>13</a:t>
             </a:fld>
             <a:endParaRPr lang="en-US" sz="1600"/>
           </a:p>
@@ -5790,7 +6644,7 @@
     </p:spTree>
     <p:extLst>
       <p:ext uri="{BB962C8B-B14F-4D97-AF65-F5344CB8AC3E}">
-        <p14:creationId xmlns:p14="http://schemas.microsoft.com/office/powerpoint/2010/main" val="4119278081"/>
+        <p14:creationId xmlns:p14="http://schemas.microsoft.com/office/powerpoint/2010/main" val="2134984936"/>
       </p:ext>
     </p:extLst>
   </p:cSld>
@@ -6147,7 +7001,7 @@
 </p:sld>
 </file>
 
-<file path=ppt/slides/slide13.xml><?xml version="1.0" encoding="utf-8"?>
+<file path=ppt/slides/slide14.xml><?xml version="1.0" encoding="utf-8"?>
 <p:sld xmlns:a="http://schemas.openxmlformats.org/drawingml/2006/main" xmlns:r="http://schemas.openxmlformats.org/officeDocument/2006/relationships" xmlns:p="http://schemas.openxmlformats.org/presentationml/2006/main">
   <p:cSld>
     <p:spTree>
@@ -6221,7 +7075,7 @@
           <a:p>
             <a:fld id="{A80A81DD-F10A-4B1C-963A-0ABBB4865886}" type="slidenum">
               <a:rPr lang="en-US" sz="1600" smtClean="0"/>
-              <a:t>13</a:t>
+              <a:t>14</a:t>
             </a:fld>
             <a:endParaRPr lang="en-US" sz="1600"/>
           </a:p>
@@ -6560,751 +7414,6 @@
     <p:extLst>
       <p:ext uri="{BB962C8B-B14F-4D97-AF65-F5344CB8AC3E}">
         <p14:creationId xmlns:p14="http://schemas.microsoft.com/office/powerpoint/2010/main" val="3346080673"/>
-      </p:ext>
-    </p:extLst>
-  </p:cSld>
-  <p:clrMapOvr>
-    <a:masterClrMapping/>
-  </p:clrMapOvr>
-  <p:timing>
-    <p:tnLst>
-      <p:par>
-        <p:cTn id="1" dur="indefinite" restart="never" nodeType="tmRoot">
-          <p:childTnLst>
-            <p:seq concurrent="1" nextAc="seek">
-              <p:cTn id="2" dur="indefinite" nodeType="mainSeq">
-                <p:childTnLst>
-                  <p:par>
-                    <p:cTn id="3" fill="hold">
-                      <p:stCondLst>
-                        <p:cond delay="indefinite"/>
-                      </p:stCondLst>
-                      <p:childTnLst>
-                        <p:par>
-                          <p:cTn id="4" fill="hold">
-                            <p:stCondLst>
-                              <p:cond delay="0"/>
-                            </p:stCondLst>
-                            <p:childTnLst>
-                              <p:par>
-                                <p:cTn id="5" presetID="34" presetClass="entr" presetSubtype="0" fill="hold" grpId="0" nodeType="clickEffect">
-                                  <p:stCondLst>
-                                    <p:cond delay="0"/>
-                                  </p:stCondLst>
-                                  <p:childTnLst>
-                                    <p:set>
-                                      <p:cBhvr>
-                                        <p:cTn id="6" dur="1" fill="hold">
-                                          <p:stCondLst>
-                                            <p:cond delay="0"/>
-                                          </p:stCondLst>
-                                        </p:cTn>
-                                        <p:tgtEl>
-                                          <p:spTgt spid="6"/>
-                                        </p:tgtEl>
-                                        <p:attrNameLst>
-                                          <p:attrName>style.visibility</p:attrName>
-                                        </p:attrNameLst>
-                                      </p:cBhvr>
-                                      <p:to>
-                                        <p:strVal val="visible"/>
-                                      </p:to>
-                                    </p:set>
-                                    <p:anim from="(-#ppt_w/2)" to="(#ppt_x)" calcmode="lin" valueType="num">
-                                      <p:cBhvr>
-                                        <p:cTn id="7" dur="600" fill="hold">
-                                          <p:stCondLst>
-                                            <p:cond delay="0"/>
-                                          </p:stCondLst>
-                                        </p:cTn>
-                                        <p:tgtEl>
-                                          <p:spTgt spid="6"/>
-                                        </p:tgtEl>
-                                        <p:attrNameLst>
-                                          <p:attrName>ppt_x</p:attrName>
-                                        </p:attrNameLst>
-                                      </p:cBhvr>
-                                    </p:anim>
-                                    <p:anim from="0" to="-1.0" calcmode="lin" valueType="num">
-                                      <p:cBhvr>
-                                        <p:cTn id="8" dur="200" decel="50000" autoRev="1" fill="hold">
-                                          <p:stCondLst>
-                                            <p:cond delay="600"/>
-                                          </p:stCondLst>
-                                        </p:cTn>
-                                        <p:tgtEl>
-                                          <p:spTgt spid="6"/>
-                                        </p:tgtEl>
-                                        <p:attrNameLst>
-                                          <p:attrName>xshear</p:attrName>
-                                        </p:attrNameLst>
-                                      </p:cBhvr>
-                                    </p:anim>
-                                    <p:animScale>
-                                      <p:cBhvr>
-                                        <p:cTn id="9" dur="200" decel="100000" autoRev="1" fill="hold">
-                                          <p:stCondLst>
-                                            <p:cond delay="600"/>
-                                          </p:stCondLst>
-                                        </p:cTn>
-                                        <p:tgtEl>
-                                          <p:spTgt spid="6"/>
-                                        </p:tgtEl>
-                                      </p:cBhvr>
-                                      <p:from x="100000" y="100000"/>
-                                      <p:to x="80000" y="100000"/>
-                                    </p:animScale>
-                                    <p:anim by="(#ppt_h/3+#ppt_w*0.1)" calcmode="lin" valueType="num">
-                                      <p:cBhvr additive="sum">
-                                        <p:cTn id="10" dur="200" decel="100000" autoRev="1" fill="hold">
-                                          <p:stCondLst>
-                                            <p:cond delay="600"/>
-                                          </p:stCondLst>
-                                        </p:cTn>
-                                        <p:tgtEl>
-                                          <p:spTgt spid="6"/>
-                                        </p:tgtEl>
-                                        <p:attrNameLst>
-                                          <p:attrName>ppt_x</p:attrName>
-                                        </p:attrNameLst>
-                                      </p:cBhvr>
-                                    </p:anim>
-                                  </p:childTnLst>
-                                </p:cTn>
-                              </p:par>
-                            </p:childTnLst>
-                          </p:cTn>
-                        </p:par>
-                      </p:childTnLst>
-                    </p:cTn>
-                  </p:par>
-                  <p:par>
-                    <p:cTn id="11" fill="hold">
-                      <p:stCondLst>
-                        <p:cond delay="indefinite"/>
-                      </p:stCondLst>
-                      <p:childTnLst>
-                        <p:par>
-                          <p:cTn id="12" fill="hold">
-                            <p:stCondLst>
-                              <p:cond delay="0"/>
-                            </p:stCondLst>
-                            <p:childTnLst>
-                              <p:par>
-                                <p:cTn id="13" presetID="34" presetClass="entr" presetSubtype="0" fill="hold" grpId="0" nodeType="clickEffect">
-                                  <p:stCondLst>
-                                    <p:cond delay="0"/>
-                                  </p:stCondLst>
-                                  <p:childTnLst>
-                                    <p:set>
-                                      <p:cBhvr>
-                                        <p:cTn id="14" dur="1" fill="hold">
-                                          <p:stCondLst>
-                                            <p:cond delay="0"/>
-                                          </p:stCondLst>
-                                        </p:cTn>
-                                        <p:tgtEl>
-                                          <p:spTgt spid="8"/>
-                                        </p:tgtEl>
-                                        <p:attrNameLst>
-                                          <p:attrName>style.visibility</p:attrName>
-                                        </p:attrNameLst>
-                                      </p:cBhvr>
-                                      <p:to>
-                                        <p:strVal val="visible"/>
-                                      </p:to>
-                                    </p:set>
-                                    <p:anim from="(-#ppt_w/2)" to="(#ppt_x)" calcmode="lin" valueType="num">
-                                      <p:cBhvr>
-                                        <p:cTn id="15" dur="600" fill="hold">
-                                          <p:stCondLst>
-                                            <p:cond delay="0"/>
-                                          </p:stCondLst>
-                                        </p:cTn>
-                                        <p:tgtEl>
-                                          <p:spTgt spid="8"/>
-                                        </p:tgtEl>
-                                        <p:attrNameLst>
-                                          <p:attrName>ppt_x</p:attrName>
-                                        </p:attrNameLst>
-                                      </p:cBhvr>
-                                    </p:anim>
-                                    <p:anim from="0" to="-1.0" calcmode="lin" valueType="num">
-                                      <p:cBhvr>
-                                        <p:cTn id="16" dur="200" decel="50000" autoRev="1" fill="hold">
-                                          <p:stCondLst>
-                                            <p:cond delay="600"/>
-                                          </p:stCondLst>
-                                        </p:cTn>
-                                        <p:tgtEl>
-                                          <p:spTgt spid="8"/>
-                                        </p:tgtEl>
-                                        <p:attrNameLst>
-                                          <p:attrName>xshear</p:attrName>
-                                        </p:attrNameLst>
-                                      </p:cBhvr>
-                                    </p:anim>
-                                    <p:animScale>
-                                      <p:cBhvr>
-                                        <p:cTn id="17" dur="200" decel="100000" autoRev="1" fill="hold">
-                                          <p:stCondLst>
-                                            <p:cond delay="600"/>
-                                          </p:stCondLst>
-                                        </p:cTn>
-                                        <p:tgtEl>
-                                          <p:spTgt spid="8"/>
-                                        </p:tgtEl>
-                                      </p:cBhvr>
-                                      <p:from x="100000" y="100000"/>
-                                      <p:to x="80000" y="100000"/>
-                                    </p:animScale>
-                                    <p:anim by="(#ppt_h/3+#ppt_w*0.1)" calcmode="lin" valueType="num">
-                                      <p:cBhvr additive="sum">
-                                        <p:cTn id="18" dur="200" decel="100000" autoRev="1" fill="hold">
-                                          <p:stCondLst>
-                                            <p:cond delay="600"/>
-                                          </p:stCondLst>
-                                        </p:cTn>
-                                        <p:tgtEl>
-                                          <p:spTgt spid="8"/>
-                                        </p:tgtEl>
-                                        <p:attrNameLst>
-                                          <p:attrName>ppt_x</p:attrName>
-                                        </p:attrNameLst>
-                                      </p:cBhvr>
-                                    </p:anim>
-                                  </p:childTnLst>
-                                </p:cTn>
-                              </p:par>
-                            </p:childTnLst>
-                          </p:cTn>
-                        </p:par>
-                      </p:childTnLst>
-                    </p:cTn>
-                  </p:par>
-                  <p:par>
-                    <p:cTn id="19" fill="hold">
-                      <p:stCondLst>
-                        <p:cond delay="indefinite"/>
-                      </p:stCondLst>
-                      <p:childTnLst>
-                        <p:par>
-                          <p:cTn id="20" fill="hold">
-                            <p:stCondLst>
-                              <p:cond delay="0"/>
-                            </p:stCondLst>
-                            <p:childTnLst>
-                              <p:par>
-                                <p:cTn id="21" presetID="34" presetClass="entr" presetSubtype="0" fill="hold" grpId="0" nodeType="clickEffect">
-                                  <p:stCondLst>
-                                    <p:cond delay="0"/>
-                                  </p:stCondLst>
-                                  <p:childTnLst>
-                                    <p:set>
-                                      <p:cBhvr>
-                                        <p:cTn id="22" dur="1" fill="hold">
-                                          <p:stCondLst>
-                                            <p:cond delay="0"/>
-                                          </p:stCondLst>
-                                        </p:cTn>
-                                        <p:tgtEl>
-                                          <p:spTgt spid="10"/>
-                                        </p:tgtEl>
-                                        <p:attrNameLst>
-                                          <p:attrName>style.visibility</p:attrName>
-                                        </p:attrNameLst>
-                                      </p:cBhvr>
-                                      <p:to>
-                                        <p:strVal val="visible"/>
-                                      </p:to>
-                                    </p:set>
-                                    <p:anim from="(-#ppt_w/2)" to="(#ppt_x)" calcmode="lin" valueType="num">
-                                      <p:cBhvr>
-                                        <p:cTn id="23" dur="600" fill="hold">
-                                          <p:stCondLst>
-                                            <p:cond delay="0"/>
-                                          </p:stCondLst>
-                                        </p:cTn>
-                                        <p:tgtEl>
-                                          <p:spTgt spid="10"/>
-                                        </p:tgtEl>
-                                        <p:attrNameLst>
-                                          <p:attrName>ppt_x</p:attrName>
-                                        </p:attrNameLst>
-                                      </p:cBhvr>
-                                    </p:anim>
-                                    <p:anim from="0" to="-1.0" calcmode="lin" valueType="num">
-                                      <p:cBhvr>
-                                        <p:cTn id="24" dur="200" decel="50000" autoRev="1" fill="hold">
-                                          <p:stCondLst>
-                                            <p:cond delay="600"/>
-                                          </p:stCondLst>
-                                        </p:cTn>
-                                        <p:tgtEl>
-                                          <p:spTgt spid="10"/>
-                                        </p:tgtEl>
-                                        <p:attrNameLst>
-                                          <p:attrName>xshear</p:attrName>
-                                        </p:attrNameLst>
-                                      </p:cBhvr>
-                                    </p:anim>
-                                    <p:animScale>
-                                      <p:cBhvr>
-                                        <p:cTn id="25" dur="200" decel="100000" autoRev="1" fill="hold">
-                                          <p:stCondLst>
-                                            <p:cond delay="600"/>
-                                          </p:stCondLst>
-                                        </p:cTn>
-                                        <p:tgtEl>
-                                          <p:spTgt spid="10"/>
-                                        </p:tgtEl>
-                                      </p:cBhvr>
-                                      <p:from x="100000" y="100000"/>
-                                      <p:to x="80000" y="100000"/>
-                                    </p:animScale>
-                                    <p:anim by="(#ppt_h/3+#ppt_w*0.1)" calcmode="lin" valueType="num">
-                                      <p:cBhvr additive="sum">
-                                        <p:cTn id="26" dur="200" decel="100000" autoRev="1" fill="hold">
-                                          <p:stCondLst>
-                                            <p:cond delay="600"/>
-                                          </p:stCondLst>
-                                        </p:cTn>
-                                        <p:tgtEl>
-                                          <p:spTgt spid="10"/>
-                                        </p:tgtEl>
-                                        <p:attrNameLst>
-                                          <p:attrName>ppt_x</p:attrName>
-                                        </p:attrNameLst>
-                                      </p:cBhvr>
-                                    </p:anim>
-                                  </p:childTnLst>
-                                </p:cTn>
-                              </p:par>
-                            </p:childTnLst>
-                          </p:cTn>
-                        </p:par>
-                      </p:childTnLst>
-                    </p:cTn>
-                  </p:par>
-                </p:childTnLst>
-              </p:cTn>
-              <p:prevCondLst>
-                <p:cond evt="onPrev" delay="0">
-                  <p:tgtEl>
-                    <p:sldTgt/>
-                  </p:tgtEl>
-                </p:cond>
-              </p:prevCondLst>
-              <p:nextCondLst>
-                <p:cond evt="onNext" delay="0">
-                  <p:tgtEl>
-                    <p:sldTgt/>
-                  </p:tgtEl>
-                </p:cond>
-              </p:nextCondLst>
-            </p:seq>
-          </p:childTnLst>
-        </p:cTn>
-      </p:par>
-    </p:tnLst>
-    <p:bldLst>
-      <p:bldP spid="6" grpId="0"/>
-      <p:bldP spid="8" grpId="0"/>
-      <p:bldP spid="10" grpId="0"/>
-    </p:bldLst>
-  </p:timing>
-</p:sld>
-</file>
-
-<file path=ppt/slides/slide14.xml><?xml version="1.0" encoding="utf-8"?>
-<p:sld xmlns:a="http://schemas.openxmlformats.org/drawingml/2006/main" xmlns:r="http://schemas.openxmlformats.org/officeDocument/2006/relationships" xmlns:p="http://schemas.openxmlformats.org/presentationml/2006/main">
-  <p:cSld>
-    <p:spTree>
-      <p:nvGrpSpPr>
-        <p:cNvPr id="1" name=""/>
-        <p:cNvGrpSpPr/>
-        <p:nvPr/>
-      </p:nvGrpSpPr>
-      <p:grpSpPr>
-        <a:xfrm>
-          <a:off x="0" y="0"/>
-          <a:ext cx="0" cy="0"/>
-          <a:chOff x="0" y="0"/>
-          <a:chExt cx="0" cy="0"/>
-        </a:xfrm>
-      </p:grpSpPr>
-      <p:sp>
-        <p:nvSpPr>
-          <p:cNvPr id="2" name="Title 1">
-            <a:extLst>
-              <a:ext uri="{FF2B5EF4-FFF2-40B4-BE49-F238E27FC236}">
-                <a16:creationId xmlns:a16="http://schemas.microsoft.com/office/drawing/2014/main" id="{D617AB41-6AD1-9EF2-7F95-46A904399681}"/>
-              </a:ext>
-            </a:extLst>
-          </p:cNvPr>
-          <p:cNvSpPr>
-            <a:spLocks noGrp="1"/>
-          </p:cNvSpPr>
-          <p:nvPr>
-            <p:ph type="title"/>
-          </p:nvPr>
-        </p:nvSpPr>
-        <p:spPr/>
-        <p:txBody>
-          <a:bodyPr>
-            <a:noAutofit/>
-          </a:bodyPr>
-          <a:lstStyle/>
-          <a:p>
-            <a:r>
-              <a:rPr lang="en-US">
-                <a:solidFill>
-                  <a:srgbClr val="1F3864"/>
-                </a:solidFill>
-              </a:rPr>
-              <a:t>What you should know: kinds of study</a:t>
-            </a:r>
-          </a:p>
-        </p:txBody>
-      </p:sp>
-      <p:sp>
-        <p:nvSpPr>
-          <p:cNvPr id="4" name="Slide Number Placeholder 3">
-            <a:extLst>
-              <a:ext uri="{FF2B5EF4-FFF2-40B4-BE49-F238E27FC236}">
-                <a16:creationId xmlns:a16="http://schemas.microsoft.com/office/drawing/2014/main" id="{97D44AE5-98B5-B840-6B8A-D345C7C2E2F0}"/>
-              </a:ext>
-            </a:extLst>
-          </p:cNvPr>
-          <p:cNvSpPr>
-            <a:spLocks noGrp="1"/>
-          </p:cNvSpPr>
-          <p:nvPr>
-            <p:ph type="sldNum" sz="quarter" idx="12"/>
-          </p:nvPr>
-        </p:nvSpPr>
-        <p:spPr/>
-        <p:txBody>
-          <a:bodyPr/>
-          <a:lstStyle/>
-          <a:p>
-            <a:fld id="{A80A81DD-F10A-4B1C-963A-0ABBB4865886}" type="slidenum">
-              <a:rPr lang="en-US" sz="1600" smtClean="0"/>
-              <a:t>14</a:t>
-            </a:fld>
-            <a:endParaRPr lang="en-US" sz="1600"/>
-          </a:p>
-        </p:txBody>
-      </p:sp>
-      <p:sp>
-        <p:nvSpPr>
-          <p:cNvPr id="5" name="TextBox 4">
-            <a:extLst>
-              <a:ext uri="{FF2B5EF4-FFF2-40B4-BE49-F238E27FC236}">
-                <a16:creationId xmlns:a16="http://schemas.microsoft.com/office/drawing/2014/main" id="{A34AAE17-27CE-D7A3-C663-11BB48ACBF5B}"/>
-              </a:ext>
-            </a:extLst>
-          </p:cNvPr>
-          <p:cNvSpPr txBox="1"/>
-          <p:nvPr/>
-        </p:nvSpPr>
-        <p:spPr>
-          <a:xfrm>
-            <a:off x="762000" y="1841500"/>
-            <a:ext cx="10668000" cy="345440"/>
-          </a:xfrm>
-          <a:prstGeom prst="rect">
-            <a:avLst/>
-          </a:prstGeom>
-          <a:noFill/>
-        </p:spPr>
-        <p:txBody>
-          <a:bodyPr vert="horz" wrap="square" rtlCol="0">
-            <a:spAutoFit/>
-          </a:bodyPr>
-          <a:lstStyle/>
-          <a:p>
-            <a:pPr marL="304800" indent="-304800"/>
-            <a:r>
-              <a:rPr lang="en-US" sz="1600">
-                <a:solidFill>
-                  <a:srgbClr val="000000"/>
-                </a:solidFill>
-              </a:rPr>
-              <a:t>Experimental study</a:t>
-            </a:r>
-          </a:p>
-        </p:txBody>
-      </p:sp>
-      <p:sp>
-        <p:nvSpPr>
-          <p:cNvPr id="6" name="TextBox 5">
-            <a:extLst>
-              <a:ext uri="{FF2B5EF4-FFF2-40B4-BE49-F238E27FC236}">
-                <a16:creationId xmlns:a16="http://schemas.microsoft.com/office/drawing/2014/main" id="{E410A0F8-5E1E-9A1D-B64C-50827EE6C9B2}"/>
-              </a:ext>
-            </a:extLst>
-          </p:cNvPr>
-          <p:cNvSpPr txBox="1"/>
-          <p:nvPr/>
-        </p:nvSpPr>
-        <p:spPr>
-          <a:xfrm>
-            <a:off x="1117600" y="2212340"/>
-            <a:ext cx="10312400" cy="584775"/>
-          </a:xfrm>
-          <a:prstGeom prst="rect">
-            <a:avLst/>
-          </a:prstGeom>
-          <a:noFill/>
-        </p:spPr>
-        <p:txBody>
-          <a:bodyPr vert="horz" wrap="square" rtlCol="0">
-            <a:spAutoFit/>
-          </a:bodyPr>
-          <a:lstStyle/>
-          <a:p>
-            <a:r>
-              <a:rPr lang="en-US" sz="1600" b="1">
-                <a:solidFill>
-                  <a:srgbClr val="C00000"/>
-                </a:solidFill>
-              </a:rPr>
-              <a:t>A study in which the researcher assigns the experimental units to treatments and then measures the response. The researcher decides who gets what.</a:t>
-            </a:r>
-          </a:p>
-        </p:txBody>
-      </p:sp>
-      <p:sp>
-        <p:nvSpPr>
-          <p:cNvPr id="7" name="TextBox 6">
-            <a:extLst>
-              <a:ext uri="{FF2B5EF4-FFF2-40B4-BE49-F238E27FC236}">
-                <a16:creationId xmlns:a16="http://schemas.microsoft.com/office/drawing/2014/main" id="{47D3CD95-D52E-5227-B663-7C0A72677B6E}"/>
-              </a:ext>
-            </a:extLst>
-          </p:cNvPr>
-          <p:cNvSpPr txBox="1"/>
-          <p:nvPr/>
-        </p:nvSpPr>
-        <p:spPr>
-          <a:xfrm>
-            <a:off x="762000" y="2974915"/>
-            <a:ext cx="10668000" cy="345440"/>
-          </a:xfrm>
-          <a:prstGeom prst="rect">
-            <a:avLst/>
-          </a:prstGeom>
-          <a:noFill/>
-        </p:spPr>
-        <p:txBody>
-          <a:bodyPr vert="horz" wrap="square" rtlCol="0">
-            <a:spAutoFit/>
-          </a:bodyPr>
-          <a:lstStyle/>
-          <a:p>
-            <a:pPr marL="304800" indent="-304800"/>
-            <a:r>
-              <a:rPr lang="en-US" sz="1600">
-                <a:solidFill>
-                  <a:srgbClr val="000000"/>
-                </a:solidFill>
-              </a:rPr>
-              <a:t>Observational study</a:t>
-            </a:r>
-          </a:p>
-        </p:txBody>
-      </p:sp>
-      <p:sp>
-        <p:nvSpPr>
-          <p:cNvPr id="8" name="TextBox 7">
-            <a:extLst>
-              <a:ext uri="{FF2B5EF4-FFF2-40B4-BE49-F238E27FC236}">
-                <a16:creationId xmlns:a16="http://schemas.microsoft.com/office/drawing/2014/main" id="{1CE3E601-601D-C6B1-8265-C079CB8C9269}"/>
-              </a:ext>
-            </a:extLst>
-          </p:cNvPr>
-          <p:cNvSpPr txBox="1"/>
-          <p:nvPr/>
-        </p:nvSpPr>
-        <p:spPr>
-          <a:xfrm>
-            <a:off x="1117600" y="3345755"/>
-            <a:ext cx="10312400" cy="584775"/>
-          </a:xfrm>
-          <a:prstGeom prst="rect">
-            <a:avLst/>
-          </a:prstGeom>
-          <a:noFill/>
-        </p:spPr>
-        <p:txBody>
-          <a:bodyPr vert="horz" wrap="square" rtlCol="0">
-            <a:spAutoFit/>
-          </a:bodyPr>
-          <a:lstStyle/>
-          <a:p>
-            <a:r>
-              <a:rPr lang="en-US" sz="1600" b="1">
-                <a:solidFill>
-                  <a:srgbClr val="C00000"/>
-                </a:solidFill>
-              </a:rPr>
-              <a:t>A study in which the researcher measures the explanatory and response variables for each unit without trying to influence anything. The units, or circumstance, decide who ends up in which group.</a:t>
-            </a:r>
-          </a:p>
-        </p:txBody>
-      </p:sp>
-      <p:sp>
-        <p:nvSpPr>
-          <p:cNvPr id="9" name="TextBox 8">
-            <a:extLst>
-              <a:ext uri="{FF2B5EF4-FFF2-40B4-BE49-F238E27FC236}">
-                <a16:creationId xmlns:a16="http://schemas.microsoft.com/office/drawing/2014/main" id="{FB002BF4-8037-2F73-E27A-7A453477E389}"/>
-              </a:ext>
-            </a:extLst>
-          </p:cNvPr>
-          <p:cNvSpPr txBox="1"/>
-          <p:nvPr/>
-        </p:nvSpPr>
-        <p:spPr>
-          <a:xfrm>
-            <a:off x="762000" y="4108330"/>
-            <a:ext cx="10668000" cy="345440"/>
-          </a:xfrm>
-          <a:prstGeom prst="rect">
-            <a:avLst/>
-          </a:prstGeom>
-          <a:noFill/>
-        </p:spPr>
-        <p:txBody>
-          <a:bodyPr vert="horz" wrap="square" rtlCol="0">
-            <a:spAutoFit/>
-          </a:bodyPr>
-          <a:lstStyle/>
-          <a:p>
-            <a:pPr marL="304800" indent="-304800"/>
-            <a:r>
-              <a:rPr lang="en-US" sz="1600">
-                <a:solidFill>
-                  <a:srgbClr val="000000"/>
-                </a:solidFill>
-              </a:rPr>
-              <a:t>Survey</a:t>
-            </a:r>
-          </a:p>
-        </p:txBody>
-      </p:sp>
-      <p:sp>
-        <p:nvSpPr>
-          <p:cNvPr id="10" name="TextBox 9">
-            <a:extLst>
-              <a:ext uri="{FF2B5EF4-FFF2-40B4-BE49-F238E27FC236}">
-                <a16:creationId xmlns:a16="http://schemas.microsoft.com/office/drawing/2014/main" id="{10F3B3E3-D27C-E008-C93E-ED70BD2A4754}"/>
-              </a:ext>
-            </a:extLst>
-          </p:cNvPr>
-          <p:cNvSpPr txBox="1"/>
-          <p:nvPr/>
-        </p:nvSpPr>
-        <p:spPr>
-          <a:xfrm>
-            <a:off x="1117600" y="4479170"/>
-            <a:ext cx="10312400" cy="584775"/>
-          </a:xfrm>
-          <a:prstGeom prst="rect">
-            <a:avLst/>
-          </a:prstGeom>
-          <a:noFill/>
-        </p:spPr>
-        <p:txBody>
-          <a:bodyPr vert="horz" wrap="square" rtlCol="0">
-            <a:spAutoFit/>
-          </a:bodyPr>
-          <a:lstStyle/>
-          <a:p>
-            <a:r>
-              <a:rPr lang="en-US" sz="1600" b="1">
-                <a:solidFill>
-                  <a:srgbClr val="C00000"/>
-                </a:solidFill>
-              </a:rPr>
-              <a:t>A study in which units are selected from a population and asked questions, in order to describe that population. A survey is generally a type of observational study - nothing is assigned.</a:t>
-            </a:r>
-          </a:p>
-        </p:txBody>
-      </p:sp>
-      <p:sp>
-        <p:nvSpPr>
-          <p:cNvPr id="3" name="Title rule">
-            <a:extLst>
-              <a:ext uri="{FF2B5EF4-FFF2-40B4-BE49-F238E27FC236}">
-                <a16:creationId xmlns:a16="http://schemas.microsoft.com/office/drawing/2014/main" id="{B469CAAB-2B69-6863-7C28-0C5959E5734B}"/>
-              </a:ext>
-            </a:extLst>
-          </p:cNvPr>
-          <p:cNvSpPr/>
-          <p:nvPr/>
-        </p:nvSpPr>
-        <p:spPr>
-          <a:xfrm>
-            <a:off x="838200" y="1600200"/>
-            <a:ext cx="10515600" cy="38100"/>
-          </a:xfrm>
-          <a:prstGeom prst="rect">
-            <a:avLst/>
-          </a:prstGeom>
-          <a:solidFill>
-            <a:srgbClr val="4472C4"/>
-          </a:solidFill>
-          <a:ln w="12700" cap="flat" cmpd="sng" algn="ctr">
-            <a:noFill/>
-            <a:prstDash val="solid"/>
-            <a:miter lim="800000"/>
-          </a:ln>
-          <a:effectLst/>
-          <a:extLst>
-            <a:ext uri="{91240B29-F687-4F45-9708-019B960494DF}">
-              <a14:hiddenLine xmlns:a14="http://schemas.microsoft.com/office/drawing/2010/main" w="12700" cap="flat" cmpd="sng" algn="ctr">
-                <a:solidFill>
-                  <a:schemeClr val="accent1">
-                    <a:shade val="15000"/>
-                  </a:schemeClr>
-                </a:solidFill>
-                <a:prstDash val="solid"/>
-                <a:miter lim="800000"/>
-              </a14:hiddenLine>
-            </a:ext>
-          </a:extLst>
-        </p:spPr>
-        <p:style>
-          <a:lnRef idx="2">
-            <a:schemeClr val="accent1">
-              <a:shade val="15000"/>
-            </a:schemeClr>
-          </a:lnRef>
-          <a:fillRef idx="1">
-            <a:schemeClr val="accent1"/>
-          </a:fillRef>
-          <a:effectRef idx="0">
-            <a:schemeClr val="accent1"/>
-          </a:effectRef>
-          <a:fontRef idx="minor">
-            <a:schemeClr val="lt1"/>
-          </a:fontRef>
-        </p:style>
-        <p:txBody>
-          <a:bodyPr rtlCol="0" anchor="ctr"/>
-          <a:lstStyle/>
-          <a:p>
-            <a:pPr algn="ctr"/>
-            <a:endParaRPr lang="en-US"/>
-          </a:p>
-        </p:txBody>
-      </p:sp>
-    </p:spTree>
-    <p:extLst>
-      <p:ext uri="{BB962C8B-B14F-4D97-AF65-F5344CB8AC3E}">
-        <p14:creationId xmlns:p14="http://schemas.microsoft.com/office/powerpoint/2010/main" val="2480152057"/>
       </p:ext>
     </p:extLst>
   </p:cSld>
@@ -7707,7 +7816,7 @@
                   <a:srgbClr val="1F3864"/>
                 </a:solidFill>
               </a:rPr>
-              <a:t>What you should know: sampling designs</a:t>
+              <a:t>What you should know: kinds of study</a:t>
             </a:r>
           </a:p>
         </p:txBody>
@@ -7776,7 +7885,7 @@
                   <a:srgbClr val="000000"/>
                 </a:solidFill>
               </a:rPr>
-              <a:t>Simple random sample (SRS), and systematic sample</a:t>
+              <a:t>Experimental study</a:t>
             </a:r>
           </a:p>
         </p:txBody>
@@ -7815,7 +7924,7 @@
                   <a:srgbClr val="C00000"/>
                 </a:solidFill>
               </a:rPr>
-              <a:t>SRS: every possible sample of n units is equally likely. Systematic: choose a random starting point, then take every kth unit from the sampling frame.</a:t>
+              <a:t>A study in which the researcher assigns the experimental units to treatments and then measures the response. The researcher decides who gets what.</a:t>
             </a:r>
           </a:p>
         </p:txBody>
@@ -7855,7 +7964,7 @@
                   <a:srgbClr val="000000"/>
                 </a:solidFill>
               </a:rPr>
-              <a:t>Stratified random sample, and cluster sample</a:t>
+              <a:t>Observational study</a:t>
             </a:r>
           </a:p>
         </p:txBody>
@@ -7875,7 +7984,7 @@
         <p:spPr>
           <a:xfrm>
             <a:off x="1117600" y="3345755"/>
-            <a:ext cx="10312400" cy="830997"/>
+            <a:ext cx="10312400" cy="584775"/>
           </a:xfrm>
           <a:prstGeom prst="rect">
             <a:avLst/>
@@ -7894,7 +8003,7 @@
                   <a:srgbClr val="C00000"/>
                 </a:solidFill>
               </a:rPr>
-              <a:t>Stratified: split the population into strata that are alike within, then draw an independent SRS from each one. Cluster: split it into clusters, each a mini-population, then randomly select whole clusters and measure everyone in them. A two-stage cluster sample then samples units inside the chosen clusters instead of taking all of them.</a:t>
+              <a:t>A study in which the researcher measures the explanatory and response variables for each unit without trying to influence anything. The units, or circumstance, decide who ends up in which group.</a:t>
             </a:r>
           </a:p>
         </p:txBody>
@@ -7913,7 +8022,7 @@
         </p:nvSpPr>
         <p:spPr>
           <a:xfrm>
-            <a:off x="762000" y="4354552"/>
+            <a:off x="762000" y="4108330"/>
             <a:ext cx="10668000" cy="345440"/>
           </a:xfrm>
           <a:prstGeom prst="rect">
@@ -7934,7 +8043,7 @@
                   <a:srgbClr val="000000"/>
                 </a:solidFill>
               </a:rPr>
-              <a:t>Convenience sample, and voluntary response sample</a:t>
+              <a:t>Survey</a:t>
             </a:r>
           </a:p>
         </p:txBody>
@@ -7953,7 +8062,7 @@
         </p:nvSpPr>
         <p:spPr>
           <a:xfrm>
-            <a:off x="1117600" y="4725392"/>
+            <a:off x="1117600" y="4479170"/>
             <a:ext cx="10312400" cy="584775"/>
           </a:xfrm>
           <a:prstGeom prst="rect">
@@ -7973,7 +8082,7 @@
                   <a:srgbClr val="C00000"/>
                 </a:solidFill>
               </a:rPr>
-              <a:t>Convenience: a sample of whoever is easiest to reach. Voluntary response: a sample of people who select themselves by responding. Neither is random, and both are biased no matter how large they get.</a:t>
+              <a:t>A study in which units are selected from a population and asked questions, in order to describe that population. A survey is generally a type of observational study - nothing is assigned.</a:t>
             </a:r>
           </a:p>
         </p:txBody>
@@ -8049,7 +8158,7 @@
     </p:spTree>
     <p:extLst>
       <p:ext uri="{BB962C8B-B14F-4D97-AF65-F5344CB8AC3E}">
-        <p14:creationId xmlns:p14="http://schemas.microsoft.com/office/powerpoint/2010/main" val="2508626730"/>
+        <p14:creationId xmlns:p14="http://schemas.microsoft.com/office/powerpoint/2010/main" val="1113694236"/>
       </p:ext>
     </p:extLst>
   </p:cSld>
@@ -8452,7 +8561,7 @@
                   <a:srgbClr val="1F3864"/>
                 </a:solidFill>
               </a:rPr>
-              <a:t>What you should know: experimental designs</a:t>
+              <a:t>What you should know: sampling designs</a:t>
             </a:r>
           </a:p>
         </p:txBody>
@@ -8521,7 +8630,7 @@
                   <a:srgbClr val="000000"/>
                 </a:solidFill>
               </a:rPr>
-              <a:t>Completely randomized design</a:t>
+              <a:t>Simple random sample (SRS), and systematic sample</a:t>
             </a:r>
           </a:p>
         </p:txBody>
@@ -8541,7 +8650,7 @@
         <p:spPr>
           <a:xfrm>
             <a:off x="1117600" y="2212340"/>
-            <a:ext cx="10312400" cy="345440"/>
+            <a:ext cx="10312400" cy="584775"/>
           </a:xfrm>
           <a:prstGeom prst="rect">
             <a:avLst/>
@@ -8560,7 +8669,7 @@
                   <a:srgbClr val="C00000"/>
                 </a:solidFill>
               </a:rPr>
-              <a:t>Every experimental unit is assigned to a treatment completely at random. The simplest design.</a:t>
+              <a:t>SRS: every possible sample of n units is equally likely. Systematic: choose a random starting point, then take every kth unit from the sampling frame.</a:t>
             </a:r>
           </a:p>
         </p:txBody>
@@ -8579,7 +8688,7 @@
         </p:nvSpPr>
         <p:spPr>
           <a:xfrm>
-            <a:off x="762000" y="2735580"/>
+            <a:off x="762000" y="2974915"/>
             <a:ext cx="10668000" cy="345440"/>
           </a:xfrm>
           <a:prstGeom prst="rect">
@@ -8600,7 +8709,7 @@
                   <a:srgbClr val="000000"/>
                 </a:solidFill>
               </a:rPr>
-              <a:t>Randomized block design</a:t>
+              <a:t>Stratified random sample, and cluster sample</a:t>
             </a:r>
           </a:p>
         </p:txBody>
@@ -8619,7 +8728,86 @@
         </p:nvSpPr>
         <p:spPr>
           <a:xfrm>
-            <a:off x="1117600" y="3106420"/>
+            <a:off x="1117600" y="3345755"/>
+            <a:ext cx="10312400" cy="830997"/>
+          </a:xfrm>
+          <a:prstGeom prst="rect">
+            <a:avLst/>
+          </a:prstGeom>
+          <a:noFill/>
+        </p:spPr>
+        <p:txBody>
+          <a:bodyPr vert="horz" wrap="square" rtlCol="0">
+            <a:spAutoFit/>
+          </a:bodyPr>
+          <a:lstStyle/>
+          <a:p>
+            <a:r>
+              <a:rPr lang="en-US" sz="1600" b="1">
+                <a:solidFill>
+                  <a:srgbClr val="C00000"/>
+                </a:solidFill>
+              </a:rPr>
+              <a:t>Stratified: split the population into strata that are alike within, then draw an independent SRS from each one. Cluster: split it into clusters, each a mini-population, then randomly select whole clusters and measure everyone in them. A two-stage cluster sample then samples units inside the chosen clusters instead of taking all of them.</a:t>
+            </a:r>
+          </a:p>
+        </p:txBody>
+      </p:sp>
+      <p:sp>
+        <p:nvSpPr>
+          <p:cNvPr id="9" name="TextBox 8">
+            <a:extLst>
+              <a:ext uri="{FF2B5EF4-FFF2-40B4-BE49-F238E27FC236}">
+                <a16:creationId xmlns:a16="http://schemas.microsoft.com/office/drawing/2014/main" id="{FB002BF4-8037-2F73-E27A-7A453477E389}"/>
+              </a:ext>
+            </a:extLst>
+          </p:cNvPr>
+          <p:cNvSpPr txBox="1"/>
+          <p:nvPr/>
+        </p:nvSpPr>
+        <p:spPr>
+          <a:xfrm>
+            <a:off x="762000" y="4354552"/>
+            <a:ext cx="10668000" cy="345440"/>
+          </a:xfrm>
+          <a:prstGeom prst="rect">
+            <a:avLst/>
+          </a:prstGeom>
+          <a:noFill/>
+        </p:spPr>
+        <p:txBody>
+          <a:bodyPr vert="horz" wrap="square" rtlCol="0">
+            <a:spAutoFit/>
+          </a:bodyPr>
+          <a:lstStyle/>
+          <a:p>
+            <a:pPr marL="304800" indent="-304800"/>
+            <a:r>
+              <a:rPr lang="en-US" sz="1600">
+                <a:solidFill>
+                  <a:srgbClr val="000000"/>
+                </a:solidFill>
+              </a:rPr>
+              <a:t>Convenience sample, and voluntary response sample</a:t>
+            </a:r>
+          </a:p>
+        </p:txBody>
+      </p:sp>
+      <p:sp>
+        <p:nvSpPr>
+          <p:cNvPr id="10" name="TextBox 9">
+            <a:extLst>
+              <a:ext uri="{FF2B5EF4-FFF2-40B4-BE49-F238E27FC236}">
+                <a16:creationId xmlns:a16="http://schemas.microsoft.com/office/drawing/2014/main" id="{10F3B3E3-D27C-E008-C93E-ED70BD2A4754}"/>
+              </a:ext>
+            </a:extLst>
+          </p:cNvPr>
+          <p:cNvSpPr txBox="1"/>
+          <p:nvPr/>
+        </p:nvSpPr>
+        <p:spPr>
+          <a:xfrm>
+            <a:off x="1117600" y="4725392"/>
             <a:ext cx="10312400" cy="584775"/>
           </a:xfrm>
           <a:prstGeom prst="rect">
@@ -8639,86 +8827,7 @@
                   <a:srgbClr val="C00000"/>
                 </a:solidFill>
               </a:rPr>
-              <a:t>Units are first grouped into blocks that are alike in a way expected to affect the response, and the random assignment is then carried out separately within each block. Blocking is to experiments what stratifying is to sampling.</a:t>
-            </a:r>
-          </a:p>
-        </p:txBody>
-      </p:sp>
-      <p:sp>
-        <p:nvSpPr>
-          <p:cNvPr id="9" name="TextBox 8">
-            <a:extLst>
-              <a:ext uri="{FF2B5EF4-FFF2-40B4-BE49-F238E27FC236}">
-                <a16:creationId xmlns:a16="http://schemas.microsoft.com/office/drawing/2014/main" id="{FB002BF4-8037-2F73-E27A-7A453477E389}"/>
-              </a:ext>
-            </a:extLst>
-          </p:cNvPr>
-          <p:cNvSpPr txBox="1"/>
-          <p:nvPr/>
-        </p:nvSpPr>
-        <p:spPr>
-          <a:xfrm>
-            <a:off x="762000" y="3868995"/>
-            <a:ext cx="10668000" cy="345440"/>
-          </a:xfrm>
-          <a:prstGeom prst="rect">
-            <a:avLst/>
-          </a:prstGeom>
-          <a:noFill/>
-        </p:spPr>
-        <p:txBody>
-          <a:bodyPr vert="horz" wrap="square" rtlCol="0">
-            <a:spAutoFit/>
-          </a:bodyPr>
-          <a:lstStyle/>
-          <a:p>
-            <a:pPr marL="304800" indent="-304800"/>
-            <a:r>
-              <a:rPr lang="en-US" sz="1600">
-                <a:solidFill>
-                  <a:srgbClr val="000000"/>
-                </a:solidFill>
-              </a:rPr>
-              <a:t>Matched pairs design</a:t>
-            </a:r>
-          </a:p>
-        </p:txBody>
-      </p:sp>
-      <p:sp>
-        <p:nvSpPr>
-          <p:cNvPr id="10" name="TextBox 9">
-            <a:extLst>
-              <a:ext uri="{FF2B5EF4-FFF2-40B4-BE49-F238E27FC236}">
-                <a16:creationId xmlns:a16="http://schemas.microsoft.com/office/drawing/2014/main" id="{10F3B3E3-D27C-E008-C93E-ED70BD2A4754}"/>
-              </a:ext>
-            </a:extLst>
-          </p:cNvPr>
-          <p:cNvSpPr txBox="1"/>
-          <p:nvPr/>
-        </p:nvSpPr>
-        <p:spPr>
-          <a:xfrm>
-            <a:off x="1117600" y="4239835"/>
-            <a:ext cx="10312400" cy="584775"/>
-          </a:xfrm>
-          <a:prstGeom prst="rect">
-            <a:avLst/>
-          </a:prstGeom>
-          <a:noFill/>
-        </p:spPr>
-        <p:txBody>
-          <a:bodyPr vert="horz" wrap="square" rtlCol="0">
-            <a:spAutoFit/>
-          </a:bodyPr>
-          <a:lstStyle/>
-          <a:p>
-            <a:r>
-              <a:rPr lang="en-US" sz="1600" b="1">
-                <a:solidFill>
-                  <a:srgbClr val="C00000"/>
-                </a:solidFill>
-              </a:rPr>
-              <a:t>A block design in which each block is a pair of very similar units, such as twins or two adjacent plots - or a single subject who receives both treatments in a random order.</a:t>
+              <a:t>Convenience: a sample of whoever is easiest to reach. Voluntary response: a sample of people who select themselves by responding. Neither is random, and both are biased no matter how large they get.</a:t>
             </a:r>
           </a:p>
         </p:txBody>
@@ -8794,7 +8903,7 @@
     </p:spTree>
     <p:extLst>
       <p:ext uri="{BB962C8B-B14F-4D97-AF65-F5344CB8AC3E}">
-        <p14:creationId xmlns:p14="http://schemas.microsoft.com/office/powerpoint/2010/main" val="4219450826"/>
+        <p14:creationId xmlns:p14="http://schemas.microsoft.com/office/powerpoint/2010/main" val="1920129692"/>
       </p:ext>
     </p:extLst>
   </p:cSld>
@@ -9197,7 +9306,7 @@
                   <a:srgbClr val="1F3864"/>
                 </a:solidFill>
               </a:rPr>
-              <a:t>What you should know: terminology</a:t>
+              <a:t>What you should know: experimental designs</a:t>
             </a:r>
           </a:p>
         </p:txBody>
@@ -9266,7 +9375,7 @@
                   <a:srgbClr val="000000"/>
                 </a:solidFill>
               </a:rPr>
-              <a:t>The language of an experiment</a:t>
+              <a:t>Completely randomized design</a:t>
             </a:r>
           </a:p>
         </p:txBody>
@@ -9305,7 +9414,7 @@
                   <a:srgbClr val="C00000"/>
                 </a:solidFill>
               </a:rPr>
-              <a:t>Experimental units, the factor, its levels, the treatments, the control group, a placebo, blinding and double blinding.</a:t>
+              <a:t>Every experimental unit is assigned to a treatment completely at random. The simplest design.</a:t>
             </a:r>
           </a:p>
         </p:txBody>
@@ -9345,7 +9454,7 @@
                   <a:srgbClr val="000000"/>
                 </a:solidFill>
               </a:rPr>
-              <a:t>Association is not causation</a:t>
+              <a:t>Randomized block design</a:t>
             </a:r>
           </a:p>
         </p:txBody>
@@ -9384,7 +9493,7 @@
                   <a:srgbClr val="C00000"/>
                 </a:solidFill>
               </a:rPr>
-              <a:t>A lurking variable is associated with both the explanatory and the response variable, and can produce an association where there is no causal link.</a:t>
+              <a:t>Units are first grouped into blocks that are alike in a way expected to affect the response, and the random assignment is then carried out separately within each block. Blocking is to experiments what stratifying is to sampling.</a:t>
             </a:r>
           </a:p>
         </p:txBody>
@@ -9424,7 +9533,7 @@
                   <a:srgbClr val="000000"/>
                 </a:solidFill>
               </a:rPr>
-              <a:t>The two things randomness buys you</a:t>
+              <a:t>Matched pairs design</a:t>
             </a:r>
           </a:p>
         </p:txBody>
@@ -9463,7 +9572,7 @@
                   <a:srgbClr val="C00000"/>
                 </a:solidFill>
               </a:rPr>
-              <a:t>Random sampling lets you generalize to the population. Random assignment lets you claim cause. A bigger sample shrinks sampling error, but it never removes bias.</a:t>
+              <a:t>A block design in which each block is a pair of very similar units, such as twins or two adjacent plots - or a single subject who receives both treatments in a random order.</a:t>
             </a:r>
           </a:p>
         </p:txBody>
@@ -9539,7 +9648,752 @@
     </p:spTree>
     <p:extLst>
       <p:ext uri="{BB962C8B-B14F-4D97-AF65-F5344CB8AC3E}">
-        <p14:creationId xmlns:p14="http://schemas.microsoft.com/office/powerpoint/2010/main" val="4067632691"/>
+        <p14:creationId xmlns:p14="http://schemas.microsoft.com/office/powerpoint/2010/main" val="1921636688"/>
+      </p:ext>
+    </p:extLst>
+  </p:cSld>
+  <p:clrMapOvr>
+    <a:masterClrMapping/>
+  </p:clrMapOvr>
+  <p:timing>
+    <p:tnLst>
+      <p:par>
+        <p:cTn id="1" dur="indefinite" restart="never" nodeType="tmRoot">
+          <p:childTnLst>
+            <p:seq concurrent="1" nextAc="seek">
+              <p:cTn id="2" dur="indefinite" nodeType="mainSeq">
+                <p:childTnLst>
+                  <p:par>
+                    <p:cTn id="3" fill="hold">
+                      <p:stCondLst>
+                        <p:cond delay="indefinite"/>
+                      </p:stCondLst>
+                      <p:childTnLst>
+                        <p:par>
+                          <p:cTn id="4" fill="hold">
+                            <p:stCondLst>
+                              <p:cond delay="0"/>
+                            </p:stCondLst>
+                            <p:childTnLst>
+                              <p:par>
+                                <p:cTn id="5" presetID="34" presetClass="entr" presetSubtype="0" fill="hold" grpId="0" nodeType="clickEffect">
+                                  <p:stCondLst>
+                                    <p:cond delay="0"/>
+                                  </p:stCondLst>
+                                  <p:childTnLst>
+                                    <p:set>
+                                      <p:cBhvr>
+                                        <p:cTn id="6" dur="1" fill="hold">
+                                          <p:stCondLst>
+                                            <p:cond delay="0"/>
+                                          </p:stCondLst>
+                                        </p:cTn>
+                                        <p:tgtEl>
+                                          <p:spTgt spid="6"/>
+                                        </p:tgtEl>
+                                        <p:attrNameLst>
+                                          <p:attrName>style.visibility</p:attrName>
+                                        </p:attrNameLst>
+                                      </p:cBhvr>
+                                      <p:to>
+                                        <p:strVal val="visible"/>
+                                      </p:to>
+                                    </p:set>
+                                    <p:anim from="(-#ppt_w/2)" to="(#ppt_x)" calcmode="lin" valueType="num">
+                                      <p:cBhvr>
+                                        <p:cTn id="7" dur="600" fill="hold">
+                                          <p:stCondLst>
+                                            <p:cond delay="0"/>
+                                          </p:stCondLst>
+                                        </p:cTn>
+                                        <p:tgtEl>
+                                          <p:spTgt spid="6"/>
+                                        </p:tgtEl>
+                                        <p:attrNameLst>
+                                          <p:attrName>ppt_x</p:attrName>
+                                        </p:attrNameLst>
+                                      </p:cBhvr>
+                                    </p:anim>
+                                    <p:anim from="0" to="-1.0" calcmode="lin" valueType="num">
+                                      <p:cBhvr>
+                                        <p:cTn id="8" dur="200" decel="50000" autoRev="1" fill="hold">
+                                          <p:stCondLst>
+                                            <p:cond delay="600"/>
+                                          </p:stCondLst>
+                                        </p:cTn>
+                                        <p:tgtEl>
+                                          <p:spTgt spid="6"/>
+                                        </p:tgtEl>
+                                        <p:attrNameLst>
+                                          <p:attrName>xshear</p:attrName>
+                                        </p:attrNameLst>
+                                      </p:cBhvr>
+                                    </p:anim>
+                                    <p:animScale>
+                                      <p:cBhvr>
+                                        <p:cTn id="9" dur="200" decel="100000" autoRev="1" fill="hold">
+                                          <p:stCondLst>
+                                            <p:cond delay="600"/>
+                                          </p:stCondLst>
+                                        </p:cTn>
+                                        <p:tgtEl>
+                                          <p:spTgt spid="6"/>
+                                        </p:tgtEl>
+                                      </p:cBhvr>
+                                      <p:from x="100000" y="100000"/>
+                                      <p:to x="80000" y="100000"/>
+                                    </p:animScale>
+                                    <p:anim by="(#ppt_h/3+#ppt_w*0.1)" calcmode="lin" valueType="num">
+                                      <p:cBhvr additive="sum">
+                                        <p:cTn id="10" dur="200" decel="100000" autoRev="1" fill="hold">
+                                          <p:stCondLst>
+                                            <p:cond delay="600"/>
+                                          </p:stCondLst>
+                                        </p:cTn>
+                                        <p:tgtEl>
+                                          <p:spTgt spid="6"/>
+                                        </p:tgtEl>
+                                        <p:attrNameLst>
+                                          <p:attrName>ppt_x</p:attrName>
+                                        </p:attrNameLst>
+                                      </p:cBhvr>
+                                    </p:anim>
+                                  </p:childTnLst>
+                                </p:cTn>
+                              </p:par>
+                            </p:childTnLst>
+                          </p:cTn>
+                        </p:par>
+                      </p:childTnLst>
+                    </p:cTn>
+                  </p:par>
+                  <p:par>
+                    <p:cTn id="11" fill="hold">
+                      <p:stCondLst>
+                        <p:cond delay="indefinite"/>
+                      </p:stCondLst>
+                      <p:childTnLst>
+                        <p:par>
+                          <p:cTn id="12" fill="hold">
+                            <p:stCondLst>
+                              <p:cond delay="0"/>
+                            </p:stCondLst>
+                            <p:childTnLst>
+                              <p:par>
+                                <p:cTn id="13" presetID="34" presetClass="entr" presetSubtype="0" fill="hold" grpId="0" nodeType="clickEffect">
+                                  <p:stCondLst>
+                                    <p:cond delay="0"/>
+                                  </p:stCondLst>
+                                  <p:childTnLst>
+                                    <p:set>
+                                      <p:cBhvr>
+                                        <p:cTn id="14" dur="1" fill="hold">
+                                          <p:stCondLst>
+                                            <p:cond delay="0"/>
+                                          </p:stCondLst>
+                                        </p:cTn>
+                                        <p:tgtEl>
+                                          <p:spTgt spid="8"/>
+                                        </p:tgtEl>
+                                        <p:attrNameLst>
+                                          <p:attrName>style.visibility</p:attrName>
+                                        </p:attrNameLst>
+                                      </p:cBhvr>
+                                      <p:to>
+                                        <p:strVal val="visible"/>
+                                      </p:to>
+                                    </p:set>
+                                    <p:anim from="(-#ppt_w/2)" to="(#ppt_x)" calcmode="lin" valueType="num">
+                                      <p:cBhvr>
+                                        <p:cTn id="15" dur="600" fill="hold">
+                                          <p:stCondLst>
+                                            <p:cond delay="0"/>
+                                          </p:stCondLst>
+                                        </p:cTn>
+                                        <p:tgtEl>
+                                          <p:spTgt spid="8"/>
+                                        </p:tgtEl>
+                                        <p:attrNameLst>
+                                          <p:attrName>ppt_x</p:attrName>
+                                        </p:attrNameLst>
+                                      </p:cBhvr>
+                                    </p:anim>
+                                    <p:anim from="0" to="-1.0" calcmode="lin" valueType="num">
+                                      <p:cBhvr>
+                                        <p:cTn id="16" dur="200" decel="50000" autoRev="1" fill="hold">
+                                          <p:stCondLst>
+                                            <p:cond delay="600"/>
+                                          </p:stCondLst>
+                                        </p:cTn>
+                                        <p:tgtEl>
+                                          <p:spTgt spid="8"/>
+                                        </p:tgtEl>
+                                        <p:attrNameLst>
+                                          <p:attrName>xshear</p:attrName>
+                                        </p:attrNameLst>
+                                      </p:cBhvr>
+                                    </p:anim>
+                                    <p:animScale>
+                                      <p:cBhvr>
+                                        <p:cTn id="17" dur="200" decel="100000" autoRev="1" fill="hold">
+                                          <p:stCondLst>
+                                            <p:cond delay="600"/>
+                                          </p:stCondLst>
+                                        </p:cTn>
+                                        <p:tgtEl>
+                                          <p:spTgt spid="8"/>
+                                        </p:tgtEl>
+                                      </p:cBhvr>
+                                      <p:from x="100000" y="100000"/>
+                                      <p:to x="80000" y="100000"/>
+                                    </p:animScale>
+                                    <p:anim by="(#ppt_h/3+#ppt_w*0.1)" calcmode="lin" valueType="num">
+                                      <p:cBhvr additive="sum">
+                                        <p:cTn id="18" dur="200" decel="100000" autoRev="1" fill="hold">
+                                          <p:stCondLst>
+                                            <p:cond delay="600"/>
+                                          </p:stCondLst>
+                                        </p:cTn>
+                                        <p:tgtEl>
+                                          <p:spTgt spid="8"/>
+                                        </p:tgtEl>
+                                        <p:attrNameLst>
+                                          <p:attrName>ppt_x</p:attrName>
+                                        </p:attrNameLst>
+                                      </p:cBhvr>
+                                    </p:anim>
+                                  </p:childTnLst>
+                                </p:cTn>
+                              </p:par>
+                            </p:childTnLst>
+                          </p:cTn>
+                        </p:par>
+                      </p:childTnLst>
+                    </p:cTn>
+                  </p:par>
+                  <p:par>
+                    <p:cTn id="19" fill="hold">
+                      <p:stCondLst>
+                        <p:cond delay="indefinite"/>
+                      </p:stCondLst>
+                      <p:childTnLst>
+                        <p:par>
+                          <p:cTn id="20" fill="hold">
+                            <p:stCondLst>
+                              <p:cond delay="0"/>
+                            </p:stCondLst>
+                            <p:childTnLst>
+                              <p:par>
+                                <p:cTn id="21" presetID="34" presetClass="entr" presetSubtype="0" fill="hold" grpId="0" nodeType="clickEffect">
+                                  <p:stCondLst>
+                                    <p:cond delay="0"/>
+                                  </p:stCondLst>
+                                  <p:childTnLst>
+                                    <p:set>
+                                      <p:cBhvr>
+                                        <p:cTn id="22" dur="1" fill="hold">
+                                          <p:stCondLst>
+                                            <p:cond delay="0"/>
+                                          </p:stCondLst>
+                                        </p:cTn>
+                                        <p:tgtEl>
+                                          <p:spTgt spid="10"/>
+                                        </p:tgtEl>
+                                        <p:attrNameLst>
+                                          <p:attrName>style.visibility</p:attrName>
+                                        </p:attrNameLst>
+                                      </p:cBhvr>
+                                      <p:to>
+                                        <p:strVal val="visible"/>
+                                      </p:to>
+                                    </p:set>
+                                    <p:anim from="(-#ppt_w/2)" to="(#ppt_x)" calcmode="lin" valueType="num">
+                                      <p:cBhvr>
+                                        <p:cTn id="23" dur="600" fill="hold">
+                                          <p:stCondLst>
+                                            <p:cond delay="0"/>
+                                          </p:stCondLst>
+                                        </p:cTn>
+                                        <p:tgtEl>
+                                          <p:spTgt spid="10"/>
+                                        </p:tgtEl>
+                                        <p:attrNameLst>
+                                          <p:attrName>ppt_x</p:attrName>
+                                        </p:attrNameLst>
+                                      </p:cBhvr>
+                                    </p:anim>
+                                    <p:anim from="0" to="-1.0" calcmode="lin" valueType="num">
+                                      <p:cBhvr>
+                                        <p:cTn id="24" dur="200" decel="50000" autoRev="1" fill="hold">
+                                          <p:stCondLst>
+                                            <p:cond delay="600"/>
+                                          </p:stCondLst>
+                                        </p:cTn>
+                                        <p:tgtEl>
+                                          <p:spTgt spid="10"/>
+                                        </p:tgtEl>
+                                        <p:attrNameLst>
+                                          <p:attrName>xshear</p:attrName>
+                                        </p:attrNameLst>
+                                      </p:cBhvr>
+                                    </p:anim>
+                                    <p:animScale>
+                                      <p:cBhvr>
+                                        <p:cTn id="25" dur="200" decel="100000" autoRev="1" fill="hold">
+                                          <p:stCondLst>
+                                            <p:cond delay="600"/>
+                                          </p:stCondLst>
+                                        </p:cTn>
+                                        <p:tgtEl>
+                                          <p:spTgt spid="10"/>
+                                        </p:tgtEl>
+                                      </p:cBhvr>
+                                      <p:from x="100000" y="100000"/>
+                                      <p:to x="80000" y="100000"/>
+                                    </p:animScale>
+                                    <p:anim by="(#ppt_h/3+#ppt_w*0.1)" calcmode="lin" valueType="num">
+                                      <p:cBhvr additive="sum">
+                                        <p:cTn id="26" dur="200" decel="100000" autoRev="1" fill="hold">
+                                          <p:stCondLst>
+                                            <p:cond delay="600"/>
+                                          </p:stCondLst>
+                                        </p:cTn>
+                                        <p:tgtEl>
+                                          <p:spTgt spid="10"/>
+                                        </p:tgtEl>
+                                        <p:attrNameLst>
+                                          <p:attrName>ppt_x</p:attrName>
+                                        </p:attrNameLst>
+                                      </p:cBhvr>
+                                    </p:anim>
+                                  </p:childTnLst>
+                                </p:cTn>
+                              </p:par>
+                            </p:childTnLst>
+                          </p:cTn>
+                        </p:par>
+                      </p:childTnLst>
+                    </p:cTn>
+                  </p:par>
+                </p:childTnLst>
+              </p:cTn>
+              <p:prevCondLst>
+                <p:cond evt="onPrev" delay="0">
+                  <p:tgtEl>
+                    <p:sldTgt/>
+                  </p:tgtEl>
+                </p:cond>
+              </p:prevCondLst>
+              <p:nextCondLst>
+                <p:cond evt="onNext" delay="0">
+                  <p:tgtEl>
+                    <p:sldTgt/>
+                  </p:tgtEl>
+                </p:cond>
+              </p:nextCondLst>
+            </p:seq>
+          </p:childTnLst>
+        </p:cTn>
+      </p:par>
+    </p:tnLst>
+    <p:bldLst>
+      <p:bldP spid="6" grpId="0"/>
+      <p:bldP spid="8" grpId="0"/>
+      <p:bldP spid="10" grpId="0"/>
+    </p:bldLst>
+  </p:timing>
+</p:sld>
+</file>
+
+<file path=ppt/slides/slide18.xml><?xml version="1.0" encoding="utf-8"?>
+<p:sld xmlns:a="http://schemas.openxmlformats.org/drawingml/2006/main" xmlns:r="http://schemas.openxmlformats.org/officeDocument/2006/relationships" xmlns:p="http://schemas.openxmlformats.org/presentationml/2006/main">
+  <p:cSld>
+    <p:spTree>
+      <p:nvGrpSpPr>
+        <p:cNvPr id="1" name=""/>
+        <p:cNvGrpSpPr/>
+        <p:nvPr/>
+      </p:nvGrpSpPr>
+      <p:grpSpPr>
+        <a:xfrm>
+          <a:off x="0" y="0"/>
+          <a:ext cx="0" cy="0"/>
+          <a:chOff x="0" y="0"/>
+          <a:chExt cx="0" cy="0"/>
+        </a:xfrm>
+      </p:grpSpPr>
+      <p:sp>
+        <p:nvSpPr>
+          <p:cNvPr id="2" name="Title 1">
+            <a:extLst>
+              <a:ext uri="{FF2B5EF4-FFF2-40B4-BE49-F238E27FC236}">
+                <a16:creationId xmlns:a16="http://schemas.microsoft.com/office/drawing/2014/main" id="{D617AB41-6AD1-9EF2-7F95-46A904399681}"/>
+              </a:ext>
+            </a:extLst>
+          </p:cNvPr>
+          <p:cNvSpPr>
+            <a:spLocks noGrp="1"/>
+          </p:cNvSpPr>
+          <p:nvPr>
+            <p:ph type="title"/>
+          </p:nvPr>
+        </p:nvSpPr>
+        <p:spPr/>
+        <p:txBody>
+          <a:bodyPr>
+            <a:noAutofit/>
+          </a:bodyPr>
+          <a:lstStyle/>
+          <a:p>
+            <a:r>
+              <a:rPr lang="en-US">
+                <a:solidFill>
+                  <a:srgbClr val="1F3864"/>
+                </a:solidFill>
+              </a:rPr>
+              <a:t>What you should know: terminology</a:t>
+            </a:r>
+          </a:p>
+        </p:txBody>
+      </p:sp>
+      <p:sp>
+        <p:nvSpPr>
+          <p:cNvPr id="4" name="Slide Number Placeholder 3">
+            <a:extLst>
+              <a:ext uri="{FF2B5EF4-FFF2-40B4-BE49-F238E27FC236}">
+                <a16:creationId xmlns:a16="http://schemas.microsoft.com/office/drawing/2014/main" id="{97D44AE5-98B5-B840-6B8A-D345C7C2E2F0}"/>
+              </a:ext>
+            </a:extLst>
+          </p:cNvPr>
+          <p:cNvSpPr>
+            <a:spLocks noGrp="1"/>
+          </p:cNvSpPr>
+          <p:nvPr>
+            <p:ph type="sldNum" sz="quarter" idx="12"/>
+          </p:nvPr>
+        </p:nvSpPr>
+        <p:spPr/>
+        <p:txBody>
+          <a:bodyPr/>
+          <a:lstStyle/>
+          <a:p>
+            <a:fld id="{A80A81DD-F10A-4B1C-963A-0ABBB4865886}" type="slidenum">
+              <a:rPr lang="en-US" sz="1600" smtClean="0"/>
+              <a:t>18</a:t>
+            </a:fld>
+            <a:endParaRPr lang="en-US" sz="1600"/>
+          </a:p>
+        </p:txBody>
+      </p:sp>
+      <p:sp>
+        <p:nvSpPr>
+          <p:cNvPr id="5" name="TextBox 4">
+            <a:extLst>
+              <a:ext uri="{FF2B5EF4-FFF2-40B4-BE49-F238E27FC236}">
+                <a16:creationId xmlns:a16="http://schemas.microsoft.com/office/drawing/2014/main" id="{A34AAE17-27CE-D7A3-C663-11BB48ACBF5B}"/>
+              </a:ext>
+            </a:extLst>
+          </p:cNvPr>
+          <p:cNvSpPr txBox="1"/>
+          <p:nvPr/>
+        </p:nvSpPr>
+        <p:spPr>
+          <a:xfrm>
+            <a:off x="762000" y="1841500"/>
+            <a:ext cx="10668000" cy="345440"/>
+          </a:xfrm>
+          <a:prstGeom prst="rect">
+            <a:avLst/>
+          </a:prstGeom>
+          <a:noFill/>
+        </p:spPr>
+        <p:txBody>
+          <a:bodyPr vert="horz" wrap="square" rtlCol="0">
+            <a:spAutoFit/>
+          </a:bodyPr>
+          <a:lstStyle/>
+          <a:p>
+            <a:pPr marL="304800" indent="-304800"/>
+            <a:r>
+              <a:rPr lang="en-US" sz="1600">
+                <a:solidFill>
+                  <a:srgbClr val="000000"/>
+                </a:solidFill>
+              </a:rPr>
+              <a:t>The language of an experiment</a:t>
+            </a:r>
+          </a:p>
+        </p:txBody>
+      </p:sp>
+      <p:sp>
+        <p:nvSpPr>
+          <p:cNvPr id="6" name="TextBox 5">
+            <a:extLst>
+              <a:ext uri="{FF2B5EF4-FFF2-40B4-BE49-F238E27FC236}">
+                <a16:creationId xmlns:a16="http://schemas.microsoft.com/office/drawing/2014/main" id="{E410A0F8-5E1E-9A1D-B64C-50827EE6C9B2}"/>
+              </a:ext>
+            </a:extLst>
+          </p:cNvPr>
+          <p:cNvSpPr txBox="1"/>
+          <p:nvPr/>
+        </p:nvSpPr>
+        <p:spPr>
+          <a:xfrm>
+            <a:off x="1117600" y="2212340"/>
+            <a:ext cx="10312400" cy="345440"/>
+          </a:xfrm>
+          <a:prstGeom prst="rect">
+            <a:avLst/>
+          </a:prstGeom>
+          <a:noFill/>
+        </p:spPr>
+        <p:txBody>
+          <a:bodyPr vert="horz" wrap="square" rtlCol="0">
+            <a:spAutoFit/>
+          </a:bodyPr>
+          <a:lstStyle/>
+          <a:p>
+            <a:r>
+              <a:rPr lang="en-US" sz="1600" b="1">
+                <a:solidFill>
+                  <a:srgbClr val="C00000"/>
+                </a:solidFill>
+              </a:rPr>
+              <a:t>Experimental units, the factor, its levels, the treatments, the control group, a placebo, blinding and double blinding.</a:t>
+            </a:r>
+          </a:p>
+        </p:txBody>
+      </p:sp>
+      <p:sp>
+        <p:nvSpPr>
+          <p:cNvPr id="7" name="TextBox 6">
+            <a:extLst>
+              <a:ext uri="{FF2B5EF4-FFF2-40B4-BE49-F238E27FC236}">
+                <a16:creationId xmlns:a16="http://schemas.microsoft.com/office/drawing/2014/main" id="{47D3CD95-D52E-5227-B663-7C0A72677B6E}"/>
+              </a:ext>
+            </a:extLst>
+          </p:cNvPr>
+          <p:cNvSpPr txBox="1"/>
+          <p:nvPr/>
+        </p:nvSpPr>
+        <p:spPr>
+          <a:xfrm>
+            <a:off x="762000" y="2735580"/>
+            <a:ext cx="10668000" cy="345440"/>
+          </a:xfrm>
+          <a:prstGeom prst="rect">
+            <a:avLst/>
+          </a:prstGeom>
+          <a:noFill/>
+        </p:spPr>
+        <p:txBody>
+          <a:bodyPr vert="horz" wrap="square" rtlCol="0">
+            <a:spAutoFit/>
+          </a:bodyPr>
+          <a:lstStyle/>
+          <a:p>
+            <a:pPr marL="304800" indent="-304800"/>
+            <a:r>
+              <a:rPr lang="en-US" sz="1600">
+                <a:solidFill>
+                  <a:srgbClr val="000000"/>
+                </a:solidFill>
+              </a:rPr>
+              <a:t>Association is not causation</a:t>
+            </a:r>
+          </a:p>
+        </p:txBody>
+      </p:sp>
+      <p:sp>
+        <p:nvSpPr>
+          <p:cNvPr id="8" name="TextBox 7">
+            <a:extLst>
+              <a:ext uri="{FF2B5EF4-FFF2-40B4-BE49-F238E27FC236}">
+                <a16:creationId xmlns:a16="http://schemas.microsoft.com/office/drawing/2014/main" id="{1CE3E601-601D-C6B1-8265-C079CB8C9269}"/>
+              </a:ext>
+            </a:extLst>
+          </p:cNvPr>
+          <p:cNvSpPr txBox="1"/>
+          <p:nvPr/>
+        </p:nvSpPr>
+        <p:spPr>
+          <a:xfrm>
+            <a:off x="1117600" y="3106420"/>
+            <a:ext cx="10312400" cy="584775"/>
+          </a:xfrm>
+          <a:prstGeom prst="rect">
+            <a:avLst/>
+          </a:prstGeom>
+          <a:noFill/>
+        </p:spPr>
+        <p:txBody>
+          <a:bodyPr vert="horz" wrap="square" rtlCol="0">
+            <a:spAutoFit/>
+          </a:bodyPr>
+          <a:lstStyle/>
+          <a:p>
+            <a:r>
+              <a:rPr lang="en-US" sz="1600" b="1">
+                <a:solidFill>
+                  <a:srgbClr val="C00000"/>
+                </a:solidFill>
+              </a:rPr>
+              <a:t>A lurking variable is associated with both the explanatory and the response variable, and can produce an association where there is no causal link.</a:t>
+            </a:r>
+          </a:p>
+        </p:txBody>
+      </p:sp>
+      <p:sp>
+        <p:nvSpPr>
+          <p:cNvPr id="9" name="TextBox 8">
+            <a:extLst>
+              <a:ext uri="{FF2B5EF4-FFF2-40B4-BE49-F238E27FC236}">
+                <a16:creationId xmlns:a16="http://schemas.microsoft.com/office/drawing/2014/main" id="{FB002BF4-8037-2F73-E27A-7A453477E389}"/>
+              </a:ext>
+            </a:extLst>
+          </p:cNvPr>
+          <p:cNvSpPr txBox="1"/>
+          <p:nvPr/>
+        </p:nvSpPr>
+        <p:spPr>
+          <a:xfrm>
+            <a:off x="762000" y="3868995"/>
+            <a:ext cx="10668000" cy="345440"/>
+          </a:xfrm>
+          <a:prstGeom prst="rect">
+            <a:avLst/>
+          </a:prstGeom>
+          <a:noFill/>
+        </p:spPr>
+        <p:txBody>
+          <a:bodyPr vert="horz" wrap="square" rtlCol="0">
+            <a:spAutoFit/>
+          </a:bodyPr>
+          <a:lstStyle/>
+          <a:p>
+            <a:pPr marL="304800" indent="-304800"/>
+            <a:r>
+              <a:rPr lang="en-US" sz="1600">
+                <a:solidFill>
+                  <a:srgbClr val="000000"/>
+                </a:solidFill>
+              </a:rPr>
+              <a:t>The two things randomness buys you</a:t>
+            </a:r>
+          </a:p>
+        </p:txBody>
+      </p:sp>
+      <p:sp>
+        <p:nvSpPr>
+          <p:cNvPr id="10" name="TextBox 9">
+            <a:extLst>
+              <a:ext uri="{FF2B5EF4-FFF2-40B4-BE49-F238E27FC236}">
+                <a16:creationId xmlns:a16="http://schemas.microsoft.com/office/drawing/2014/main" id="{10F3B3E3-D27C-E008-C93E-ED70BD2A4754}"/>
+              </a:ext>
+            </a:extLst>
+          </p:cNvPr>
+          <p:cNvSpPr txBox="1"/>
+          <p:nvPr/>
+        </p:nvSpPr>
+        <p:spPr>
+          <a:xfrm>
+            <a:off x="1117600" y="4239835"/>
+            <a:ext cx="10312400" cy="584775"/>
+          </a:xfrm>
+          <a:prstGeom prst="rect">
+            <a:avLst/>
+          </a:prstGeom>
+          <a:noFill/>
+        </p:spPr>
+        <p:txBody>
+          <a:bodyPr vert="horz" wrap="square" rtlCol="0">
+            <a:spAutoFit/>
+          </a:bodyPr>
+          <a:lstStyle/>
+          <a:p>
+            <a:r>
+              <a:rPr lang="en-US" sz="1600" b="1">
+                <a:solidFill>
+                  <a:srgbClr val="C00000"/>
+                </a:solidFill>
+              </a:rPr>
+              <a:t>Random sampling lets you generalize to the population. Random assignment lets you claim cause. A bigger sample shrinks sampling error, but it never removes bias.</a:t>
+            </a:r>
+          </a:p>
+        </p:txBody>
+      </p:sp>
+      <p:sp>
+        <p:nvSpPr>
+          <p:cNvPr id="3" name="Title rule">
+            <a:extLst>
+              <a:ext uri="{FF2B5EF4-FFF2-40B4-BE49-F238E27FC236}">
+                <a16:creationId xmlns:a16="http://schemas.microsoft.com/office/drawing/2014/main" id="{B469CAAB-2B69-6863-7C28-0C5959E5734B}"/>
+              </a:ext>
+            </a:extLst>
+          </p:cNvPr>
+          <p:cNvSpPr/>
+          <p:nvPr/>
+        </p:nvSpPr>
+        <p:spPr>
+          <a:xfrm>
+            <a:off x="838200" y="1600200"/>
+            <a:ext cx="10515600" cy="38100"/>
+          </a:xfrm>
+          <a:prstGeom prst="rect">
+            <a:avLst/>
+          </a:prstGeom>
+          <a:solidFill>
+            <a:srgbClr val="4472C4"/>
+          </a:solidFill>
+          <a:ln w="12700" cap="flat" cmpd="sng" algn="ctr">
+            <a:noFill/>
+            <a:prstDash val="solid"/>
+            <a:miter lim="800000"/>
+          </a:ln>
+          <a:effectLst/>
+          <a:extLst>
+            <a:ext uri="{91240B29-F687-4F45-9708-019B960494DF}">
+              <a14:hiddenLine xmlns:a14="http://schemas.microsoft.com/office/drawing/2010/main" w="12700" cap="flat" cmpd="sng" algn="ctr">
+                <a:solidFill>
+                  <a:schemeClr val="accent1">
+                    <a:shade val="15000"/>
+                  </a:schemeClr>
+                </a:solidFill>
+                <a:prstDash val="solid"/>
+                <a:miter lim="800000"/>
+              </a14:hiddenLine>
+            </a:ext>
+          </a:extLst>
+        </p:spPr>
+        <p:style>
+          <a:lnRef idx="2">
+            <a:schemeClr val="accent1">
+              <a:shade val="15000"/>
+            </a:schemeClr>
+          </a:lnRef>
+          <a:fillRef idx="1">
+            <a:schemeClr val="accent1"/>
+          </a:fillRef>
+          <a:effectRef idx="0">
+            <a:schemeClr val="accent1"/>
+          </a:effectRef>
+          <a:fontRef idx="minor">
+            <a:schemeClr val="lt1"/>
+          </a:fontRef>
+        </p:style>
+        <p:txBody>
+          <a:bodyPr rtlCol="0" anchor="ctr"/>
+          <a:lstStyle/>
+          <a:p>
+            <a:pPr algn="ctr"/>
+            <a:endParaRPr lang="en-US"/>
+          </a:p>
+        </p:txBody>
+      </p:sp>
+    </p:spTree>
+    <p:extLst>
+      <p:ext uri="{BB962C8B-B14F-4D97-AF65-F5344CB8AC3E}">
+        <p14:creationId xmlns:p14="http://schemas.microsoft.com/office/powerpoint/2010/main" val="3228885230"/>
       </p:ext>
     </p:extLst>
   </p:cSld>
@@ -10256,7 +11110,7 @@
     </p:spTree>
     <p:extLst>
       <p:ext uri="{BB962C8B-B14F-4D97-AF65-F5344CB8AC3E}">
-        <p14:creationId xmlns:p14="http://schemas.microsoft.com/office/powerpoint/2010/main" val="1732832051"/>
+        <p14:creationId xmlns:p14="http://schemas.microsoft.com/office/powerpoint/2010/main" val="1361040548"/>
       </p:ext>
     </p:extLst>
   </p:cSld>
@@ -10588,7 +11442,7 @@
           <p:cNvPr id="2" name="Title 1">
             <a:extLst>
               <a:ext uri="{FF2B5EF4-FFF2-40B4-BE49-F238E27FC236}">
-                <a16:creationId xmlns:a16="http://schemas.microsoft.com/office/drawing/2014/main" id="{C08D30B1-1864-30EF-7EAB-9BEE656C0012}"/>
+                <a16:creationId xmlns:a16="http://schemas.microsoft.com/office/drawing/2014/main" id="{8E239F2B-D79C-B061-7D7C-D0E3E9E9F703}"/>
               </a:ext>
             </a:extLst>
           </p:cNvPr>
@@ -10612,7 +11466,7 @@
                   <a:srgbClr val="1F3864"/>
                 </a:solidFill>
               </a:rPr>
-              <a:t>A placebo surgery</a:t>
+              <a:t>Example: the VITAL trial</a:t>
             </a:r>
           </a:p>
         </p:txBody>
@@ -10622,7 +11476,7 @@
           <p:cNvPr id="4" name="Slide Number Placeholder 3">
             <a:extLst>
               <a:ext uri="{FF2B5EF4-FFF2-40B4-BE49-F238E27FC236}">
-                <a16:creationId xmlns:a16="http://schemas.microsoft.com/office/drawing/2014/main" id="{3F875068-D051-44AE-498E-1BEBEDE3A7C8}"/>
+                <a16:creationId xmlns:a16="http://schemas.microsoft.com/office/drawing/2014/main" id="{50869749-915A-A889-6AF8-EEE3DE2B6C67}"/>
               </a:ext>
             </a:extLst>
           </p:cNvPr>
@@ -10641,6 +11495,1051 @@
             <a:fld id="{A80A81DD-F10A-4B1C-963A-0ABBB4865886}" type="slidenum">
               <a:rPr lang="en-US" sz="1600" smtClean="0"/>
               <a:t>3</a:t>
+            </a:fld>
+            <a:endParaRPr lang="en-US" sz="1600"/>
+          </a:p>
+        </p:txBody>
+      </p:sp>
+      <p:sp>
+        <p:nvSpPr>
+          <p:cNvPr id="5" name="TextBox 4">
+            <a:extLst>
+              <a:ext uri="{FF2B5EF4-FFF2-40B4-BE49-F238E27FC236}">
+                <a16:creationId xmlns:a16="http://schemas.microsoft.com/office/drawing/2014/main" id="{0154EC98-752B-E4E1-3A6C-D7C162824379}"/>
+              </a:ext>
+            </a:extLst>
+          </p:cNvPr>
+          <p:cNvSpPr txBox="1"/>
+          <p:nvPr/>
+        </p:nvSpPr>
+        <p:spPr>
+          <a:xfrm>
+            <a:off x="762000" y="1841499"/>
+            <a:ext cx="10668000" cy="584775"/>
+          </a:xfrm>
+          <a:prstGeom prst="rect">
+            <a:avLst/>
+          </a:prstGeom>
+          <a:noFill/>
+        </p:spPr>
+        <p:txBody>
+          <a:bodyPr vert="horz" wrap="square" rtlCol="0">
+            <a:spAutoFit/>
+          </a:bodyPr>
+          <a:lstStyle/>
+          <a:p>
+            <a:pPr>
+              <a:spcAft>
+                <a:spcPts val="400"/>
+              </a:spcAft>
+            </a:pPr>
+            <a:r>
+              <a:rPr lang="en-US" sz="1600">
+                <a:solidFill>
+                  <a:srgbClr val="000000"/>
+                </a:solidFill>
+              </a:rPr>
+              <a:t>VITAL randomly assigned 25,871 U.S. adults to vitamin D (2,000 IU a day) or a placebo, AND to omega-3 fish oil (1 g a day) or a placebo - nobody knew who got what - then followed them for about 5 years.</a:t>
+            </a:r>
+          </a:p>
+        </p:txBody>
+      </p:sp>
+      <p:sp>
+        <p:nvSpPr>
+          <p:cNvPr id="6" name="TextBox 5">
+            <a:extLst>
+              <a:ext uri="{FF2B5EF4-FFF2-40B4-BE49-F238E27FC236}">
+                <a16:creationId xmlns:a16="http://schemas.microsoft.com/office/drawing/2014/main" id="{FEA24511-5DA8-139E-D168-B30F6FC9D645}"/>
+              </a:ext>
+            </a:extLst>
+          </p:cNvPr>
+          <p:cNvSpPr txBox="1"/>
+          <p:nvPr/>
+        </p:nvSpPr>
+        <p:spPr>
+          <a:xfrm>
+            <a:off x="762000" y="2578674"/>
+            <a:ext cx="10668000" cy="345440"/>
+          </a:xfrm>
+          <a:prstGeom prst="rect">
+            <a:avLst/>
+          </a:prstGeom>
+          <a:noFill/>
+        </p:spPr>
+        <p:txBody>
+          <a:bodyPr vert="horz" wrap="square" rtlCol="0">
+            <a:spAutoFit/>
+          </a:bodyPr>
+          <a:lstStyle/>
+          <a:p>
+            <a:pPr marL="304800" indent="-304800"/>
+            <a:r>
+              <a:rPr lang="en-US" sz="1600" b="1">
+                <a:solidFill>
+                  <a:srgbClr val="C00000"/>
+                </a:solidFill>
+              </a:rPr>
+              <a:t>1.</a:t>
+            </a:r>
+            <a:r>
+              <a:rPr lang="en-US" sz="1600">
+                <a:solidFill>
+                  <a:srgbClr val="000000"/>
+                </a:solidFill>
+              </a:rPr>
+              <a:t>  What are the experimental units - and what do we call them?</a:t>
+            </a:r>
+          </a:p>
+        </p:txBody>
+      </p:sp>
+      <p:sp>
+        <p:nvSpPr>
+          <p:cNvPr id="7" name="TextBox 6">
+            <a:extLst>
+              <a:ext uri="{FF2B5EF4-FFF2-40B4-BE49-F238E27FC236}">
+                <a16:creationId xmlns:a16="http://schemas.microsoft.com/office/drawing/2014/main" id="{36AD3336-BE2D-C5F7-C1A2-C937A4C032A2}"/>
+              </a:ext>
+            </a:extLst>
+          </p:cNvPr>
+          <p:cNvSpPr txBox="1"/>
+          <p:nvPr/>
+        </p:nvSpPr>
+        <p:spPr>
+          <a:xfrm>
+            <a:off x="1117600" y="2936814"/>
+            <a:ext cx="10312400" cy="345440"/>
+          </a:xfrm>
+          <a:prstGeom prst="rect">
+            <a:avLst/>
+          </a:prstGeom>
+          <a:noFill/>
+        </p:spPr>
+        <p:txBody>
+          <a:bodyPr vert="horz" wrap="square" rtlCol="0">
+            <a:spAutoFit/>
+          </a:bodyPr>
+          <a:lstStyle/>
+          <a:p>
+            <a:r>
+              <a:rPr lang="en-US" sz="1600" b="1">
+                <a:solidFill>
+                  <a:srgbClr val="C00000"/>
+                </a:solidFill>
+              </a:rPr>
+              <a:t>The 25,871 adults. They are people, so they are subjects.</a:t>
+            </a:r>
+          </a:p>
+        </p:txBody>
+      </p:sp>
+      <p:sp>
+        <p:nvSpPr>
+          <p:cNvPr id="8" name="TextBox 7">
+            <a:extLst>
+              <a:ext uri="{FF2B5EF4-FFF2-40B4-BE49-F238E27FC236}">
+                <a16:creationId xmlns:a16="http://schemas.microsoft.com/office/drawing/2014/main" id="{CE03E08D-862C-AF03-64BB-BE6B12D52B9E}"/>
+              </a:ext>
+            </a:extLst>
+          </p:cNvPr>
+          <p:cNvSpPr txBox="1"/>
+          <p:nvPr/>
+        </p:nvSpPr>
+        <p:spPr>
+          <a:xfrm>
+            <a:off x="762000" y="3383854"/>
+            <a:ext cx="10668000" cy="345440"/>
+          </a:xfrm>
+          <a:prstGeom prst="rect">
+            <a:avLst/>
+          </a:prstGeom>
+          <a:noFill/>
+        </p:spPr>
+        <p:txBody>
+          <a:bodyPr vert="horz" wrap="square" rtlCol="0">
+            <a:spAutoFit/>
+          </a:bodyPr>
+          <a:lstStyle/>
+          <a:p>
+            <a:pPr marL="304800" indent="-304800"/>
+            <a:r>
+              <a:rPr lang="en-US" sz="1600" b="1">
+                <a:solidFill>
+                  <a:srgbClr val="C00000"/>
+                </a:solidFill>
+              </a:rPr>
+              <a:t>2.</a:t>
+            </a:r>
+            <a:r>
+              <a:rPr lang="en-US" sz="1600">
+                <a:solidFill>
+                  <a:srgbClr val="000000"/>
+                </a:solidFill>
+              </a:rPr>
+              <a:t>  What are the factors, and how many levels does each have?</a:t>
+            </a:r>
+          </a:p>
+        </p:txBody>
+      </p:sp>
+      <p:sp>
+        <p:nvSpPr>
+          <p:cNvPr id="9" name="TextBox 8">
+            <a:extLst>
+              <a:ext uri="{FF2B5EF4-FFF2-40B4-BE49-F238E27FC236}">
+                <a16:creationId xmlns:a16="http://schemas.microsoft.com/office/drawing/2014/main" id="{6193DCC8-196D-E1A6-C6DA-904079F554A1}"/>
+              </a:ext>
+            </a:extLst>
+          </p:cNvPr>
+          <p:cNvSpPr txBox="1"/>
+          <p:nvPr/>
+        </p:nvSpPr>
+        <p:spPr>
+          <a:xfrm>
+            <a:off x="1117600" y="3741994"/>
+            <a:ext cx="10312400" cy="345440"/>
+          </a:xfrm>
+          <a:prstGeom prst="rect">
+            <a:avLst/>
+          </a:prstGeom>
+          <a:noFill/>
+        </p:spPr>
+        <p:txBody>
+          <a:bodyPr vert="horz" wrap="square" rtlCol="0">
+            <a:spAutoFit/>
+          </a:bodyPr>
+          <a:lstStyle/>
+          <a:p>
+            <a:r>
+              <a:rPr lang="en-US" sz="1600" b="1">
+                <a:solidFill>
+                  <a:srgbClr val="C00000"/>
+                </a:solidFill>
+              </a:rPr>
+              <a:t>Vitamin D and omega-3 - 2 levels each (the supplement or a placebo).</a:t>
+            </a:r>
+          </a:p>
+        </p:txBody>
+      </p:sp>
+      <p:sp>
+        <p:nvSpPr>
+          <p:cNvPr id="10" name="TextBox 9">
+            <a:extLst>
+              <a:ext uri="{FF2B5EF4-FFF2-40B4-BE49-F238E27FC236}">
+                <a16:creationId xmlns:a16="http://schemas.microsoft.com/office/drawing/2014/main" id="{30E25D4A-4773-05CB-3292-48B30A495FCF}"/>
+              </a:ext>
+            </a:extLst>
+          </p:cNvPr>
+          <p:cNvSpPr txBox="1"/>
+          <p:nvPr/>
+        </p:nvSpPr>
+        <p:spPr>
+          <a:xfrm>
+            <a:off x="762000" y="4189034"/>
+            <a:ext cx="10668000" cy="345440"/>
+          </a:xfrm>
+          <a:prstGeom prst="rect">
+            <a:avLst/>
+          </a:prstGeom>
+          <a:noFill/>
+        </p:spPr>
+        <p:txBody>
+          <a:bodyPr vert="horz" wrap="square" rtlCol="0">
+            <a:spAutoFit/>
+          </a:bodyPr>
+          <a:lstStyle/>
+          <a:p>
+            <a:pPr marL="304800" indent="-304800"/>
+            <a:r>
+              <a:rPr lang="en-US" sz="1600" b="1">
+                <a:solidFill>
+                  <a:srgbClr val="C00000"/>
+                </a:solidFill>
+              </a:rPr>
+              <a:t>3.</a:t>
+            </a:r>
+            <a:r>
+              <a:rPr lang="en-US" sz="1600">
+                <a:solidFill>
+                  <a:srgbClr val="000000"/>
+                </a:solidFill>
+              </a:rPr>
+              <a:t>  How many treatments are there?</a:t>
+            </a:r>
+          </a:p>
+        </p:txBody>
+      </p:sp>
+      <p:sp>
+        <p:nvSpPr>
+          <p:cNvPr id="11" name="TextBox 10">
+            <a:extLst>
+              <a:ext uri="{FF2B5EF4-FFF2-40B4-BE49-F238E27FC236}">
+                <a16:creationId xmlns:a16="http://schemas.microsoft.com/office/drawing/2014/main" id="{03F8927A-06B7-68FB-674D-7CEEB23B0E4F}"/>
+              </a:ext>
+            </a:extLst>
+          </p:cNvPr>
+          <p:cNvSpPr txBox="1"/>
+          <p:nvPr/>
+        </p:nvSpPr>
+        <p:spPr>
+          <a:xfrm>
+            <a:off x="1117600" y="4547174"/>
+            <a:ext cx="10312400" cy="345440"/>
+          </a:xfrm>
+          <a:prstGeom prst="rect">
+            <a:avLst/>
+          </a:prstGeom>
+          <a:noFill/>
+        </p:spPr>
+        <p:txBody>
+          <a:bodyPr vert="horz" wrap="square" rtlCol="0">
+            <a:spAutoFit/>
+          </a:bodyPr>
+          <a:lstStyle/>
+          <a:p>
+            <a:r>
+              <a:rPr lang="en-US" sz="1600" b="1">
+                <a:solidFill>
+                  <a:srgbClr val="C00000"/>
+                </a:solidFill>
+              </a:rPr>
+              <a:t>2 x 2 = 4: vitamin D + omega-3, vitamin D + placebo, placebo + omega-3, placebo + placebo.</a:t>
+            </a:r>
+          </a:p>
+        </p:txBody>
+      </p:sp>
+      <p:sp>
+        <p:nvSpPr>
+          <p:cNvPr id="12" name="TextBox 11">
+            <a:extLst>
+              <a:ext uri="{FF2B5EF4-FFF2-40B4-BE49-F238E27FC236}">
+                <a16:creationId xmlns:a16="http://schemas.microsoft.com/office/drawing/2014/main" id="{43AC598D-D11F-462C-0B3E-1312AD123B2D}"/>
+              </a:ext>
+            </a:extLst>
+          </p:cNvPr>
+          <p:cNvSpPr txBox="1"/>
+          <p:nvPr/>
+        </p:nvSpPr>
+        <p:spPr>
+          <a:xfrm>
+            <a:off x="762000" y="4994214"/>
+            <a:ext cx="10668000" cy="345440"/>
+          </a:xfrm>
+          <a:prstGeom prst="rect">
+            <a:avLst/>
+          </a:prstGeom>
+          <a:noFill/>
+        </p:spPr>
+        <p:txBody>
+          <a:bodyPr vert="horz" wrap="square" rtlCol="0">
+            <a:spAutoFit/>
+          </a:bodyPr>
+          <a:lstStyle/>
+          <a:p>
+            <a:pPr marL="304800" indent="-304800"/>
+            <a:r>
+              <a:rPr lang="en-US" sz="1600" b="1">
+                <a:solidFill>
+                  <a:srgbClr val="C00000"/>
+                </a:solidFill>
+              </a:rPr>
+              <a:t>4.</a:t>
+            </a:r>
+            <a:r>
+              <a:rPr lang="en-US" sz="1600">
+                <a:solidFill>
+                  <a:srgbClr val="000000"/>
+                </a:solidFill>
+              </a:rPr>
+              <a:t>  What kind of design is this, and is it blinded?</a:t>
+            </a:r>
+          </a:p>
+        </p:txBody>
+      </p:sp>
+      <p:sp>
+        <p:nvSpPr>
+          <p:cNvPr id="13" name="TextBox 12">
+            <a:extLst>
+              <a:ext uri="{FF2B5EF4-FFF2-40B4-BE49-F238E27FC236}">
+                <a16:creationId xmlns:a16="http://schemas.microsoft.com/office/drawing/2014/main" id="{DE32CBC3-2896-472B-A54A-0EF0CDD6FDC6}"/>
+              </a:ext>
+            </a:extLst>
+          </p:cNvPr>
+          <p:cNvSpPr txBox="1"/>
+          <p:nvPr/>
+        </p:nvSpPr>
+        <p:spPr>
+          <a:xfrm>
+            <a:off x="1117600" y="5352354"/>
+            <a:ext cx="10312400" cy="584775"/>
+          </a:xfrm>
+          <a:prstGeom prst="rect">
+            <a:avLst/>
+          </a:prstGeom>
+          <a:noFill/>
+        </p:spPr>
+        <p:txBody>
+          <a:bodyPr vert="horz" wrap="square" rtlCol="0">
+            <a:spAutoFit/>
+          </a:bodyPr>
+          <a:lstStyle/>
+          <a:p>
+            <a:r>
+              <a:rPr lang="en-US" sz="1600" b="1">
+                <a:solidFill>
+                  <a:srgbClr val="C00000"/>
+                </a:solidFill>
+              </a:rPr>
+              <a:t>A completely randomized 2 x 2 factorial design, double blind and placebo controlled. Neither supplement lowered the rate of invasive cancer or of major cardiovascular events.</a:t>
+            </a:r>
+          </a:p>
+        </p:txBody>
+      </p:sp>
+      <p:sp>
+        <p:nvSpPr>
+          <p:cNvPr id="14" name="TextBox 13">
+            <a:extLst>
+              <a:ext uri="{FF2B5EF4-FFF2-40B4-BE49-F238E27FC236}">
+                <a16:creationId xmlns:a16="http://schemas.microsoft.com/office/drawing/2014/main" id="{EA15CB9B-7BE5-0C0D-696A-48328ABA1439}"/>
+              </a:ext>
+            </a:extLst>
+          </p:cNvPr>
+          <p:cNvSpPr txBox="1"/>
+          <p:nvPr/>
+        </p:nvSpPr>
+        <p:spPr>
+          <a:xfrm>
+            <a:off x="762000" y="6045200"/>
+            <a:ext cx="10668000" cy="345440"/>
+          </a:xfrm>
+          <a:prstGeom prst="rect">
+            <a:avLst/>
+          </a:prstGeom>
+          <a:noFill/>
+        </p:spPr>
+        <p:txBody>
+          <a:bodyPr vert="horz" wrap="square" rtlCol="0">
+            <a:noAutofit/>
+          </a:bodyPr>
+          <a:lstStyle/>
+          <a:p>
+            <a:pPr algn="r"/>
+            <a:r>
+              <a:rPr lang="en-US" sz="1600" i="1">
+                <a:solidFill>
+                  <a:srgbClr val="595959"/>
+                </a:solidFill>
+              </a:rPr>
+              <a:t>Source: Manson et al. (2019), New England Journal of Medicine</a:t>
+            </a:r>
+          </a:p>
+        </p:txBody>
+      </p:sp>
+      <p:sp>
+        <p:nvSpPr>
+          <p:cNvPr id="3" name="Title rule">
+            <a:extLst>
+              <a:ext uri="{FF2B5EF4-FFF2-40B4-BE49-F238E27FC236}">
+                <a16:creationId xmlns:a16="http://schemas.microsoft.com/office/drawing/2014/main" id="{33842B88-3FD8-7BBF-86D4-D79A31D0D324}"/>
+              </a:ext>
+            </a:extLst>
+          </p:cNvPr>
+          <p:cNvSpPr/>
+          <p:nvPr/>
+        </p:nvSpPr>
+        <p:spPr>
+          <a:xfrm>
+            <a:off x="838200" y="1600200"/>
+            <a:ext cx="10515600" cy="38100"/>
+          </a:xfrm>
+          <a:prstGeom prst="rect">
+            <a:avLst/>
+          </a:prstGeom>
+          <a:solidFill>
+            <a:srgbClr val="4472C4"/>
+          </a:solidFill>
+          <a:ln w="12700" cap="flat" cmpd="sng" algn="ctr">
+            <a:noFill/>
+            <a:prstDash val="solid"/>
+            <a:miter lim="800000"/>
+          </a:ln>
+          <a:effectLst/>
+          <a:extLst>
+            <a:ext uri="{91240B29-F687-4F45-9708-019B960494DF}">
+              <a14:hiddenLine xmlns:a14="http://schemas.microsoft.com/office/drawing/2010/main" w="12700" cap="flat" cmpd="sng" algn="ctr">
+                <a:solidFill>
+                  <a:schemeClr val="accent1">
+                    <a:shade val="15000"/>
+                  </a:schemeClr>
+                </a:solidFill>
+                <a:prstDash val="solid"/>
+                <a:miter lim="800000"/>
+              </a14:hiddenLine>
+            </a:ext>
+          </a:extLst>
+        </p:spPr>
+        <p:style>
+          <a:lnRef idx="2">
+            <a:schemeClr val="accent1">
+              <a:shade val="15000"/>
+            </a:schemeClr>
+          </a:lnRef>
+          <a:fillRef idx="1">
+            <a:schemeClr val="accent1"/>
+          </a:fillRef>
+          <a:effectRef idx="0">
+            <a:schemeClr val="accent1"/>
+          </a:effectRef>
+          <a:fontRef idx="minor">
+            <a:schemeClr val="lt1"/>
+          </a:fontRef>
+        </p:style>
+        <p:txBody>
+          <a:bodyPr rtlCol="0" anchor="ctr"/>
+          <a:lstStyle/>
+          <a:p>
+            <a:pPr algn="ctr"/>
+            <a:endParaRPr lang="en-US"/>
+          </a:p>
+        </p:txBody>
+      </p:sp>
+    </p:spTree>
+    <p:extLst>
+      <p:ext uri="{BB962C8B-B14F-4D97-AF65-F5344CB8AC3E}">
+        <p14:creationId xmlns:p14="http://schemas.microsoft.com/office/powerpoint/2010/main" val="1961640933"/>
+      </p:ext>
+    </p:extLst>
+  </p:cSld>
+  <p:clrMapOvr>
+    <a:masterClrMapping/>
+  </p:clrMapOvr>
+  <p:timing>
+    <p:tnLst>
+      <p:par>
+        <p:cTn id="1" dur="indefinite" restart="never" nodeType="tmRoot">
+          <p:childTnLst>
+            <p:seq concurrent="1" nextAc="seek">
+              <p:cTn id="2" dur="indefinite" nodeType="mainSeq">
+                <p:childTnLst>
+                  <p:par>
+                    <p:cTn id="3" fill="hold">
+                      <p:stCondLst>
+                        <p:cond delay="indefinite"/>
+                      </p:stCondLst>
+                      <p:childTnLst>
+                        <p:par>
+                          <p:cTn id="4" fill="hold">
+                            <p:stCondLst>
+                              <p:cond delay="0"/>
+                            </p:stCondLst>
+                            <p:childTnLst>
+                              <p:par>
+                                <p:cTn id="5" presetID="34" presetClass="entr" presetSubtype="0" fill="hold" grpId="0" nodeType="clickEffect">
+                                  <p:stCondLst>
+                                    <p:cond delay="0"/>
+                                  </p:stCondLst>
+                                  <p:childTnLst>
+                                    <p:set>
+                                      <p:cBhvr>
+                                        <p:cTn id="6" dur="1" fill="hold">
+                                          <p:stCondLst>
+                                            <p:cond delay="0"/>
+                                          </p:stCondLst>
+                                        </p:cTn>
+                                        <p:tgtEl>
+                                          <p:spTgt spid="7"/>
+                                        </p:tgtEl>
+                                        <p:attrNameLst>
+                                          <p:attrName>style.visibility</p:attrName>
+                                        </p:attrNameLst>
+                                      </p:cBhvr>
+                                      <p:to>
+                                        <p:strVal val="visible"/>
+                                      </p:to>
+                                    </p:set>
+                                    <p:anim from="(-#ppt_w/2)" to="(#ppt_x)" calcmode="lin" valueType="num">
+                                      <p:cBhvr>
+                                        <p:cTn id="7" dur="600" fill="hold">
+                                          <p:stCondLst>
+                                            <p:cond delay="0"/>
+                                          </p:stCondLst>
+                                        </p:cTn>
+                                        <p:tgtEl>
+                                          <p:spTgt spid="7"/>
+                                        </p:tgtEl>
+                                        <p:attrNameLst>
+                                          <p:attrName>ppt_x</p:attrName>
+                                        </p:attrNameLst>
+                                      </p:cBhvr>
+                                    </p:anim>
+                                    <p:anim from="0" to="-1.0" calcmode="lin" valueType="num">
+                                      <p:cBhvr>
+                                        <p:cTn id="8" dur="200" decel="50000" autoRev="1" fill="hold">
+                                          <p:stCondLst>
+                                            <p:cond delay="600"/>
+                                          </p:stCondLst>
+                                        </p:cTn>
+                                        <p:tgtEl>
+                                          <p:spTgt spid="7"/>
+                                        </p:tgtEl>
+                                        <p:attrNameLst>
+                                          <p:attrName>xshear</p:attrName>
+                                        </p:attrNameLst>
+                                      </p:cBhvr>
+                                    </p:anim>
+                                    <p:animScale>
+                                      <p:cBhvr>
+                                        <p:cTn id="9" dur="200" decel="100000" autoRev="1" fill="hold">
+                                          <p:stCondLst>
+                                            <p:cond delay="600"/>
+                                          </p:stCondLst>
+                                        </p:cTn>
+                                        <p:tgtEl>
+                                          <p:spTgt spid="7"/>
+                                        </p:tgtEl>
+                                      </p:cBhvr>
+                                      <p:from x="100000" y="100000"/>
+                                      <p:to x="80000" y="100000"/>
+                                    </p:animScale>
+                                    <p:anim by="(#ppt_h/3+#ppt_w*0.1)" calcmode="lin" valueType="num">
+                                      <p:cBhvr additive="sum">
+                                        <p:cTn id="10" dur="200" decel="100000" autoRev="1" fill="hold">
+                                          <p:stCondLst>
+                                            <p:cond delay="600"/>
+                                          </p:stCondLst>
+                                        </p:cTn>
+                                        <p:tgtEl>
+                                          <p:spTgt spid="7"/>
+                                        </p:tgtEl>
+                                        <p:attrNameLst>
+                                          <p:attrName>ppt_x</p:attrName>
+                                        </p:attrNameLst>
+                                      </p:cBhvr>
+                                    </p:anim>
+                                  </p:childTnLst>
+                                </p:cTn>
+                              </p:par>
+                            </p:childTnLst>
+                          </p:cTn>
+                        </p:par>
+                      </p:childTnLst>
+                    </p:cTn>
+                  </p:par>
+                  <p:par>
+                    <p:cTn id="11" fill="hold">
+                      <p:stCondLst>
+                        <p:cond delay="indefinite"/>
+                      </p:stCondLst>
+                      <p:childTnLst>
+                        <p:par>
+                          <p:cTn id="12" fill="hold">
+                            <p:stCondLst>
+                              <p:cond delay="0"/>
+                            </p:stCondLst>
+                            <p:childTnLst>
+                              <p:par>
+                                <p:cTn id="13" presetID="34" presetClass="entr" presetSubtype="0" fill="hold" grpId="0" nodeType="clickEffect">
+                                  <p:stCondLst>
+                                    <p:cond delay="0"/>
+                                  </p:stCondLst>
+                                  <p:childTnLst>
+                                    <p:set>
+                                      <p:cBhvr>
+                                        <p:cTn id="14" dur="1" fill="hold">
+                                          <p:stCondLst>
+                                            <p:cond delay="0"/>
+                                          </p:stCondLst>
+                                        </p:cTn>
+                                        <p:tgtEl>
+                                          <p:spTgt spid="9"/>
+                                        </p:tgtEl>
+                                        <p:attrNameLst>
+                                          <p:attrName>style.visibility</p:attrName>
+                                        </p:attrNameLst>
+                                      </p:cBhvr>
+                                      <p:to>
+                                        <p:strVal val="visible"/>
+                                      </p:to>
+                                    </p:set>
+                                    <p:anim from="(-#ppt_w/2)" to="(#ppt_x)" calcmode="lin" valueType="num">
+                                      <p:cBhvr>
+                                        <p:cTn id="15" dur="600" fill="hold">
+                                          <p:stCondLst>
+                                            <p:cond delay="0"/>
+                                          </p:stCondLst>
+                                        </p:cTn>
+                                        <p:tgtEl>
+                                          <p:spTgt spid="9"/>
+                                        </p:tgtEl>
+                                        <p:attrNameLst>
+                                          <p:attrName>ppt_x</p:attrName>
+                                        </p:attrNameLst>
+                                      </p:cBhvr>
+                                    </p:anim>
+                                    <p:anim from="0" to="-1.0" calcmode="lin" valueType="num">
+                                      <p:cBhvr>
+                                        <p:cTn id="16" dur="200" decel="50000" autoRev="1" fill="hold">
+                                          <p:stCondLst>
+                                            <p:cond delay="600"/>
+                                          </p:stCondLst>
+                                        </p:cTn>
+                                        <p:tgtEl>
+                                          <p:spTgt spid="9"/>
+                                        </p:tgtEl>
+                                        <p:attrNameLst>
+                                          <p:attrName>xshear</p:attrName>
+                                        </p:attrNameLst>
+                                      </p:cBhvr>
+                                    </p:anim>
+                                    <p:animScale>
+                                      <p:cBhvr>
+                                        <p:cTn id="17" dur="200" decel="100000" autoRev="1" fill="hold">
+                                          <p:stCondLst>
+                                            <p:cond delay="600"/>
+                                          </p:stCondLst>
+                                        </p:cTn>
+                                        <p:tgtEl>
+                                          <p:spTgt spid="9"/>
+                                        </p:tgtEl>
+                                      </p:cBhvr>
+                                      <p:from x="100000" y="100000"/>
+                                      <p:to x="80000" y="100000"/>
+                                    </p:animScale>
+                                    <p:anim by="(#ppt_h/3+#ppt_w*0.1)" calcmode="lin" valueType="num">
+                                      <p:cBhvr additive="sum">
+                                        <p:cTn id="18" dur="200" decel="100000" autoRev="1" fill="hold">
+                                          <p:stCondLst>
+                                            <p:cond delay="600"/>
+                                          </p:stCondLst>
+                                        </p:cTn>
+                                        <p:tgtEl>
+                                          <p:spTgt spid="9"/>
+                                        </p:tgtEl>
+                                        <p:attrNameLst>
+                                          <p:attrName>ppt_x</p:attrName>
+                                        </p:attrNameLst>
+                                      </p:cBhvr>
+                                    </p:anim>
+                                  </p:childTnLst>
+                                </p:cTn>
+                              </p:par>
+                            </p:childTnLst>
+                          </p:cTn>
+                        </p:par>
+                      </p:childTnLst>
+                    </p:cTn>
+                  </p:par>
+                  <p:par>
+                    <p:cTn id="19" fill="hold">
+                      <p:stCondLst>
+                        <p:cond delay="indefinite"/>
+                      </p:stCondLst>
+                      <p:childTnLst>
+                        <p:par>
+                          <p:cTn id="20" fill="hold">
+                            <p:stCondLst>
+                              <p:cond delay="0"/>
+                            </p:stCondLst>
+                            <p:childTnLst>
+                              <p:par>
+                                <p:cTn id="21" presetID="34" presetClass="entr" presetSubtype="0" fill="hold" grpId="0" nodeType="clickEffect">
+                                  <p:stCondLst>
+                                    <p:cond delay="0"/>
+                                  </p:stCondLst>
+                                  <p:childTnLst>
+                                    <p:set>
+                                      <p:cBhvr>
+                                        <p:cTn id="22" dur="1" fill="hold">
+                                          <p:stCondLst>
+                                            <p:cond delay="0"/>
+                                          </p:stCondLst>
+                                        </p:cTn>
+                                        <p:tgtEl>
+                                          <p:spTgt spid="11"/>
+                                        </p:tgtEl>
+                                        <p:attrNameLst>
+                                          <p:attrName>style.visibility</p:attrName>
+                                        </p:attrNameLst>
+                                      </p:cBhvr>
+                                      <p:to>
+                                        <p:strVal val="visible"/>
+                                      </p:to>
+                                    </p:set>
+                                    <p:anim from="(-#ppt_w/2)" to="(#ppt_x)" calcmode="lin" valueType="num">
+                                      <p:cBhvr>
+                                        <p:cTn id="23" dur="600" fill="hold">
+                                          <p:stCondLst>
+                                            <p:cond delay="0"/>
+                                          </p:stCondLst>
+                                        </p:cTn>
+                                        <p:tgtEl>
+                                          <p:spTgt spid="11"/>
+                                        </p:tgtEl>
+                                        <p:attrNameLst>
+                                          <p:attrName>ppt_x</p:attrName>
+                                        </p:attrNameLst>
+                                      </p:cBhvr>
+                                    </p:anim>
+                                    <p:anim from="0" to="-1.0" calcmode="lin" valueType="num">
+                                      <p:cBhvr>
+                                        <p:cTn id="24" dur="200" decel="50000" autoRev="1" fill="hold">
+                                          <p:stCondLst>
+                                            <p:cond delay="600"/>
+                                          </p:stCondLst>
+                                        </p:cTn>
+                                        <p:tgtEl>
+                                          <p:spTgt spid="11"/>
+                                        </p:tgtEl>
+                                        <p:attrNameLst>
+                                          <p:attrName>xshear</p:attrName>
+                                        </p:attrNameLst>
+                                      </p:cBhvr>
+                                    </p:anim>
+                                    <p:animScale>
+                                      <p:cBhvr>
+                                        <p:cTn id="25" dur="200" decel="100000" autoRev="1" fill="hold">
+                                          <p:stCondLst>
+                                            <p:cond delay="600"/>
+                                          </p:stCondLst>
+                                        </p:cTn>
+                                        <p:tgtEl>
+                                          <p:spTgt spid="11"/>
+                                        </p:tgtEl>
+                                      </p:cBhvr>
+                                      <p:from x="100000" y="100000"/>
+                                      <p:to x="80000" y="100000"/>
+                                    </p:animScale>
+                                    <p:anim by="(#ppt_h/3+#ppt_w*0.1)" calcmode="lin" valueType="num">
+                                      <p:cBhvr additive="sum">
+                                        <p:cTn id="26" dur="200" decel="100000" autoRev="1" fill="hold">
+                                          <p:stCondLst>
+                                            <p:cond delay="600"/>
+                                          </p:stCondLst>
+                                        </p:cTn>
+                                        <p:tgtEl>
+                                          <p:spTgt spid="11"/>
+                                        </p:tgtEl>
+                                        <p:attrNameLst>
+                                          <p:attrName>ppt_x</p:attrName>
+                                        </p:attrNameLst>
+                                      </p:cBhvr>
+                                    </p:anim>
+                                  </p:childTnLst>
+                                </p:cTn>
+                              </p:par>
+                            </p:childTnLst>
+                          </p:cTn>
+                        </p:par>
+                      </p:childTnLst>
+                    </p:cTn>
+                  </p:par>
+                  <p:par>
+                    <p:cTn id="27" fill="hold">
+                      <p:stCondLst>
+                        <p:cond delay="indefinite"/>
+                      </p:stCondLst>
+                      <p:childTnLst>
+                        <p:par>
+                          <p:cTn id="28" fill="hold">
+                            <p:stCondLst>
+                              <p:cond delay="0"/>
+                            </p:stCondLst>
+                            <p:childTnLst>
+                              <p:par>
+                                <p:cTn id="29" presetID="34" presetClass="entr" presetSubtype="0" fill="hold" grpId="0" nodeType="clickEffect">
+                                  <p:stCondLst>
+                                    <p:cond delay="0"/>
+                                  </p:stCondLst>
+                                  <p:childTnLst>
+                                    <p:set>
+                                      <p:cBhvr>
+                                        <p:cTn id="30" dur="1" fill="hold">
+                                          <p:stCondLst>
+                                            <p:cond delay="0"/>
+                                          </p:stCondLst>
+                                        </p:cTn>
+                                        <p:tgtEl>
+                                          <p:spTgt spid="13"/>
+                                        </p:tgtEl>
+                                        <p:attrNameLst>
+                                          <p:attrName>style.visibility</p:attrName>
+                                        </p:attrNameLst>
+                                      </p:cBhvr>
+                                      <p:to>
+                                        <p:strVal val="visible"/>
+                                      </p:to>
+                                    </p:set>
+                                    <p:anim from="(-#ppt_w/2)" to="(#ppt_x)" calcmode="lin" valueType="num">
+                                      <p:cBhvr>
+                                        <p:cTn id="31" dur="600" fill="hold">
+                                          <p:stCondLst>
+                                            <p:cond delay="0"/>
+                                          </p:stCondLst>
+                                        </p:cTn>
+                                        <p:tgtEl>
+                                          <p:spTgt spid="13"/>
+                                        </p:tgtEl>
+                                        <p:attrNameLst>
+                                          <p:attrName>ppt_x</p:attrName>
+                                        </p:attrNameLst>
+                                      </p:cBhvr>
+                                    </p:anim>
+                                    <p:anim from="0" to="-1.0" calcmode="lin" valueType="num">
+                                      <p:cBhvr>
+                                        <p:cTn id="32" dur="200" decel="50000" autoRev="1" fill="hold">
+                                          <p:stCondLst>
+                                            <p:cond delay="600"/>
+                                          </p:stCondLst>
+                                        </p:cTn>
+                                        <p:tgtEl>
+                                          <p:spTgt spid="13"/>
+                                        </p:tgtEl>
+                                        <p:attrNameLst>
+                                          <p:attrName>xshear</p:attrName>
+                                        </p:attrNameLst>
+                                      </p:cBhvr>
+                                    </p:anim>
+                                    <p:animScale>
+                                      <p:cBhvr>
+                                        <p:cTn id="33" dur="200" decel="100000" autoRev="1" fill="hold">
+                                          <p:stCondLst>
+                                            <p:cond delay="600"/>
+                                          </p:stCondLst>
+                                        </p:cTn>
+                                        <p:tgtEl>
+                                          <p:spTgt spid="13"/>
+                                        </p:tgtEl>
+                                      </p:cBhvr>
+                                      <p:from x="100000" y="100000"/>
+                                      <p:to x="80000" y="100000"/>
+                                    </p:animScale>
+                                    <p:anim by="(#ppt_h/3+#ppt_w*0.1)" calcmode="lin" valueType="num">
+                                      <p:cBhvr additive="sum">
+                                        <p:cTn id="34" dur="200" decel="100000" autoRev="1" fill="hold">
+                                          <p:stCondLst>
+                                            <p:cond delay="600"/>
+                                          </p:stCondLst>
+                                        </p:cTn>
+                                        <p:tgtEl>
+                                          <p:spTgt spid="13"/>
+                                        </p:tgtEl>
+                                        <p:attrNameLst>
+                                          <p:attrName>ppt_x</p:attrName>
+                                        </p:attrNameLst>
+                                      </p:cBhvr>
+                                    </p:anim>
+                                  </p:childTnLst>
+                                </p:cTn>
+                              </p:par>
+                            </p:childTnLst>
+                          </p:cTn>
+                        </p:par>
+                      </p:childTnLst>
+                    </p:cTn>
+                  </p:par>
+                </p:childTnLst>
+              </p:cTn>
+              <p:prevCondLst>
+                <p:cond evt="onPrev" delay="0">
+                  <p:tgtEl>
+                    <p:sldTgt/>
+                  </p:tgtEl>
+                </p:cond>
+              </p:prevCondLst>
+              <p:nextCondLst>
+                <p:cond evt="onNext" delay="0">
+                  <p:tgtEl>
+                    <p:sldTgt/>
+                  </p:tgtEl>
+                </p:cond>
+              </p:nextCondLst>
+            </p:seq>
+          </p:childTnLst>
+        </p:cTn>
+      </p:par>
+    </p:tnLst>
+    <p:bldLst>
+      <p:bldP spid="7" grpId="0"/>
+      <p:bldP spid="9" grpId="0"/>
+      <p:bldP spid="11" grpId="0"/>
+      <p:bldP spid="13" grpId="0"/>
+    </p:bldLst>
+  </p:timing>
+</p:sld>
+</file>
+
+<file path=ppt/slides/slide4.xml><?xml version="1.0" encoding="utf-8"?>
+<p:sld xmlns:a="http://schemas.openxmlformats.org/drawingml/2006/main" xmlns:r="http://schemas.openxmlformats.org/officeDocument/2006/relationships" xmlns:p="http://schemas.openxmlformats.org/presentationml/2006/main">
+  <p:cSld>
+    <p:spTree>
+      <p:nvGrpSpPr>
+        <p:cNvPr id="1" name=""/>
+        <p:cNvGrpSpPr/>
+        <p:nvPr/>
+      </p:nvGrpSpPr>
+      <p:grpSpPr>
+        <a:xfrm>
+          <a:off x="0" y="0"/>
+          <a:ext cx="0" cy="0"/>
+          <a:chOff x="0" y="0"/>
+          <a:chExt cx="0" cy="0"/>
+        </a:xfrm>
+      </p:grpSpPr>
+      <p:sp>
+        <p:nvSpPr>
+          <p:cNvPr id="2" name="Title 1">
+            <a:extLst>
+              <a:ext uri="{FF2B5EF4-FFF2-40B4-BE49-F238E27FC236}">
+                <a16:creationId xmlns:a16="http://schemas.microsoft.com/office/drawing/2014/main" id="{C08D30B1-1864-30EF-7EAB-9BEE656C0012}"/>
+              </a:ext>
+            </a:extLst>
+          </p:cNvPr>
+          <p:cNvSpPr>
+            <a:spLocks noGrp="1"/>
+          </p:cNvSpPr>
+          <p:nvPr>
+            <p:ph type="title"/>
+          </p:nvPr>
+        </p:nvSpPr>
+        <p:spPr/>
+        <p:txBody>
+          <a:bodyPr>
+            <a:noAutofit/>
+          </a:bodyPr>
+          <a:lstStyle/>
+          <a:p>
+            <a:r>
+              <a:rPr lang="en-US">
+                <a:solidFill>
+                  <a:srgbClr val="1F3864"/>
+                </a:solidFill>
+              </a:rPr>
+              <a:t>A placebo surgery</a:t>
+            </a:r>
+          </a:p>
+        </p:txBody>
+      </p:sp>
+      <p:sp>
+        <p:nvSpPr>
+          <p:cNvPr id="4" name="Slide Number Placeholder 3">
+            <a:extLst>
+              <a:ext uri="{FF2B5EF4-FFF2-40B4-BE49-F238E27FC236}">
+                <a16:creationId xmlns:a16="http://schemas.microsoft.com/office/drawing/2014/main" id="{3F875068-D051-44AE-498E-1BEBEDE3A7C8}"/>
+              </a:ext>
+            </a:extLst>
+          </p:cNvPr>
+          <p:cNvSpPr>
+            <a:spLocks noGrp="1"/>
+          </p:cNvSpPr>
+          <p:nvPr>
+            <p:ph type="sldNum" sz="quarter" idx="12"/>
+          </p:nvPr>
+        </p:nvSpPr>
+        <p:spPr/>
+        <p:txBody>
+          <a:bodyPr/>
+          <a:lstStyle/>
+          <a:p>
+            <a:fld id="{A80A81DD-F10A-4B1C-963A-0ABBB4865886}" type="slidenum">
+              <a:rPr lang="en-US" sz="1600" smtClean="0"/>
+              <a:t>4</a:t>
             </a:fld>
             <a:endParaRPr lang="en-US" sz="1600"/>
           </a:p>
@@ -11067,7 +12966,7 @@
 </p:sld>
 </file>
 
-<file path=ppt/slides/slide4.xml><?xml version="1.0" encoding="utf-8"?>
+<file path=ppt/slides/slide5.xml><?xml version="1.0" encoding="utf-8"?>
 <p:sld xmlns:a="http://schemas.openxmlformats.org/drawingml/2006/main" xmlns:r="http://schemas.openxmlformats.org/officeDocument/2006/relationships" xmlns:p="http://schemas.openxmlformats.org/presentationml/2006/main">
   <p:cSld>
     <p:spTree>
@@ -11141,7 +13040,7 @@
           <a:p>
             <a:fld id="{A80A81DD-F10A-4B1C-963A-0ABBB4865886}" type="slidenum">
               <a:rPr lang="en-US" sz="1600" smtClean="0"/>
-              <a:t>4</a:t>
+              <a:t>5</a:t>
             </a:fld>
             <a:endParaRPr lang="en-US" sz="1600"/>
           </a:p>
@@ -11518,7 +13417,7 @@
 </p:sld>
 </file>
 
-<file path=ppt/slides/slide5.xml><?xml version="1.0" encoding="utf-8"?>
+<file path=ppt/slides/slide6.xml><?xml version="1.0" encoding="utf-8"?>
 <p:sld xmlns:a="http://schemas.openxmlformats.org/drawingml/2006/main" xmlns:r="http://schemas.openxmlformats.org/officeDocument/2006/relationships" xmlns:p="http://schemas.openxmlformats.org/presentationml/2006/main">
   <p:cSld>
     <p:spTree>
@@ -11592,7 +13491,7 @@
           <a:p>
             <a:fld id="{A80A81DD-F10A-4B1C-963A-0ABBB4865886}" type="slidenum">
               <a:rPr lang="en-US" sz="1600" smtClean="0"/>
-              <a:t>5</a:t>
+              <a:t>6</a:t>
             </a:fld>
             <a:endParaRPr lang="en-US" sz="1600"/>
           </a:p>
@@ -12123,7 +14022,7 @@
 </p:sld>
 </file>
 
-<file path=ppt/slides/slide6.xml><?xml version="1.0" encoding="utf-8"?>
+<file path=ppt/slides/slide7.xml><?xml version="1.0" encoding="utf-8"?>
 <p:sld xmlns:a="http://schemas.openxmlformats.org/drawingml/2006/main" xmlns:r="http://schemas.openxmlformats.org/officeDocument/2006/relationships" xmlns:p="http://schemas.openxmlformats.org/presentationml/2006/main">
   <p:cSld>
     <p:spTree>
@@ -12197,7 +14096,7 @@
           <a:p>
             <a:fld id="{A80A81DD-F10A-4B1C-963A-0ABBB4865886}" type="slidenum">
               <a:rPr lang="en-US" sz="1600" smtClean="0"/>
-              <a:t>6</a:t>
+              <a:t>7</a:t>
             </a:fld>
             <a:endParaRPr lang="en-US" sz="1600"/>
           </a:p>
@@ -12689,7 +14588,7 @@
 </p:sld>
 </file>
 
-<file path=ppt/slides/slide7.xml><?xml version="1.0" encoding="utf-8"?>
+<file path=ppt/slides/slide8.xml><?xml version="1.0" encoding="utf-8"?>
 <p:sld xmlns:a="http://schemas.openxmlformats.org/drawingml/2006/main" xmlns:r="http://schemas.openxmlformats.org/officeDocument/2006/relationships" xmlns:p="http://schemas.openxmlformats.org/presentationml/2006/main">
   <p:cSld>
     <p:spTree>
@@ -12763,7 +14662,7 @@
           <a:p>
             <a:fld id="{A80A81DD-F10A-4B1C-963A-0ABBB4865886}" type="slidenum">
               <a:rPr lang="en-US" sz="1600" smtClean="0"/>
-              <a:t>7</a:t>
+              <a:t>8</a:t>
             </a:fld>
             <a:endParaRPr lang="en-US" sz="1600"/>
           </a:p>
@@ -13261,7 +15160,7 @@
 </p:sld>
 </file>
 
-<file path=ppt/slides/slide8.xml><?xml version="1.0" encoding="utf-8"?>
+<file path=ppt/slides/slide9.xml><?xml version="1.0" encoding="utf-8"?>
 <p:sld xmlns:a="http://schemas.openxmlformats.org/drawingml/2006/main" xmlns:r="http://schemas.openxmlformats.org/officeDocument/2006/relationships" xmlns:p="http://schemas.openxmlformats.org/presentationml/2006/main">
   <p:cSld>
     <p:spTree>
@@ -13335,7 +15234,7 @@
           <a:p>
             <a:fld id="{A80A81DD-F10A-4B1C-963A-0ABBB4865886}" type="slidenum">
               <a:rPr lang="en-US" sz="1600" smtClean="0"/>
-              <a:t>8</a:t>
+              <a:t>9</a:t>
             </a:fld>
             <a:endParaRPr lang="en-US" sz="1600"/>
           </a:p>
@@ -13649,7 +15548,7 @@
     </p:spTree>
     <p:extLst>
       <p:ext uri="{BB962C8B-B14F-4D97-AF65-F5344CB8AC3E}">
-        <p14:creationId xmlns:p14="http://schemas.microsoft.com/office/powerpoint/2010/main" val="476550455"/>
+        <p14:creationId xmlns:p14="http://schemas.microsoft.com/office/powerpoint/2010/main" val="1284691026"/>
       </p:ext>
     </p:extLst>
   </p:cSld>
@@ -14001,859 +15900,6 @@
       <p:bldP spid="6" grpId="0"/>
       <p:bldP spid="8" grpId="0"/>
       <p:bldP spid="10" grpId="0"/>
-    </p:bldLst>
-  </p:timing>
-</p:sld>
-</file>
-
-<file path=ppt/slides/slide9.xml><?xml version="1.0" encoding="utf-8"?>
-<p:sld xmlns:a="http://schemas.openxmlformats.org/drawingml/2006/main" xmlns:r="http://schemas.openxmlformats.org/officeDocument/2006/relationships" xmlns:p="http://schemas.openxmlformats.org/presentationml/2006/main">
-  <p:cSld>
-    <p:spTree>
-      <p:nvGrpSpPr>
-        <p:cNvPr id="1" name=""/>
-        <p:cNvGrpSpPr/>
-        <p:nvPr/>
-      </p:nvGrpSpPr>
-      <p:grpSpPr>
-        <a:xfrm>
-          <a:off x="0" y="0"/>
-          <a:ext cx="0" cy="0"/>
-          <a:chOff x="0" y="0"/>
-          <a:chExt cx="0" cy="0"/>
-        </a:xfrm>
-      </p:grpSpPr>
-      <p:sp>
-        <p:nvSpPr>
-          <p:cNvPr id="2" name="Title 1">
-            <a:extLst>
-              <a:ext uri="{FF2B5EF4-FFF2-40B4-BE49-F238E27FC236}">
-                <a16:creationId xmlns:a16="http://schemas.microsoft.com/office/drawing/2014/main" id="{928FBCDC-48E3-34D7-E16A-ED185680B6C5}"/>
-              </a:ext>
-            </a:extLst>
-          </p:cNvPr>
-          <p:cNvSpPr>
-            <a:spLocks noGrp="1"/>
-          </p:cNvSpPr>
-          <p:nvPr>
-            <p:ph type="title"/>
-          </p:nvPr>
-        </p:nvSpPr>
-        <p:spPr/>
-        <p:txBody>
-          <a:bodyPr>
-            <a:noAutofit/>
-          </a:bodyPr>
-          <a:lstStyle/>
-          <a:p>
-            <a:r>
-              <a:rPr lang="en-US">
-                <a:solidFill>
-                  <a:srgbClr val="1F3864"/>
-                </a:solidFill>
-              </a:rPr>
-              <a:t>Ethics: the Facebook experiment</a:t>
-            </a:r>
-          </a:p>
-        </p:txBody>
-      </p:sp>
-      <p:sp>
-        <p:nvSpPr>
-          <p:cNvPr id="4" name="Slide Number Placeholder 3">
-            <a:extLst>
-              <a:ext uri="{FF2B5EF4-FFF2-40B4-BE49-F238E27FC236}">
-                <a16:creationId xmlns:a16="http://schemas.microsoft.com/office/drawing/2014/main" id="{867D343A-B691-3B93-BC2E-2BC7ADBAE788}"/>
-              </a:ext>
-            </a:extLst>
-          </p:cNvPr>
-          <p:cNvSpPr>
-            <a:spLocks noGrp="1"/>
-          </p:cNvSpPr>
-          <p:nvPr>
-            <p:ph type="sldNum" sz="quarter" idx="12"/>
-          </p:nvPr>
-        </p:nvSpPr>
-        <p:spPr/>
-        <p:txBody>
-          <a:bodyPr/>
-          <a:lstStyle/>
-          <a:p>
-            <a:fld id="{A80A81DD-F10A-4B1C-963A-0ABBB4865886}" type="slidenum">
-              <a:rPr lang="en-US" sz="1600" smtClean="0"/>
-              <a:t>9</a:t>
-            </a:fld>
-            <a:endParaRPr lang="en-US" sz="1600"/>
-          </a:p>
-        </p:txBody>
-      </p:sp>
-      <p:sp>
-        <p:nvSpPr>
-          <p:cNvPr id="5" name="TextBox 4">
-            <a:extLst>
-              <a:ext uri="{FF2B5EF4-FFF2-40B4-BE49-F238E27FC236}">
-                <a16:creationId xmlns:a16="http://schemas.microsoft.com/office/drawing/2014/main" id="{803EF544-7BC1-830E-74B1-64EDAAE169AE}"/>
-              </a:ext>
-            </a:extLst>
-          </p:cNvPr>
-          <p:cNvSpPr txBox="1"/>
-          <p:nvPr/>
-        </p:nvSpPr>
-        <p:spPr>
-          <a:xfrm>
-            <a:off x="762000" y="1841499"/>
-            <a:ext cx="10668000" cy="830997"/>
-          </a:xfrm>
-          <a:prstGeom prst="rect">
-            <a:avLst/>
-          </a:prstGeom>
-          <a:noFill/>
-        </p:spPr>
-        <p:txBody>
-          <a:bodyPr vert="horz" wrap="square" rtlCol="0">
-            <a:spAutoFit/>
-          </a:bodyPr>
-          <a:lstStyle/>
-          <a:p>
-            <a:pPr>
-              <a:spcAft>
-                <a:spcPts val="400"/>
-              </a:spcAft>
-            </a:pPr>
-            <a:r>
-              <a:rPr lang="en-US" sz="1600">
-                <a:solidFill>
-                  <a:srgbClr val="000000"/>
-                </a:solidFill>
-              </a:rPr>
-              <a:t>For one week in January 2012, Facebook ran a completely randomized experiment on 689,003 users: each was assigned at random to a News Feed with fewer positive posts, with fewer negative posts, or left unchanged as a control. The results were published in 2014. The users never knew.</a:t>
-            </a:r>
-          </a:p>
-        </p:txBody>
-      </p:sp>
-      <p:sp>
-        <p:nvSpPr>
-          <p:cNvPr id="6" name="TextBox 5">
-            <a:extLst>
-              <a:ext uri="{FF2B5EF4-FFF2-40B4-BE49-F238E27FC236}">
-                <a16:creationId xmlns:a16="http://schemas.microsoft.com/office/drawing/2014/main" id="{173928F0-6402-96DA-08AE-79702CFCC1E5}"/>
-              </a:ext>
-            </a:extLst>
-          </p:cNvPr>
-          <p:cNvSpPr txBox="1"/>
-          <p:nvPr/>
-        </p:nvSpPr>
-        <p:spPr>
-          <a:xfrm>
-            <a:off x="762000" y="2824896"/>
-            <a:ext cx="10668000" cy="345440"/>
-          </a:xfrm>
-          <a:prstGeom prst="rect">
-            <a:avLst/>
-          </a:prstGeom>
-          <a:noFill/>
-        </p:spPr>
-        <p:txBody>
-          <a:bodyPr vert="horz" wrap="square" rtlCol="0">
-            <a:spAutoFit/>
-          </a:bodyPr>
-          <a:lstStyle/>
-          <a:p>
-            <a:pPr marL="304800" indent="-304800"/>
-            <a:r>
-              <a:rPr lang="en-US" sz="1600" b="1">
-                <a:solidFill>
-                  <a:srgbClr val="C00000"/>
-                </a:solidFill>
-              </a:rPr>
-              <a:t>1.</a:t>
-            </a:r>
-            <a:r>
-              <a:rPr lang="en-US" sz="1600">
-                <a:solidFill>
-                  <a:srgbClr val="000000"/>
-                </a:solidFill>
-              </a:rPr>
-              <a:t>  Facebook said agreeing to its Data Use Policy counted as informed consent. Do you agree?</a:t>
-            </a:r>
-          </a:p>
-        </p:txBody>
-      </p:sp>
-      <p:sp>
-        <p:nvSpPr>
-          <p:cNvPr id="7" name="TextBox 6">
-            <a:extLst>
-              <a:ext uri="{FF2B5EF4-FFF2-40B4-BE49-F238E27FC236}">
-                <a16:creationId xmlns:a16="http://schemas.microsoft.com/office/drawing/2014/main" id="{096B0234-5946-443E-D3EF-6B904164792E}"/>
-              </a:ext>
-            </a:extLst>
-          </p:cNvPr>
-          <p:cNvSpPr txBox="1"/>
-          <p:nvPr/>
-        </p:nvSpPr>
-        <p:spPr>
-          <a:xfrm>
-            <a:off x="1117600" y="3195736"/>
-            <a:ext cx="10312400" cy="589280"/>
-          </a:xfrm>
-          <a:prstGeom prst="rect">
-            <a:avLst/>
-          </a:prstGeom>
-          <a:noFill/>
-        </p:spPr>
-        <p:txBody>
-          <a:bodyPr vert="horz" wrap="square" rtlCol="0">
-            <a:spAutoFit/>
-          </a:bodyPr>
-          <a:lstStyle/>
-          <a:p>
-            <a:r>
-              <a:rPr lang="en-US" sz="1600" b="1">
-                <a:solidFill>
-                  <a:srgbClr val="C00000"/>
-                </a:solidFill>
-              </a:rPr>
-              <a:t>The journal did not: its Expression of Concern said the study may not have met the principles of informed consent and the chance to opt out.</a:t>
-            </a:r>
-          </a:p>
-        </p:txBody>
-      </p:sp>
-      <p:sp>
-        <p:nvSpPr>
-          <p:cNvPr id="8" name="TextBox 7">
-            <a:extLst>
-              <a:ext uri="{FF2B5EF4-FFF2-40B4-BE49-F238E27FC236}">
-                <a16:creationId xmlns:a16="http://schemas.microsoft.com/office/drawing/2014/main" id="{DDBAFEBF-2B58-DFE7-62AD-B002E3656906}"/>
-              </a:ext>
-            </a:extLst>
-          </p:cNvPr>
-          <p:cNvSpPr txBox="1"/>
-          <p:nvPr/>
-        </p:nvSpPr>
-        <p:spPr>
-          <a:xfrm>
-            <a:off x="762000" y="3962816"/>
-            <a:ext cx="10668000" cy="345440"/>
-          </a:xfrm>
-          <a:prstGeom prst="rect">
-            <a:avLst/>
-          </a:prstGeom>
-          <a:noFill/>
-        </p:spPr>
-        <p:txBody>
-          <a:bodyPr vert="horz" wrap="square" rtlCol="0">
-            <a:spAutoFit/>
-          </a:bodyPr>
-          <a:lstStyle/>
-          <a:p>
-            <a:pPr marL="304800" indent="-304800"/>
-            <a:r>
-              <a:rPr lang="en-US" sz="1600" b="1">
-                <a:solidFill>
-                  <a:srgbClr val="C00000"/>
-                </a:solidFill>
-              </a:rPr>
-              <a:t>2.</a:t>
-            </a:r>
-            <a:r>
-              <a:rPr lang="en-US" sz="1600">
-                <a:solidFill>
-                  <a:srgbClr val="000000"/>
-                </a:solidFill>
-              </a:rPr>
-              <a:t>  Why did no ethics board stop it?</a:t>
-            </a:r>
-          </a:p>
-        </p:txBody>
-      </p:sp>
-      <p:sp>
-        <p:nvSpPr>
-          <p:cNvPr id="9" name="TextBox 8">
-            <a:extLst>
-              <a:ext uri="{FF2B5EF4-FFF2-40B4-BE49-F238E27FC236}">
-                <a16:creationId xmlns:a16="http://schemas.microsoft.com/office/drawing/2014/main" id="{37C5EB09-8181-01D4-0AE9-A06C5E9A6703}"/>
-              </a:ext>
-            </a:extLst>
-          </p:cNvPr>
-          <p:cNvSpPr txBox="1"/>
-          <p:nvPr/>
-        </p:nvSpPr>
-        <p:spPr>
-          <a:xfrm>
-            <a:off x="1117600" y="4333656"/>
-            <a:ext cx="10312400" cy="589280"/>
-          </a:xfrm>
-          <a:prstGeom prst="rect">
-            <a:avLst/>
-          </a:prstGeom>
-          <a:noFill/>
-        </p:spPr>
-        <p:txBody>
-          <a:bodyPr vert="horz" wrap="square" rtlCol="0">
-            <a:spAutoFit/>
-          </a:bodyPr>
-          <a:lstStyle/>
-          <a:p>
-            <a:r>
-              <a:rPr lang="en-US" sz="1600" b="1">
-                <a:solidFill>
-                  <a:srgbClr val="C00000"/>
-                </a:solidFill>
-              </a:rPr>
-              <a:t>Facebook, a private company, was not bound by the federal rules. Cornell's board decided its researcher was not directly involved, so it did no review.</a:t>
-            </a:r>
-          </a:p>
-        </p:txBody>
-      </p:sp>
-      <p:sp>
-        <p:nvSpPr>
-          <p:cNvPr id="10" name="TextBox 9">
-            <a:extLst>
-              <a:ext uri="{FF2B5EF4-FFF2-40B4-BE49-F238E27FC236}">
-                <a16:creationId xmlns:a16="http://schemas.microsoft.com/office/drawing/2014/main" id="{2235831A-51A3-E82F-82A5-67061AA1A22E}"/>
-              </a:ext>
-            </a:extLst>
-          </p:cNvPr>
-          <p:cNvSpPr txBox="1"/>
-          <p:nvPr/>
-        </p:nvSpPr>
-        <p:spPr>
-          <a:xfrm>
-            <a:off x="762000" y="5100736"/>
-            <a:ext cx="10668000" cy="345440"/>
-          </a:xfrm>
-          <a:prstGeom prst="rect">
-            <a:avLst/>
-          </a:prstGeom>
-          <a:noFill/>
-        </p:spPr>
-        <p:txBody>
-          <a:bodyPr vert="horz" wrap="square" rtlCol="0">
-            <a:spAutoFit/>
-          </a:bodyPr>
-          <a:lstStyle/>
-          <a:p>
-            <a:pPr marL="304800" indent="-304800"/>
-            <a:r>
-              <a:rPr lang="en-US" sz="1600" b="1">
-                <a:solidFill>
-                  <a:srgbClr val="C00000"/>
-                </a:solidFill>
-              </a:rPr>
-              <a:t>3.</a:t>
-            </a:r>
-            <a:r>
-              <a:rPr lang="en-US" sz="1600">
-                <a:solidFill>
-                  <a:srgbClr val="000000"/>
-                </a:solidFill>
-              </a:rPr>
-              <a:t>  What is the lesson?</a:t>
-            </a:r>
-          </a:p>
-        </p:txBody>
-      </p:sp>
-      <p:sp>
-        <p:nvSpPr>
-          <p:cNvPr id="11" name="TextBox 10">
-            <a:extLst>
-              <a:ext uri="{FF2B5EF4-FFF2-40B4-BE49-F238E27FC236}">
-                <a16:creationId xmlns:a16="http://schemas.microsoft.com/office/drawing/2014/main" id="{7EEE7946-5EA0-8B72-F855-AEB4B6636110}"/>
-              </a:ext>
-            </a:extLst>
-          </p:cNvPr>
-          <p:cNvSpPr txBox="1"/>
-          <p:nvPr/>
-        </p:nvSpPr>
-        <p:spPr>
-          <a:xfrm>
-            <a:off x="1117600" y="5471576"/>
-            <a:ext cx="10312400" cy="345440"/>
-          </a:xfrm>
-          <a:prstGeom prst="rect">
-            <a:avLst/>
-          </a:prstGeom>
-          <a:noFill/>
-        </p:spPr>
-        <p:txBody>
-          <a:bodyPr vert="horz" wrap="square" rtlCol="0">
-            <a:spAutoFit/>
-          </a:bodyPr>
-          <a:lstStyle/>
-          <a:p>
-            <a:r>
-              <a:rPr lang="en-US" sz="1600" b="1">
-                <a:solidFill>
-                  <a:srgbClr val="C00000"/>
-                </a:solidFill>
-              </a:rPr>
-              <a:t>Clicking I agree on a terms-of-service page is not informed consent - even for a well-designed experiment.</a:t>
-            </a:r>
-          </a:p>
-        </p:txBody>
-      </p:sp>
-      <p:sp>
-        <p:nvSpPr>
-          <p:cNvPr id="12" name="TextBox 11">
-            <a:extLst>
-              <a:ext uri="{FF2B5EF4-FFF2-40B4-BE49-F238E27FC236}">
-                <a16:creationId xmlns:a16="http://schemas.microsoft.com/office/drawing/2014/main" id="{3D8E5BD3-1CF7-2352-2707-2D7DBFFA6EBD}"/>
-              </a:ext>
-            </a:extLst>
-          </p:cNvPr>
-          <p:cNvSpPr txBox="1"/>
-          <p:nvPr/>
-        </p:nvSpPr>
-        <p:spPr>
-          <a:xfrm>
-            <a:off x="762000" y="6045200"/>
-            <a:ext cx="10668000" cy="345440"/>
-          </a:xfrm>
-          <a:prstGeom prst="rect">
-            <a:avLst/>
-          </a:prstGeom>
-          <a:noFill/>
-        </p:spPr>
-        <p:txBody>
-          <a:bodyPr vert="horz" wrap="square" rtlCol="0">
-            <a:noAutofit/>
-          </a:bodyPr>
-          <a:lstStyle/>
-          <a:p>
-            <a:pPr algn="r"/>
-            <a:r>
-              <a:rPr lang="en-US" sz="1600" i="1">
-                <a:solidFill>
-                  <a:srgbClr val="595959"/>
-                </a:solidFill>
-              </a:rPr>
-              <a:t>Sources: Kramer, Guillory and Hancock (2014), PNAS; PNAS Editorial Expression of Concern (2014)</a:t>
-            </a:r>
-          </a:p>
-        </p:txBody>
-      </p:sp>
-      <p:sp>
-        <p:nvSpPr>
-          <p:cNvPr id="3" name="Title rule">
-            <a:extLst>
-              <a:ext uri="{FF2B5EF4-FFF2-40B4-BE49-F238E27FC236}">
-                <a16:creationId xmlns:a16="http://schemas.microsoft.com/office/drawing/2014/main" id="{2A19CE9B-6143-6D05-1FF1-AF917901111D}"/>
-              </a:ext>
-            </a:extLst>
-          </p:cNvPr>
-          <p:cNvSpPr/>
-          <p:nvPr/>
-        </p:nvSpPr>
-        <p:spPr>
-          <a:xfrm>
-            <a:off x="838200" y="1600200"/>
-            <a:ext cx="10515600" cy="38100"/>
-          </a:xfrm>
-          <a:prstGeom prst="rect">
-            <a:avLst/>
-          </a:prstGeom>
-          <a:solidFill>
-            <a:srgbClr val="4472C4"/>
-          </a:solidFill>
-          <a:ln w="12700" cap="flat" cmpd="sng" algn="ctr">
-            <a:noFill/>
-            <a:prstDash val="solid"/>
-            <a:miter lim="800000"/>
-          </a:ln>
-          <a:effectLst/>
-          <a:extLst>
-            <a:ext uri="{91240B29-F687-4F45-9708-019B960494DF}">
-              <a14:hiddenLine xmlns:a14="http://schemas.microsoft.com/office/drawing/2010/main" w="12700" cap="flat" cmpd="sng" algn="ctr">
-                <a:solidFill>
-                  <a:schemeClr val="accent1">
-                    <a:shade val="15000"/>
-                  </a:schemeClr>
-                </a:solidFill>
-                <a:prstDash val="solid"/>
-                <a:miter lim="800000"/>
-              </a14:hiddenLine>
-            </a:ext>
-          </a:extLst>
-        </p:spPr>
-        <p:style>
-          <a:lnRef idx="2">
-            <a:schemeClr val="accent1">
-              <a:shade val="15000"/>
-            </a:schemeClr>
-          </a:lnRef>
-          <a:fillRef idx="1">
-            <a:schemeClr val="accent1"/>
-          </a:fillRef>
-          <a:effectRef idx="0">
-            <a:schemeClr val="accent1"/>
-          </a:effectRef>
-          <a:fontRef idx="minor">
-            <a:schemeClr val="lt1"/>
-          </a:fontRef>
-        </p:style>
-        <p:txBody>
-          <a:bodyPr rtlCol="0" anchor="ctr"/>
-          <a:lstStyle/>
-          <a:p>
-            <a:pPr algn="ctr"/>
-            <a:endParaRPr lang="en-US"/>
-          </a:p>
-        </p:txBody>
-      </p:sp>
-    </p:spTree>
-    <p:extLst>
-      <p:ext uri="{BB962C8B-B14F-4D97-AF65-F5344CB8AC3E}">
-        <p14:creationId xmlns:p14="http://schemas.microsoft.com/office/powerpoint/2010/main" val="2555584021"/>
-      </p:ext>
-    </p:extLst>
-  </p:cSld>
-  <p:clrMapOvr>
-    <a:masterClrMapping/>
-  </p:clrMapOvr>
-  <p:timing>
-    <p:tnLst>
-      <p:par>
-        <p:cTn id="1" dur="indefinite" restart="never" nodeType="tmRoot">
-          <p:childTnLst>
-            <p:seq concurrent="1" nextAc="seek">
-              <p:cTn id="2" dur="indefinite" nodeType="mainSeq">
-                <p:childTnLst>
-                  <p:par>
-                    <p:cTn id="3" fill="hold">
-                      <p:stCondLst>
-                        <p:cond delay="indefinite"/>
-                      </p:stCondLst>
-                      <p:childTnLst>
-                        <p:par>
-                          <p:cTn id="4" fill="hold">
-                            <p:stCondLst>
-                              <p:cond delay="0"/>
-                            </p:stCondLst>
-                            <p:childTnLst>
-                              <p:par>
-                                <p:cTn id="5" presetID="34" presetClass="entr" presetSubtype="0" fill="hold" grpId="0" nodeType="clickEffect">
-                                  <p:stCondLst>
-                                    <p:cond delay="0"/>
-                                  </p:stCondLst>
-                                  <p:childTnLst>
-                                    <p:set>
-                                      <p:cBhvr>
-                                        <p:cTn id="6" dur="1" fill="hold">
-                                          <p:stCondLst>
-                                            <p:cond delay="0"/>
-                                          </p:stCondLst>
-                                        </p:cTn>
-                                        <p:tgtEl>
-                                          <p:spTgt spid="7"/>
-                                        </p:tgtEl>
-                                        <p:attrNameLst>
-                                          <p:attrName>style.visibility</p:attrName>
-                                        </p:attrNameLst>
-                                      </p:cBhvr>
-                                      <p:to>
-                                        <p:strVal val="visible"/>
-                                      </p:to>
-                                    </p:set>
-                                    <p:anim from="(-#ppt_w/2)" to="(#ppt_x)" calcmode="lin" valueType="num">
-                                      <p:cBhvr>
-                                        <p:cTn id="7" dur="600" fill="hold">
-                                          <p:stCondLst>
-                                            <p:cond delay="0"/>
-                                          </p:stCondLst>
-                                        </p:cTn>
-                                        <p:tgtEl>
-                                          <p:spTgt spid="7"/>
-                                        </p:tgtEl>
-                                        <p:attrNameLst>
-                                          <p:attrName>ppt_x</p:attrName>
-                                        </p:attrNameLst>
-                                      </p:cBhvr>
-                                    </p:anim>
-                                    <p:anim from="0" to="-1.0" calcmode="lin" valueType="num">
-                                      <p:cBhvr>
-                                        <p:cTn id="8" dur="200" decel="50000" autoRev="1" fill="hold">
-                                          <p:stCondLst>
-                                            <p:cond delay="600"/>
-                                          </p:stCondLst>
-                                        </p:cTn>
-                                        <p:tgtEl>
-                                          <p:spTgt spid="7"/>
-                                        </p:tgtEl>
-                                        <p:attrNameLst>
-                                          <p:attrName>xshear</p:attrName>
-                                        </p:attrNameLst>
-                                      </p:cBhvr>
-                                    </p:anim>
-                                    <p:animScale>
-                                      <p:cBhvr>
-                                        <p:cTn id="9" dur="200" decel="100000" autoRev="1" fill="hold">
-                                          <p:stCondLst>
-                                            <p:cond delay="600"/>
-                                          </p:stCondLst>
-                                        </p:cTn>
-                                        <p:tgtEl>
-                                          <p:spTgt spid="7"/>
-                                        </p:tgtEl>
-                                      </p:cBhvr>
-                                      <p:from x="100000" y="100000"/>
-                                      <p:to x="80000" y="100000"/>
-                                    </p:animScale>
-                                    <p:anim by="(#ppt_h/3+#ppt_w*0.1)" calcmode="lin" valueType="num">
-                                      <p:cBhvr additive="sum">
-                                        <p:cTn id="10" dur="200" decel="100000" autoRev="1" fill="hold">
-                                          <p:stCondLst>
-                                            <p:cond delay="600"/>
-                                          </p:stCondLst>
-                                        </p:cTn>
-                                        <p:tgtEl>
-                                          <p:spTgt spid="7"/>
-                                        </p:tgtEl>
-                                        <p:attrNameLst>
-                                          <p:attrName>ppt_x</p:attrName>
-                                        </p:attrNameLst>
-                                      </p:cBhvr>
-                                    </p:anim>
-                                  </p:childTnLst>
-                                </p:cTn>
-                              </p:par>
-                            </p:childTnLst>
-                          </p:cTn>
-                        </p:par>
-                      </p:childTnLst>
-                    </p:cTn>
-                  </p:par>
-                  <p:par>
-                    <p:cTn id="11" fill="hold">
-                      <p:stCondLst>
-                        <p:cond delay="indefinite"/>
-                      </p:stCondLst>
-                      <p:childTnLst>
-                        <p:par>
-                          <p:cTn id="12" fill="hold">
-                            <p:stCondLst>
-                              <p:cond delay="0"/>
-                            </p:stCondLst>
-                            <p:childTnLst>
-                              <p:par>
-                                <p:cTn id="13" presetID="34" presetClass="entr" presetSubtype="0" fill="hold" grpId="0" nodeType="clickEffect">
-                                  <p:stCondLst>
-                                    <p:cond delay="0"/>
-                                  </p:stCondLst>
-                                  <p:childTnLst>
-                                    <p:set>
-                                      <p:cBhvr>
-                                        <p:cTn id="14" dur="1" fill="hold">
-                                          <p:stCondLst>
-                                            <p:cond delay="0"/>
-                                          </p:stCondLst>
-                                        </p:cTn>
-                                        <p:tgtEl>
-                                          <p:spTgt spid="9"/>
-                                        </p:tgtEl>
-                                        <p:attrNameLst>
-                                          <p:attrName>style.visibility</p:attrName>
-                                        </p:attrNameLst>
-                                      </p:cBhvr>
-                                      <p:to>
-                                        <p:strVal val="visible"/>
-                                      </p:to>
-                                    </p:set>
-                                    <p:anim from="(-#ppt_w/2)" to="(#ppt_x)" calcmode="lin" valueType="num">
-                                      <p:cBhvr>
-                                        <p:cTn id="15" dur="600" fill="hold">
-                                          <p:stCondLst>
-                                            <p:cond delay="0"/>
-                                          </p:stCondLst>
-                                        </p:cTn>
-                                        <p:tgtEl>
-                                          <p:spTgt spid="9"/>
-                                        </p:tgtEl>
-                                        <p:attrNameLst>
-                                          <p:attrName>ppt_x</p:attrName>
-                                        </p:attrNameLst>
-                                      </p:cBhvr>
-                                    </p:anim>
-                                    <p:anim from="0" to="-1.0" calcmode="lin" valueType="num">
-                                      <p:cBhvr>
-                                        <p:cTn id="16" dur="200" decel="50000" autoRev="1" fill="hold">
-                                          <p:stCondLst>
-                                            <p:cond delay="600"/>
-                                          </p:stCondLst>
-                                        </p:cTn>
-                                        <p:tgtEl>
-                                          <p:spTgt spid="9"/>
-                                        </p:tgtEl>
-                                        <p:attrNameLst>
-                                          <p:attrName>xshear</p:attrName>
-                                        </p:attrNameLst>
-                                      </p:cBhvr>
-                                    </p:anim>
-                                    <p:animScale>
-                                      <p:cBhvr>
-                                        <p:cTn id="17" dur="200" decel="100000" autoRev="1" fill="hold">
-                                          <p:stCondLst>
-                                            <p:cond delay="600"/>
-                                          </p:stCondLst>
-                                        </p:cTn>
-                                        <p:tgtEl>
-                                          <p:spTgt spid="9"/>
-                                        </p:tgtEl>
-                                      </p:cBhvr>
-                                      <p:from x="100000" y="100000"/>
-                                      <p:to x="80000" y="100000"/>
-                                    </p:animScale>
-                                    <p:anim by="(#ppt_h/3+#ppt_w*0.1)" calcmode="lin" valueType="num">
-                                      <p:cBhvr additive="sum">
-                                        <p:cTn id="18" dur="200" decel="100000" autoRev="1" fill="hold">
-                                          <p:stCondLst>
-                                            <p:cond delay="600"/>
-                                          </p:stCondLst>
-                                        </p:cTn>
-                                        <p:tgtEl>
-                                          <p:spTgt spid="9"/>
-                                        </p:tgtEl>
-                                        <p:attrNameLst>
-                                          <p:attrName>ppt_x</p:attrName>
-                                        </p:attrNameLst>
-                                      </p:cBhvr>
-                                    </p:anim>
-                                  </p:childTnLst>
-                                </p:cTn>
-                              </p:par>
-                            </p:childTnLst>
-                          </p:cTn>
-                        </p:par>
-                      </p:childTnLst>
-                    </p:cTn>
-                  </p:par>
-                  <p:par>
-                    <p:cTn id="19" fill="hold">
-                      <p:stCondLst>
-                        <p:cond delay="indefinite"/>
-                      </p:stCondLst>
-                      <p:childTnLst>
-                        <p:par>
-                          <p:cTn id="20" fill="hold">
-                            <p:stCondLst>
-                              <p:cond delay="0"/>
-                            </p:stCondLst>
-                            <p:childTnLst>
-                              <p:par>
-                                <p:cTn id="21" presetID="34" presetClass="entr" presetSubtype="0" fill="hold" grpId="0" nodeType="clickEffect">
-                                  <p:stCondLst>
-                                    <p:cond delay="0"/>
-                                  </p:stCondLst>
-                                  <p:childTnLst>
-                                    <p:set>
-                                      <p:cBhvr>
-                                        <p:cTn id="22" dur="1" fill="hold">
-                                          <p:stCondLst>
-                                            <p:cond delay="0"/>
-                                          </p:stCondLst>
-                                        </p:cTn>
-                                        <p:tgtEl>
-                                          <p:spTgt spid="11"/>
-                                        </p:tgtEl>
-                                        <p:attrNameLst>
-                                          <p:attrName>style.visibility</p:attrName>
-                                        </p:attrNameLst>
-                                      </p:cBhvr>
-                                      <p:to>
-                                        <p:strVal val="visible"/>
-                                      </p:to>
-                                    </p:set>
-                                    <p:anim from="(-#ppt_w/2)" to="(#ppt_x)" calcmode="lin" valueType="num">
-                                      <p:cBhvr>
-                                        <p:cTn id="23" dur="600" fill="hold">
-                                          <p:stCondLst>
-                                            <p:cond delay="0"/>
-                                          </p:stCondLst>
-                                        </p:cTn>
-                                        <p:tgtEl>
-                                          <p:spTgt spid="11"/>
-                                        </p:tgtEl>
-                                        <p:attrNameLst>
-                                          <p:attrName>ppt_x</p:attrName>
-                                        </p:attrNameLst>
-                                      </p:cBhvr>
-                                    </p:anim>
-                                    <p:anim from="0" to="-1.0" calcmode="lin" valueType="num">
-                                      <p:cBhvr>
-                                        <p:cTn id="24" dur="200" decel="50000" autoRev="1" fill="hold">
-                                          <p:stCondLst>
-                                            <p:cond delay="600"/>
-                                          </p:stCondLst>
-                                        </p:cTn>
-                                        <p:tgtEl>
-                                          <p:spTgt spid="11"/>
-                                        </p:tgtEl>
-                                        <p:attrNameLst>
-                                          <p:attrName>xshear</p:attrName>
-                                        </p:attrNameLst>
-                                      </p:cBhvr>
-                                    </p:anim>
-                                    <p:animScale>
-                                      <p:cBhvr>
-                                        <p:cTn id="25" dur="200" decel="100000" autoRev="1" fill="hold">
-                                          <p:stCondLst>
-                                            <p:cond delay="600"/>
-                                          </p:stCondLst>
-                                        </p:cTn>
-                                        <p:tgtEl>
-                                          <p:spTgt spid="11"/>
-                                        </p:tgtEl>
-                                      </p:cBhvr>
-                                      <p:from x="100000" y="100000"/>
-                                      <p:to x="80000" y="100000"/>
-                                    </p:animScale>
-                                    <p:anim by="(#ppt_h/3+#ppt_w*0.1)" calcmode="lin" valueType="num">
-                                      <p:cBhvr additive="sum">
-                                        <p:cTn id="26" dur="200" decel="100000" autoRev="1" fill="hold">
-                                          <p:stCondLst>
-                                            <p:cond delay="600"/>
-                                          </p:stCondLst>
-                                        </p:cTn>
-                                        <p:tgtEl>
-                                          <p:spTgt spid="11"/>
-                                        </p:tgtEl>
-                                        <p:attrNameLst>
-                                          <p:attrName>ppt_x</p:attrName>
-                                        </p:attrNameLst>
-                                      </p:cBhvr>
-                                    </p:anim>
-                                  </p:childTnLst>
-                                </p:cTn>
-                              </p:par>
-                            </p:childTnLst>
-                          </p:cTn>
-                        </p:par>
-                      </p:childTnLst>
-                    </p:cTn>
-                  </p:par>
-                </p:childTnLst>
-              </p:cTn>
-              <p:prevCondLst>
-                <p:cond evt="onPrev" delay="0">
-                  <p:tgtEl>
-                    <p:sldTgt/>
-                  </p:tgtEl>
-                </p:cond>
-              </p:prevCondLst>
-              <p:nextCondLst>
-                <p:cond evt="onNext" delay="0">
-                  <p:tgtEl>
-                    <p:sldTgt/>
-                  </p:tgtEl>
-                </p:cond>
-              </p:nextCondLst>
-            </p:seq>
-          </p:childTnLst>
-        </p:cTn>
-      </p:par>
-    </p:tnLst>
-    <p:bldLst>
-      <p:bldP spid="7" grpId="0"/>
-      <p:bldP spid="9" grpId="0"/>
-      <p:bldP spid="11" grpId="0"/>
     </p:bldLst>
   </p:timing>
 </p:sld>

</xml_diff>